<commit_message>
removed dashed lines from use cases
</commit_message>
<xml_diff>
--- a/docs/Mini_Jira_UseCases_EN.pptx
+++ b/docs/Mini_Jira_UseCases_EN.pptx
@@ -137,7 +137,7 @@
       </p:grpSpPr>
       <p:sp>
         <p:nvSpPr>
-          <p:cNvPr id="261633980" name="Header Placeholder 1"/>
+          <p:cNvPr id="534069531" name="Header Placeholder 1"/>
           <p:cNvSpPr>
             <a:spLocks noGrp="1"/>
           </p:cNvSpPr>
@@ -171,7 +171,7 @@
       </p:sp>
       <p:sp>
         <p:nvSpPr>
-          <p:cNvPr id="393565514" name="Date Placeholder 2"/>
+          <p:cNvPr id="288682482" name="Date Placeholder 2"/>
           <p:cNvSpPr>
             <a:spLocks noGrp="1"/>
           </p:cNvSpPr>
@@ -209,7 +209,7 @@
       </p:sp>
       <p:sp>
         <p:nvSpPr>
-          <p:cNvPr id="421294272" name="Slide Image Placeholder 3"/>
+          <p:cNvPr id="1746352682" name="Slide Image Placeholder 3"/>
           <p:cNvSpPr>
             <a:spLocks noChangeAspect="1" noGrp="1" noRot="1"/>
           </p:cNvSpPr>
@@ -245,7 +245,7 @@
       </p:sp>
       <p:sp>
         <p:nvSpPr>
-          <p:cNvPr id="1971835983" name="Notes Placeholder 4"/>
+          <p:cNvPr id="252799017" name="Notes Placeholder 4"/>
           <p:cNvSpPr>
             <a:spLocks noGrp="1"/>
           </p:cNvSpPr>
@@ -319,7 +319,7 @@
       </p:sp>
       <p:sp>
         <p:nvSpPr>
-          <p:cNvPr id="475096305" name="Footer Placeholder 5"/>
+          <p:cNvPr id="556103589" name="Footer Placeholder 5"/>
           <p:cNvSpPr>
             <a:spLocks noGrp="1"/>
           </p:cNvSpPr>
@@ -353,7 +353,7 @@
       </p:sp>
       <p:sp>
         <p:nvSpPr>
-          <p:cNvPr id="2104821450" name="Slide Number Placeholder 6"/>
+          <p:cNvPr id="174316058" name="Slide Number Placeholder 6"/>
           <p:cNvSpPr>
             <a:spLocks noGrp="1"/>
           </p:cNvSpPr>
@@ -506,7 +506,7 @@
       </p:grpSpPr>
       <p:sp>
         <p:nvSpPr>
-          <p:cNvPr id="1678641634" name="Slide Image Placeholder 1"/>
+          <p:cNvPr id="457121903" name="Slide Image Placeholder 1"/>
           <p:cNvSpPr>
             <a:spLocks noChangeAspect="1" noGrp="1" noRot="1"/>
           </p:cNvSpPr>
@@ -518,7 +518,7 @@
       </p:sp>
       <p:sp>
         <p:nvSpPr>
-          <p:cNvPr id="1608845164" name="Notes Placeholder 2"/>
+          <p:cNvPr id="480344064" name="Notes Placeholder 2"/>
           <p:cNvSpPr>
             <a:spLocks noGrp="1"/>
           </p:cNvSpPr>
@@ -540,7 +540,7 @@
       </p:sp>
       <p:sp>
         <p:nvSpPr>
-          <p:cNvPr id="49039944" name="Slide Number Placeholder 3"/>
+          <p:cNvPr id="819645680" name="Slide Number Placeholder 3"/>
           <p:cNvSpPr>
             <a:spLocks noGrp="1"/>
           </p:cNvSpPr>
@@ -591,7 +591,7 @@
       </p:grpSpPr>
       <p:sp>
         <p:nvSpPr>
-          <p:cNvPr id="170189356" name="Slide Image Placeholder 1"/>
+          <p:cNvPr id="1974130993" name="Slide Image Placeholder 1"/>
           <p:cNvSpPr>
             <a:spLocks noChangeAspect="1" noGrp="1" noRot="1"/>
           </p:cNvSpPr>
@@ -603,7 +603,7 @@
       </p:sp>
       <p:sp>
         <p:nvSpPr>
-          <p:cNvPr id="124485041" name="Notes Placeholder 2"/>
+          <p:cNvPr id="332821311" name="Notes Placeholder 2"/>
           <p:cNvSpPr>
             <a:spLocks noGrp="1"/>
           </p:cNvSpPr>
@@ -625,7 +625,7 @@
       </p:sp>
       <p:sp>
         <p:nvSpPr>
-          <p:cNvPr id="1710733592" name="Slide Number Placeholder 3"/>
+          <p:cNvPr id="1792035880" name="Slide Number Placeholder 3"/>
           <p:cNvSpPr>
             <a:spLocks noGrp="1"/>
           </p:cNvSpPr>
@@ -676,7 +676,7 @@
       </p:grpSpPr>
       <p:sp>
         <p:nvSpPr>
-          <p:cNvPr id="913914546" name="Slide Image Placeholder 1"/>
+          <p:cNvPr id="75371824" name="Slide Image Placeholder 1"/>
           <p:cNvSpPr>
             <a:spLocks noChangeAspect="1" noGrp="1" noRot="1"/>
           </p:cNvSpPr>
@@ -688,7 +688,7 @@
       </p:sp>
       <p:sp>
         <p:nvSpPr>
-          <p:cNvPr id="150553972" name="Notes Placeholder 2"/>
+          <p:cNvPr id="715414754" name="Notes Placeholder 2"/>
           <p:cNvSpPr>
             <a:spLocks noGrp="1"/>
           </p:cNvSpPr>
@@ -710,7 +710,7 @@
       </p:sp>
       <p:sp>
         <p:nvSpPr>
-          <p:cNvPr id="986240644" name="Slide Number Placeholder 3"/>
+          <p:cNvPr id="329305655" name="Slide Number Placeholder 3"/>
           <p:cNvSpPr>
             <a:spLocks noGrp="1"/>
           </p:cNvSpPr>
@@ -761,7 +761,7 @@
       </p:grpSpPr>
       <p:sp>
         <p:nvSpPr>
-          <p:cNvPr id="823901342" name="Slide Image Placeholder 1"/>
+          <p:cNvPr id="2066492795" name="Slide Image Placeholder 1"/>
           <p:cNvSpPr>
             <a:spLocks noChangeAspect="1" noGrp="1" noRot="1"/>
           </p:cNvSpPr>
@@ -773,7 +773,7 @@
       </p:sp>
       <p:sp>
         <p:nvSpPr>
-          <p:cNvPr id="254303073" name="Notes Placeholder 2"/>
+          <p:cNvPr id="1798382924" name="Notes Placeholder 2"/>
           <p:cNvSpPr>
             <a:spLocks noGrp="1"/>
           </p:cNvSpPr>
@@ -795,7 +795,7 @@
       </p:sp>
       <p:sp>
         <p:nvSpPr>
-          <p:cNvPr id="1533954933" name="Slide Number Placeholder 3"/>
+          <p:cNvPr id="2118202157" name="Slide Number Placeholder 3"/>
           <p:cNvSpPr>
             <a:spLocks noGrp="1"/>
           </p:cNvSpPr>
@@ -846,7 +846,7 @@
       </p:grpSpPr>
       <p:sp>
         <p:nvSpPr>
-          <p:cNvPr id="1382127910" name="Slide Image Placeholder 1"/>
+          <p:cNvPr id="1824158267" name="Slide Image Placeholder 1"/>
           <p:cNvSpPr>
             <a:spLocks noChangeAspect="1" noGrp="1" noRot="1"/>
           </p:cNvSpPr>
@@ -858,7 +858,7 @@
       </p:sp>
       <p:sp>
         <p:nvSpPr>
-          <p:cNvPr id="378618496" name="Notes Placeholder 2"/>
+          <p:cNvPr id="306170270" name="Notes Placeholder 2"/>
           <p:cNvSpPr>
             <a:spLocks noGrp="1"/>
           </p:cNvSpPr>
@@ -880,7 +880,7 @@
       </p:sp>
       <p:sp>
         <p:nvSpPr>
-          <p:cNvPr id="1720256454" name="Slide Number Placeholder 3"/>
+          <p:cNvPr id="1546738350" name="Slide Number Placeholder 3"/>
           <p:cNvSpPr>
             <a:spLocks noGrp="1"/>
           </p:cNvSpPr>
@@ -931,7 +931,7 @@
       </p:grpSpPr>
       <p:sp>
         <p:nvSpPr>
-          <p:cNvPr id="471144540" name="Slide Image Placeholder 1"/>
+          <p:cNvPr id="1106818640" name="Slide Image Placeholder 1"/>
           <p:cNvSpPr>
             <a:spLocks noChangeAspect="1" noGrp="1" noRot="1"/>
           </p:cNvSpPr>
@@ -943,7 +943,7 @@
       </p:sp>
       <p:sp>
         <p:nvSpPr>
-          <p:cNvPr id="1774637530" name="Notes Placeholder 2"/>
+          <p:cNvPr id="827621893" name="Notes Placeholder 2"/>
           <p:cNvSpPr>
             <a:spLocks noGrp="1"/>
           </p:cNvSpPr>
@@ -965,7 +965,7 @@
       </p:sp>
       <p:sp>
         <p:nvSpPr>
-          <p:cNvPr id="450048312" name="Slide Number Placeholder 3"/>
+          <p:cNvPr id="1566347764" name="Slide Number Placeholder 3"/>
           <p:cNvSpPr>
             <a:spLocks noGrp="1"/>
           </p:cNvSpPr>
@@ -1016,7 +1016,7 @@
       </p:grpSpPr>
       <p:sp>
         <p:nvSpPr>
-          <p:cNvPr id="956223476" name="Slide Image Placeholder 1"/>
+          <p:cNvPr id="356466782" name="Slide Image Placeholder 1"/>
           <p:cNvSpPr>
             <a:spLocks noChangeAspect="1" noGrp="1" noRot="1"/>
           </p:cNvSpPr>
@@ -1028,7 +1028,7 @@
       </p:sp>
       <p:sp>
         <p:nvSpPr>
-          <p:cNvPr id="1490220466" name="Notes Placeholder 2"/>
+          <p:cNvPr id="1331973556" name="Notes Placeholder 2"/>
           <p:cNvSpPr>
             <a:spLocks noGrp="1"/>
           </p:cNvSpPr>
@@ -1050,7 +1050,7 @@
       </p:sp>
       <p:sp>
         <p:nvSpPr>
-          <p:cNvPr id="1576511787" name="Slide Number Placeholder 3"/>
+          <p:cNvPr id="239793005" name="Slide Number Placeholder 3"/>
           <p:cNvSpPr>
             <a:spLocks noGrp="1"/>
           </p:cNvSpPr>
@@ -1415,7 +1415,7 @@
       </p:grpSpPr>
       <p:sp>
         <p:nvSpPr>
-          <p:cNvPr id="234288150" name="Shape 0"/>
+          <p:cNvPr id="2133771870" name="Shape 0"/>
           <p:cNvSpPr/>
           <p:nvPr/>
         </p:nvSpPr>
@@ -1440,7 +1440,7 @@
       </p:sp>
       <p:sp>
         <p:nvSpPr>
-          <p:cNvPr id="1394982540" name="Shape 1"/>
+          <p:cNvPr id="2142442180" name="Shape 1"/>
           <p:cNvSpPr/>
           <p:nvPr/>
         </p:nvSpPr>
@@ -1469,7 +1469,7 @@
       </p:sp>
       <p:sp>
         <p:nvSpPr>
-          <p:cNvPr id="1430118997" name="Shape 2"/>
+          <p:cNvPr id="1828450332" name="Shape 2"/>
           <p:cNvSpPr/>
           <p:nvPr/>
         </p:nvSpPr>
@@ -1498,7 +1498,7 @@
       </p:sp>
       <p:sp>
         <p:nvSpPr>
-          <p:cNvPr id="236952931" name="Shape 3"/>
+          <p:cNvPr id="1184335710" name="Shape 3"/>
           <p:cNvSpPr/>
           <p:nvPr/>
         </p:nvSpPr>
@@ -1527,7 +1527,7 @@
       </p:sp>
       <p:sp>
         <p:nvSpPr>
-          <p:cNvPr id="1154440211" name="Shape 4"/>
+          <p:cNvPr id="422278151" name="Shape 4"/>
           <p:cNvSpPr/>
           <p:nvPr/>
         </p:nvSpPr>
@@ -1556,7 +1556,7 @@
       </p:sp>
       <p:sp>
         <p:nvSpPr>
-          <p:cNvPr id="1401523307" name="Shape 5"/>
+          <p:cNvPr id="2066165006" name="Shape 5"/>
           <p:cNvSpPr/>
           <p:nvPr/>
         </p:nvSpPr>
@@ -1585,7 +1585,7 @@
       </p:sp>
       <p:sp>
         <p:nvSpPr>
-          <p:cNvPr id="1134455330" name="Text 6"/>
+          <p:cNvPr id="56599954" name="Text 6"/>
           <p:cNvSpPr/>
           <p:nvPr/>
         </p:nvSpPr>
@@ -1625,7 +1625,7 @@
       </p:sp>
       <p:sp>
         <p:nvSpPr>
-          <p:cNvPr id="661528179" name="Text 7"/>
+          <p:cNvPr id="1420492280" name="Text 7"/>
           <p:cNvSpPr/>
           <p:nvPr/>
         </p:nvSpPr>
@@ -1665,7 +1665,7 @@
       </p:sp>
       <p:sp>
         <p:nvSpPr>
-          <p:cNvPr id="345429569" name="Shape 8"/>
+          <p:cNvPr id="1707228727" name="Shape 8"/>
           <p:cNvSpPr/>
           <p:nvPr/>
         </p:nvSpPr>
@@ -1690,7 +1690,7 @@
       </p:sp>
       <p:sp>
         <p:nvSpPr>
-          <p:cNvPr id="1747951600" name="Text 9"/>
+          <p:cNvPr id="361856325" name="Text 9"/>
           <p:cNvSpPr/>
           <p:nvPr/>
         </p:nvSpPr>
@@ -1770,7 +1770,7 @@
       </p:grpSpPr>
       <p:sp>
         <p:nvSpPr>
-          <p:cNvPr id="1040768499" name="Shape 0"/>
+          <p:cNvPr id="1353086291" name="Shape 0"/>
           <p:cNvSpPr/>
           <p:nvPr/>
         </p:nvSpPr>
@@ -1795,7 +1795,7 @@
       </p:sp>
       <p:sp>
         <p:nvSpPr>
-          <p:cNvPr id="1370287643" name="Text 1"/>
+          <p:cNvPr id="965924905" name="Text 1"/>
           <p:cNvSpPr/>
           <p:nvPr/>
         </p:nvSpPr>
@@ -1835,7 +1835,7 @@
       </p:sp>
       <p:sp>
         <p:nvSpPr>
-          <p:cNvPr id="314143106" name="Shape 2"/>
+          <p:cNvPr id="1077814246" name="Shape 2"/>
           <p:cNvSpPr/>
           <p:nvPr/>
         </p:nvSpPr>
@@ -1867,7 +1867,7 @@
       </p:sp>
       <p:sp>
         <p:nvSpPr>
-          <p:cNvPr id="1330179577" name="Shape 2"/>
+          <p:cNvPr id="1175230966" name="Shape 2"/>
           <p:cNvSpPr/>
           <p:nvPr/>
         </p:nvSpPr>
@@ -1899,7 +1899,7 @@
       </p:sp>
       <p:sp>
         <p:nvSpPr>
-          <p:cNvPr id="1807577297" name="Shape 2"/>
+          <p:cNvPr id="1016911549" name="Shape 2"/>
           <p:cNvSpPr/>
           <p:nvPr/>
         </p:nvSpPr>
@@ -1931,7 +1931,7 @@
       </p:sp>
       <p:sp>
         <p:nvSpPr>
-          <p:cNvPr id="965875906" name="Shape 2"/>
+          <p:cNvPr id="754564943" name="Shape 2"/>
           <p:cNvSpPr/>
           <p:nvPr/>
         </p:nvSpPr>
@@ -1963,13 +1963,13 @@
       </p:sp>
       <p:sp modelId="{A8BC8CD6-8738-41EA-9E71-3CD4C9AF2582}">
         <p:nvSpPr>
-          <p:cNvPr id="628477612" name=""/>
+          <p:cNvPr id="271703874" name=""/>
           <p:cNvSpPr/>
           <p:nvPr/>
         </p:nvSpPr>
         <p:spPr bwMode="auto">
           <a:xfrm>
-            <a:off x="345747" y="1039317"/>
+            <a:off x="345747" y="1039316"/>
             <a:ext cx="683613" cy="683613"/>
           </a:xfrm>
           <a:prstGeom prst="rect">
@@ -2010,7 +2010,7 @@
       </p:sp>
       <p:sp modelId="{B63312C8-A8E7-471C-BDC7-E288FC589C93}">
         <p:nvSpPr>
-          <p:cNvPr id="1795990470" name=""/>
+          <p:cNvPr id="470688097" name=""/>
           <p:cNvSpPr/>
           <p:nvPr/>
         </p:nvSpPr>
@@ -2057,7 +2057,7 @@
       </p:sp>
       <p:sp modelId="{CA7E8371-02DB-4E6B-BDD4-4E6725844AB0}">
         <p:nvSpPr>
-          <p:cNvPr id="6785565" name=""/>
+          <p:cNvPr id="1171839730" name=""/>
           <p:cNvSpPr/>
           <p:nvPr/>
         </p:nvSpPr>
@@ -2104,7 +2104,7 @@
       </p:sp>
       <p:sp modelId="{CA7E8371-02DB-4E6B-BDD4-4E6725844AB0}">
         <p:nvSpPr>
-          <p:cNvPr id="181678663" name=""/>
+          <p:cNvPr id="728579117" name=""/>
           <p:cNvSpPr/>
           <p:nvPr/>
         </p:nvSpPr>
@@ -2153,7 +2153,7 @@
       </p:sp>
       <p:sp>
         <p:nvSpPr>
-          <p:cNvPr id="1792004691" name=""/>
+          <p:cNvPr id="1944002111" name=""/>
           <p:cNvSpPr txBox="1"/>
           <p:nvPr/>
         </p:nvSpPr>
@@ -2202,7 +2202,7 @@
       </p:sp>
       <p:sp>
         <p:nvSpPr>
-          <p:cNvPr id="999297325" name=""/>
+          <p:cNvPr id="704381987" name=""/>
           <p:cNvSpPr txBox="1"/>
           <p:nvPr/>
         </p:nvSpPr>
@@ -2251,7 +2251,7 @@
       </p:sp>
       <p:sp>
         <p:nvSpPr>
-          <p:cNvPr id="1835559148" name=""/>
+          <p:cNvPr id="416283854" name=""/>
           <p:cNvSpPr txBox="1"/>
           <p:nvPr/>
         </p:nvSpPr>
@@ -2300,7 +2300,7 @@
       </p:sp>
       <p:sp>
         <p:nvSpPr>
-          <p:cNvPr id="2134761818" name=""/>
+          <p:cNvPr id="1383374028" name=""/>
           <p:cNvSpPr txBox="1"/>
           <p:nvPr/>
         </p:nvSpPr>
@@ -2380,7 +2380,7 @@
       </p:grpSpPr>
       <p:sp>
         <p:nvSpPr>
-          <p:cNvPr id="492043432" name="Shape 0"/>
+          <p:cNvPr id="1053044368" name="Shape 0"/>
           <p:cNvSpPr/>
           <p:nvPr/>
         </p:nvSpPr>
@@ -2405,7 +2405,7 @@
       </p:sp>
       <p:sp>
         <p:nvSpPr>
-          <p:cNvPr id="545340689" name="Text 1"/>
+          <p:cNvPr id="1509059724" name="Text 1"/>
           <p:cNvSpPr/>
           <p:nvPr/>
         </p:nvSpPr>
@@ -2445,7 +2445,7 @@
       </p:sp>
       <p:sp>
         <p:nvSpPr>
-          <p:cNvPr id="570389632" name="Shape 2"/>
+          <p:cNvPr id="481073193" name="Shape 2"/>
           <p:cNvSpPr/>
           <p:nvPr/>
         </p:nvSpPr>
@@ -2477,7 +2477,7 @@
       </p:sp>
       <p:sp>
         <p:nvSpPr>
-          <p:cNvPr id="774430872" name="Shape 3"/>
+          <p:cNvPr id="29376933" name="Shape 3"/>
           <p:cNvSpPr/>
           <p:nvPr/>
         </p:nvSpPr>
@@ -2502,7 +2502,7 @@
       </p:sp>
       <p:sp>
         <p:nvSpPr>
-          <p:cNvPr id="1621276531" name="Shape 4"/>
+          <p:cNvPr id="844067266" name="Shape 4"/>
           <p:cNvSpPr/>
           <p:nvPr/>
         </p:nvSpPr>
@@ -2527,7 +2527,7 @@
       </p:sp>
       <p:pic>
         <p:nvPicPr>
-          <p:cNvPr id="1692371210" name="Image 0" descr="preencoded.png"/>
+          <p:cNvPr id="1293220103" name="Image 0" descr="preencoded.png"/>
           <p:cNvPicPr>
             <a:picLocks noChangeAspect="1"/>
           </p:cNvPicPr>
@@ -2549,7 +2549,7 @@
       </p:pic>
       <p:sp>
         <p:nvSpPr>
-          <p:cNvPr id="1389862890" name="Text 5"/>
+          <p:cNvPr id="1696720075" name="Text 5"/>
           <p:cNvSpPr/>
           <p:nvPr/>
         </p:nvSpPr>
@@ -2589,7 +2589,7 @@
       </p:sp>
       <p:sp>
         <p:nvSpPr>
-          <p:cNvPr id="1142479438" name="Text 6"/>
+          <p:cNvPr id="374094322" name="Text 6"/>
           <p:cNvSpPr/>
           <p:nvPr/>
         </p:nvSpPr>
@@ -2640,13 +2640,13 @@
       </p:sp>
       <p:sp>
         <p:nvSpPr>
-          <p:cNvPr id="1119947555" name="Shape 7"/>
+          <p:cNvPr id="1630563627" name="Shape 7"/>
           <p:cNvSpPr/>
           <p:nvPr/>
         </p:nvSpPr>
         <p:spPr bwMode="auto">
           <a:xfrm>
-            <a:off x="640080" y="2517070"/>
+            <a:off x="640080" y="2517069"/>
             <a:ext cx="2103120" cy="18288"/>
           </a:xfrm>
           <a:prstGeom prst="rect">
@@ -2665,7 +2665,7 @@
       </p:sp>
       <p:sp>
         <p:nvSpPr>
-          <p:cNvPr id="429551329" name="Shape 10"/>
+          <p:cNvPr id="68360726" name="Shape 10"/>
           <p:cNvSpPr/>
           <p:nvPr/>
         </p:nvSpPr>
@@ -2690,7 +2690,7 @@
       </p:sp>
       <p:sp>
         <p:nvSpPr>
-          <p:cNvPr id="1066846694" name="Text 11"/>
+          <p:cNvPr id="1516038380" name="Text 11"/>
           <p:cNvSpPr/>
           <p:nvPr/>
         </p:nvSpPr>
@@ -2752,7 +2752,7 @@
       </p:sp>
       <p:sp>
         <p:nvSpPr>
-          <p:cNvPr id="283878545" name="Shape 12"/>
+          <p:cNvPr id="608972180" name="Shape 12"/>
           <p:cNvSpPr/>
           <p:nvPr/>
         </p:nvSpPr>
@@ -2777,7 +2777,7 @@
       </p:sp>
       <p:sp>
         <p:nvSpPr>
-          <p:cNvPr id="1475171180" name="Text 13"/>
+          <p:cNvPr id="2140998883" name="Text 13"/>
           <p:cNvSpPr/>
           <p:nvPr/>
         </p:nvSpPr>
@@ -2828,7 +2828,7 @@
       </p:sp>
       <p:sp>
         <p:nvSpPr>
-          <p:cNvPr id="1400621730" name="Shape 14"/>
+          <p:cNvPr id="1004886497" name="Shape 14"/>
           <p:cNvSpPr/>
           <p:nvPr/>
         </p:nvSpPr>
@@ -2853,7 +2853,7 @@
       </p:sp>
       <p:sp>
         <p:nvSpPr>
-          <p:cNvPr id="691526302" name="Text 15"/>
+          <p:cNvPr id="1747435039" name="Text 15"/>
           <p:cNvSpPr/>
           <p:nvPr/>
         </p:nvSpPr>
@@ -2893,7 +2893,7 @@
       </p:sp>
       <p:sp>
         <p:nvSpPr>
-          <p:cNvPr id="779842672" name="Shape 16"/>
+          <p:cNvPr id="1486436598" name="Shape 16"/>
           <p:cNvSpPr/>
           <p:nvPr/>
         </p:nvSpPr>
@@ -2918,7 +2918,7 @@
       </p:sp>
       <p:sp>
         <p:nvSpPr>
-          <p:cNvPr id="1494165247" name="Text 17"/>
+          <p:cNvPr id="1910924638" name="Text 17"/>
           <p:cNvSpPr/>
           <p:nvPr/>
         </p:nvSpPr>
@@ -2958,7 +2958,7 @@
       </p:sp>
       <p:sp>
         <p:nvSpPr>
-          <p:cNvPr id="1712176342" name="Shape 18"/>
+          <p:cNvPr id="2026892691" name="Shape 18"/>
           <p:cNvSpPr/>
           <p:nvPr/>
         </p:nvSpPr>
@@ -2983,7 +2983,7 @@
       </p:sp>
       <p:sp>
         <p:nvSpPr>
-          <p:cNvPr id="371053674" name="Text 19"/>
+          <p:cNvPr id="1368597479" name="Text 19"/>
           <p:cNvSpPr/>
           <p:nvPr/>
         </p:nvSpPr>
@@ -3023,7 +3023,7 @@
       </p:sp>
       <p:sp>
         <p:nvSpPr>
-          <p:cNvPr id="1851754423" name="Shape 20"/>
+          <p:cNvPr id="714030644" name="Shape 20"/>
           <p:cNvSpPr/>
           <p:nvPr/>
         </p:nvSpPr>
@@ -3055,7 +3055,7 @@
       </p:sp>
       <p:sp>
         <p:nvSpPr>
-          <p:cNvPr id="2065823353" name="Shape 21"/>
+          <p:cNvPr id="1002399029" name="Shape 21"/>
           <p:cNvSpPr/>
           <p:nvPr/>
         </p:nvSpPr>
@@ -3080,7 +3080,7 @@
       </p:sp>
       <p:sp>
         <p:nvSpPr>
-          <p:cNvPr id="1034285224" name="Shape 22"/>
+          <p:cNvPr id="1047192871" name="Shape 22"/>
           <p:cNvSpPr/>
           <p:nvPr/>
         </p:nvSpPr>
@@ -3105,7 +3105,7 @@
       </p:sp>
       <p:pic>
         <p:nvPicPr>
-          <p:cNvPr id="830946581" name="Image 1" descr="preencoded.png"/>
+          <p:cNvPr id="1782332063" name="Image 1" descr="preencoded.png"/>
           <p:cNvPicPr>
             <a:picLocks noChangeAspect="1"/>
           </p:cNvPicPr>
@@ -3127,7 +3127,7 @@
       </p:pic>
       <p:sp>
         <p:nvSpPr>
-          <p:cNvPr id="1062820552" name="Text 23"/>
+          <p:cNvPr id="1008383046" name="Text 23"/>
           <p:cNvSpPr/>
           <p:nvPr/>
         </p:nvSpPr>
@@ -3167,7 +3167,7 @@
       </p:sp>
       <p:sp>
         <p:nvSpPr>
-          <p:cNvPr id="365848990" name="Text 24"/>
+          <p:cNvPr id="457840282" name="Text 24"/>
           <p:cNvSpPr/>
           <p:nvPr/>
         </p:nvSpPr>
@@ -3207,13 +3207,13 @@
       </p:sp>
       <p:sp>
         <p:nvSpPr>
-          <p:cNvPr id="67978994" name="Shape 25"/>
+          <p:cNvPr id="2027538657" name="Shape 25"/>
           <p:cNvSpPr/>
           <p:nvPr/>
         </p:nvSpPr>
         <p:spPr bwMode="auto">
           <a:xfrm>
-            <a:off x="3611880" y="2517070"/>
+            <a:off x="3611880" y="2517069"/>
             <a:ext cx="2103120" cy="18288"/>
           </a:xfrm>
           <a:prstGeom prst="rect">
@@ -3232,7 +3232,7 @@
       </p:sp>
       <p:sp>
         <p:nvSpPr>
-          <p:cNvPr id="589696805" name="Shape 26"/>
+          <p:cNvPr id="930174363" name="Shape 26"/>
           <p:cNvSpPr/>
           <p:nvPr/>
         </p:nvSpPr>
@@ -3257,7 +3257,7 @@
       </p:sp>
       <p:sp>
         <p:nvSpPr>
-          <p:cNvPr id="886037405" name="Text 27"/>
+          <p:cNvPr id="1075496747" name="Text 27"/>
           <p:cNvSpPr/>
           <p:nvPr/>
         </p:nvSpPr>
@@ -3297,7 +3297,7 @@
       </p:sp>
       <p:sp>
         <p:nvSpPr>
-          <p:cNvPr id="1743505235" name="Shape 28"/>
+          <p:cNvPr id="1932118231" name="Shape 28"/>
           <p:cNvSpPr/>
           <p:nvPr/>
         </p:nvSpPr>
@@ -3322,7 +3322,7 @@
       </p:sp>
       <p:sp>
         <p:nvSpPr>
-          <p:cNvPr id="2094026964" name="Text 29"/>
+          <p:cNvPr id="441591825" name="Text 29"/>
           <p:cNvSpPr/>
           <p:nvPr/>
         </p:nvSpPr>
@@ -3362,7 +3362,7 @@
       </p:sp>
       <p:sp>
         <p:nvSpPr>
-          <p:cNvPr id="100060438" name="Shape 36"/>
+          <p:cNvPr id="1123616937" name="Shape 36"/>
           <p:cNvSpPr/>
           <p:nvPr/>
         </p:nvSpPr>
@@ -3394,7 +3394,7 @@
       </p:sp>
       <p:sp>
         <p:nvSpPr>
-          <p:cNvPr id="575461273" name="Shape 37"/>
+          <p:cNvPr id="1295384754" name="Shape 37"/>
           <p:cNvSpPr/>
           <p:nvPr/>
         </p:nvSpPr>
@@ -3419,7 +3419,7 @@
       </p:sp>
       <p:sp>
         <p:nvSpPr>
-          <p:cNvPr id="458279529" name="Shape 38"/>
+          <p:cNvPr id="1607348451" name="Shape 38"/>
           <p:cNvSpPr/>
           <p:nvPr/>
         </p:nvSpPr>
@@ -3444,7 +3444,7 @@
       </p:sp>
       <p:pic>
         <p:nvPicPr>
-          <p:cNvPr id="750803473" name="Image 2" descr="preencoded.png"/>
+          <p:cNvPr id="272376320" name="Image 2" descr="preencoded.png"/>
           <p:cNvPicPr>
             <a:picLocks noChangeAspect="1"/>
           </p:cNvPicPr>
@@ -3466,7 +3466,7 @@
       </p:pic>
       <p:sp>
         <p:nvSpPr>
-          <p:cNvPr id="711390128" name="Text 39"/>
+          <p:cNvPr id="158653086" name="Text 39"/>
           <p:cNvSpPr/>
           <p:nvPr/>
         </p:nvSpPr>
@@ -3506,7 +3506,7 @@
       </p:sp>
       <p:sp>
         <p:nvSpPr>
-          <p:cNvPr id="1142907279" name="Text 40"/>
+          <p:cNvPr id="68816422" name="Text 40"/>
           <p:cNvSpPr/>
           <p:nvPr/>
         </p:nvSpPr>
@@ -3546,13 +3546,13 @@
       </p:sp>
       <p:sp>
         <p:nvSpPr>
-          <p:cNvPr id="1156647590" name="Shape 41"/>
+          <p:cNvPr id="1682762684" name="Shape 41"/>
           <p:cNvSpPr/>
           <p:nvPr/>
         </p:nvSpPr>
         <p:spPr bwMode="auto">
           <a:xfrm>
-            <a:off x="6583680" y="2517070"/>
+            <a:off x="6583680" y="2517069"/>
             <a:ext cx="2103120" cy="18288"/>
           </a:xfrm>
           <a:prstGeom prst="rect">
@@ -3571,7 +3571,7 @@
       </p:sp>
       <p:sp>
         <p:nvSpPr>
-          <p:cNvPr id="1676127320" name="Shape 42"/>
+          <p:cNvPr id="1060981673" name="Shape 42"/>
           <p:cNvSpPr/>
           <p:nvPr/>
         </p:nvSpPr>
@@ -3596,7 +3596,7 @@
       </p:sp>
       <p:sp>
         <p:nvSpPr>
-          <p:cNvPr id="795334068" name="Text 43"/>
+          <p:cNvPr id="4308614" name="Text 43"/>
           <p:cNvSpPr/>
           <p:nvPr/>
         </p:nvSpPr>
@@ -3636,7 +3636,7 @@
       </p:sp>
       <p:grpSp>
         <p:nvGrpSpPr>
-          <p:cNvPr id="1709988320" name=""/>
+          <p:cNvPr id="98723263" name=""/>
           <p:cNvGrpSpPr/>
           <p:nvPr/>
         </p:nvGrpSpPr>
@@ -3716,7 +3716,7 @@
       </p:grpSp>
       <p:sp>
         <p:nvSpPr>
-          <p:cNvPr id="1734330772" name="Shape 18"/>
+          <p:cNvPr id="1785849966" name="Shape 18"/>
           <p:cNvSpPr/>
           <p:nvPr/>
         </p:nvSpPr>
@@ -3741,7 +3741,7 @@
       </p:sp>
       <p:sp>
         <p:nvSpPr>
-          <p:cNvPr id="1130735717" name="Text 19"/>
+          <p:cNvPr id="15817943" name="Text 19"/>
           <p:cNvSpPr/>
           <p:nvPr/>
         </p:nvSpPr>
@@ -3781,7 +3781,7 @@
       </p:sp>
       <p:sp>
         <p:nvSpPr>
-          <p:cNvPr id="335177847" name="Text 29"/>
+          <p:cNvPr id="1693367062" name="Text 29"/>
           <p:cNvSpPr/>
           <p:nvPr/>
         </p:nvSpPr>
@@ -3821,7 +3821,7 @@
       </p:sp>
       <p:sp>
         <p:nvSpPr>
-          <p:cNvPr id="312959200" name="Shape 28"/>
+          <p:cNvPr id="111001990" name="Shape 28"/>
           <p:cNvSpPr/>
           <p:nvPr/>
         </p:nvSpPr>
@@ -3886,7 +3886,7 @@
       </p:grpSpPr>
       <p:sp>
         <p:nvSpPr>
-          <p:cNvPr id="282886709" name="Shape 0"/>
+          <p:cNvPr id="1171945367" name="Shape 0"/>
           <p:cNvSpPr/>
           <p:nvPr/>
         </p:nvSpPr>
@@ -3911,7 +3911,7 @@
       </p:sp>
       <p:sp>
         <p:nvSpPr>
-          <p:cNvPr id="525780562" name="Text 1"/>
+          <p:cNvPr id="948913531" name="Text 1"/>
           <p:cNvSpPr/>
           <p:nvPr/>
         </p:nvSpPr>
@@ -3951,7 +3951,7 @@
       </p:sp>
       <p:sp>
         <p:nvSpPr>
-          <p:cNvPr id="1877115757" name="Shape 4"/>
+          <p:cNvPr id="1866220418" name="Shape 4"/>
           <p:cNvSpPr/>
           <p:nvPr/>
         </p:nvSpPr>
@@ -3983,7 +3983,7 @@
       </p:sp>
       <p:sp>
         <p:nvSpPr>
-          <p:cNvPr id="1497626838" name="Shape 5"/>
+          <p:cNvPr id="1782073771" name="Shape 5"/>
           <p:cNvSpPr/>
           <p:nvPr/>
         </p:nvSpPr>
@@ -4008,7 +4008,7 @@
       </p:sp>
       <p:sp>
         <p:nvSpPr>
-          <p:cNvPr id="1979253294" name="Text 6"/>
+          <p:cNvPr id="1692195154" name="Text 6"/>
           <p:cNvSpPr/>
           <p:nvPr/>
         </p:nvSpPr>
@@ -4048,7 +4048,7 @@
       </p:sp>
       <p:grpSp>
         <p:nvGrpSpPr>
-          <p:cNvPr id="569992540" name=""/>
+          <p:cNvPr id="293695812" name=""/>
           <p:cNvGrpSpPr/>
           <p:nvPr/>
         </p:nvGrpSpPr>
@@ -4150,7 +4150,7 @@
       </p:grpSp>
       <p:grpSp>
         <p:nvGrpSpPr>
-          <p:cNvPr id="915935425" name=""/>
+          <p:cNvPr id="1514163319" name=""/>
           <p:cNvGrpSpPr/>
           <p:nvPr/>
         </p:nvGrpSpPr>
@@ -4392,7 +4392,7 @@
       </p:grpSp>
       <p:grpSp>
         <p:nvGrpSpPr>
-          <p:cNvPr id="1144397625" name=""/>
+          <p:cNvPr id="330477789" name=""/>
           <p:cNvGrpSpPr/>
           <p:nvPr/>
         </p:nvGrpSpPr>
@@ -4569,7 +4569,7 @@
       </p:grpSp>
       <p:grpSp>
         <p:nvGrpSpPr>
-          <p:cNvPr id="85849588" name=""/>
+          <p:cNvPr id="1732622531" name=""/>
           <p:cNvGrpSpPr/>
           <p:nvPr/>
         </p:nvGrpSpPr>
@@ -4876,7 +4876,7 @@
       </p:grpSp>
       <p:grpSp>
         <p:nvGrpSpPr>
-          <p:cNvPr id="1593158382" name=""/>
+          <p:cNvPr id="805409461" name=""/>
           <p:cNvGrpSpPr/>
           <p:nvPr/>
         </p:nvGrpSpPr>
@@ -5183,7 +5183,7 @@
       </p:grpSp>
       <p:sp>
         <p:nvSpPr>
-          <p:cNvPr id="889094402" name="Text 16"/>
+          <p:cNvPr id="158771741" name="Text 16"/>
           <p:cNvSpPr/>
           <p:nvPr/>
         </p:nvSpPr>
@@ -5212,7 +5212,7 @@
       </p:sp>
       <p:grpSp>
         <p:nvGrpSpPr>
-          <p:cNvPr id="758510439" name=""/>
+          <p:cNvPr id="1790261757" name=""/>
           <p:cNvGrpSpPr/>
           <p:nvPr/>
         </p:nvGrpSpPr>
@@ -5292,7 +5292,7 @@
       </p:grpSp>
       <p:grpSp>
         <p:nvGrpSpPr>
-          <p:cNvPr id="1384872140" name=""/>
+          <p:cNvPr id="643150038" name=""/>
           <p:cNvGrpSpPr/>
           <p:nvPr/>
         </p:nvGrpSpPr>
@@ -5372,7 +5372,7 @@
       </p:grpSp>
       <p:grpSp>
         <p:nvGrpSpPr>
-          <p:cNvPr id="1479224478" name=""/>
+          <p:cNvPr id="863721738" name=""/>
           <p:cNvGrpSpPr/>
           <p:nvPr/>
         </p:nvGrpSpPr>
@@ -5452,7 +5452,7 @@
       </p:grpSp>
       <p:grpSp>
         <p:nvGrpSpPr>
-          <p:cNvPr id="1404701487" name=""/>
+          <p:cNvPr id="2090430873" name=""/>
           <p:cNvGrpSpPr/>
           <p:nvPr/>
         </p:nvGrpSpPr>
@@ -5532,7 +5532,7 @@
       </p:grpSp>
       <p:grpSp>
         <p:nvGrpSpPr>
-          <p:cNvPr id="1869321367" name=""/>
+          <p:cNvPr id="98921278" name=""/>
           <p:cNvGrpSpPr/>
           <p:nvPr/>
         </p:nvGrpSpPr>
@@ -5612,7 +5612,7 @@
       </p:grpSp>
       <p:grpSp>
         <p:nvGrpSpPr>
-          <p:cNvPr id="444435900" name=""/>
+          <p:cNvPr id="336254761" name=""/>
           <p:cNvGrpSpPr/>
           <p:nvPr/>
         </p:nvGrpSpPr>
@@ -5692,7 +5692,7 @@
       </p:grpSp>
       <p:grpSp>
         <p:nvGrpSpPr>
-          <p:cNvPr id="1574865308" name=""/>
+          <p:cNvPr id="45074213" name=""/>
           <p:cNvGrpSpPr/>
           <p:nvPr/>
         </p:nvGrpSpPr>
@@ -5772,7 +5772,7 @@
       </p:grpSp>
       <p:grpSp>
         <p:nvGrpSpPr>
-          <p:cNvPr id="651494589" name=""/>
+          <p:cNvPr id="586422459" name=""/>
           <p:cNvGrpSpPr/>
           <p:nvPr/>
         </p:nvGrpSpPr>
@@ -5852,7 +5852,7 @@
       </p:grpSp>
       <p:grpSp>
         <p:nvGrpSpPr>
-          <p:cNvPr id="2007303275" name=""/>
+          <p:cNvPr id="702946651" name=""/>
           <p:cNvGrpSpPr/>
           <p:nvPr/>
         </p:nvGrpSpPr>
@@ -5932,7 +5932,7 @@
       </p:grpSp>
       <p:grpSp>
         <p:nvGrpSpPr>
-          <p:cNvPr id="1596930929" name=""/>
+          <p:cNvPr id="1822052636" name=""/>
           <p:cNvGrpSpPr/>
           <p:nvPr/>
         </p:nvGrpSpPr>
@@ -6012,7 +6012,7 @@
       </p:grpSp>
       <p:sp>
         <p:nvSpPr>
-          <p:cNvPr id="2069487272" name="Shape 29"/>
+          <p:cNvPr id="596279067" name="Shape 29"/>
           <p:cNvSpPr/>
           <p:nvPr/>
         </p:nvSpPr>
@@ -6035,7 +6035,7 @@
       </p:sp>
       <p:sp>
         <p:nvSpPr>
-          <p:cNvPr id="244081076" name="Shape 29"/>
+          <p:cNvPr id="1709940234" name="Shape 29"/>
           <p:cNvSpPr/>
           <p:nvPr/>
         </p:nvSpPr>
@@ -6058,7 +6058,7 @@
       </p:sp>
       <p:sp>
         <p:nvSpPr>
-          <p:cNvPr id="1032347988" name="Shape 29"/>
+          <p:cNvPr id="1972108445" name="Shape 29"/>
           <p:cNvSpPr/>
           <p:nvPr/>
         </p:nvSpPr>
@@ -6081,7 +6081,7 @@
       </p:sp>
       <p:sp>
         <p:nvSpPr>
-          <p:cNvPr id="1623794016" name="Shape 29"/>
+          <p:cNvPr id="790827463" name="Shape 29"/>
           <p:cNvSpPr/>
           <p:nvPr/>
         </p:nvSpPr>
@@ -6104,7 +6104,7 @@
       </p:sp>
       <p:sp>
         <p:nvSpPr>
-          <p:cNvPr id="770799788" name="Shape 29"/>
+          <p:cNvPr id="286550017" name="Shape 29"/>
           <p:cNvSpPr/>
           <p:nvPr/>
         </p:nvSpPr>
@@ -6122,98 +6122,6 @@
               <a:srgbClr val="7F7F7F"/>
             </a:solidFill>
             <a:prstDash val="solid"/>
-          </a:ln>
-        </p:spPr>
-      </p:sp>
-      <p:sp>
-        <p:nvSpPr>
-          <p:cNvPr id="281415860" name="Shape 29"/>
-          <p:cNvSpPr/>
-          <p:nvPr/>
-        </p:nvSpPr>
-        <p:spPr bwMode="auto">
-          <a:xfrm flipH="0" flipV="1">
-            <a:off x="2395728" y="1846040"/>
-            <a:ext cx="1088264" cy="0"/>
-          </a:xfrm>
-          <a:prstGeom prst="line">
-            <a:avLst/>
-          </a:prstGeom>
-          <a:noFill/>
-          <a:ln w="15240">
-            <a:solidFill>
-              <a:srgbClr val="7F7F7F"/>
-            </a:solidFill>
-            <a:prstDash val="dash"/>
-          </a:ln>
-        </p:spPr>
-      </p:sp>
-      <p:sp>
-        <p:nvSpPr>
-          <p:cNvPr id="195820026" name="Shape 29"/>
-          <p:cNvSpPr/>
-          <p:nvPr/>
-        </p:nvSpPr>
-        <p:spPr bwMode="auto">
-          <a:xfrm flipH="0" flipV="1">
-            <a:off x="1212306" y="893469"/>
-            <a:ext cx="6783028" cy="62819"/>
-          </a:xfrm>
-          <a:prstGeom prst="line">
-            <a:avLst/>
-          </a:prstGeom>
-          <a:noFill/>
-          <a:ln w="15240">
-            <a:solidFill>
-              <a:srgbClr val="7F7F7F"/>
-            </a:solidFill>
-            <a:prstDash val="dash"/>
-          </a:ln>
-        </p:spPr>
-      </p:sp>
-      <p:sp>
-        <p:nvSpPr>
-          <p:cNvPr id="1280921635" name="Shape 29"/>
-          <p:cNvSpPr/>
-          <p:nvPr/>
-        </p:nvSpPr>
-        <p:spPr bwMode="auto">
-          <a:xfrm flipH="0" flipV="1">
-            <a:off x="7995335" y="893469"/>
-            <a:ext cx="0" cy="138754"/>
-          </a:xfrm>
-          <a:prstGeom prst="line">
-            <a:avLst/>
-          </a:prstGeom>
-          <a:noFill/>
-          <a:ln w="15240">
-            <a:solidFill>
-              <a:srgbClr val="7F7F7F"/>
-            </a:solidFill>
-            <a:prstDash val="dash"/>
-          </a:ln>
-        </p:spPr>
-      </p:sp>
-      <p:sp>
-        <p:nvSpPr>
-          <p:cNvPr id="1841530576" name="Shape 29"/>
-          <p:cNvSpPr/>
-          <p:nvPr/>
-        </p:nvSpPr>
-        <p:spPr bwMode="auto">
-          <a:xfrm flipH="1" flipV="1">
-            <a:off x="1212306" y="956289"/>
-            <a:ext cx="0" cy="152398"/>
-          </a:xfrm>
-          <a:prstGeom prst="line">
-            <a:avLst/>
-          </a:prstGeom>
-          <a:noFill/>
-          <a:ln w="15240">
-            <a:solidFill>
-              <a:srgbClr val="7F7F7F"/>
-            </a:solidFill>
-            <a:prstDash val="dash"/>
           </a:ln>
         </p:spPr>
       </p:sp>
@@ -6259,7 +6167,7 @@
       </p:grpSpPr>
       <p:sp>
         <p:nvSpPr>
-          <p:cNvPr id="543744256" name="Shape 0"/>
+          <p:cNvPr id="1810289128" name="Shape 0"/>
           <p:cNvSpPr/>
           <p:nvPr/>
         </p:nvSpPr>
@@ -6284,7 +6192,7 @@
       </p:sp>
       <p:sp>
         <p:nvSpPr>
-          <p:cNvPr id="1982528409" name="Text 1"/>
+          <p:cNvPr id="112281903" name="Text 1"/>
           <p:cNvSpPr/>
           <p:nvPr/>
         </p:nvSpPr>
@@ -6324,7 +6232,7 @@
       </p:sp>
       <p:sp>
         <p:nvSpPr>
-          <p:cNvPr id="541583665" name="Shape 2"/>
+          <p:cNvPr id="2052464956" name="Shape 2"/>
           <p:cNvSpPr/>
           <p:nvPr/>
         </p:nvSpPr>
@@ -6349,7 +6257,7 @@
       </p:sp>
       <p:sp>
         <p:nvSpPr>
-          <p:cNvPr id="854303786" name="Text 3"/>
+          <p:cNvPr id="1312499559" name="Text 3"/>
           <p:cNvSpPr/>
           <p:nvPr/>
         </p:nvSpPr>
@@ -6389,7 +6297,7 @@
       </p:sp>
       <p:sp>
         <p:nvSpPr>
-          <p:cNvPr id="418006842" name="Shape 29"/>
+          <p:cNvPr id="523616618" name="Shape 29"/>
           <p:cNvSpPr/>
           <p:nvPr/>
         </p:nvSpPr>
@@ -6412,7 +6320,7 @@
       </p:sp>
       <p:grpSp>
         <p:nvGrpSpPr>
-          <p:cNvPr id="2024097410" name=""/>
+          <p:cNvPr id="36999070" name=""/>
           <p:cNvGrpSpPr/>
           <p:nvPr/>
         </p:nvGrpSpPr>
@@ -6514,7 +6422,7 @@
       </p:grpSp>
       <p:grpSp>
         <p:nvGrpSpPr>
-          <p:cNvPr id="356422063" name=""/>
+          <p:cNvPr id="2108949985" name=""/>
           <p:cNvGrpSpPr/>
           <p:nvPr/>
         </p:nvGrpSpPr>
@@ -6767,7 +6675,7 @@
       </p:grpSp>
       <p:sp>
         <p:nvSpPr>
-          <p:cNvPr id="950424189" name="Shape 29"/>
+          <p:cNvPr id="310947082" name="Shape 29"/>
           <p:cNvSpPr/>
           <p:nvPr/>
         </p:nvSpPr>
@@ -6790,7 +6698,7 @@
       </p:sp>
       <p:grpSp>
         <p:nvGrpSpPr>
-          <p:cNvPr id="49841512" name=""/>
+          <p:cNvPr id="2009013834" name=""/>
           <p:cNvGrpSpPr/>
           <p:nvPr/>
         </p:nvGrpSpPr>
@@ -7030,32 +6938,6 @@
           </p:txBody>
         </p:sp>
       </p:grpSp>
-      <p:sp>
-        <p:nvSpPr>
-          <p:cNvPr id="828176004" name="Shape 29"/>
-          <p:cNvSpPr/>
-          <p:nvPr/>
-        </p:nvSpPr>
-        <p:spPr bwMode="auto">
-          <a:xfrm flipH="0" flipV="0">
-            <a:off x="3029067" y="2238930"/>
-            <a:ext cx="2942798" cy="0"/>
-          </a:xfrm>
-          <a:prstGeom prst="line">
-            <a:avLst/>
-          </a:prstGeom>
-          <a:noFill/>
-          <a:ln w="15240">
-            <a:solidFill>
-              <a:schemeClr val="tx1">
-                <a:lumMod val="50196"/>
-                <a:lumOff val="49804"/>
-              </a:schemeClr>
-            </a:solidFill>
-            <a:prstDash val="dash"/>
-          </a:ln>
-        </p:spPr>
-      </p:sp>
     </p:spTree>
   </p:cSld>
   <p:clrMapOvr>
@@ -7098,7 +6980,7 @@
       </p:grpSpPr>
       <p:sp>
         <p:nvSpPr>
-          <p:cNvPr id="403694426" name="Shape 0"/>
+          <p:cNvPr id="519832114" name="Shape 0"/>
           <p:cNvSpPr/>
           <p:nvPr/>
         </p:nvSpPr>
@@ -7123,7 +7005,7 @@
       </p:sp>
       <p:sp>
         <p:nvSpPr>
-          <p:cNvPr id="1821057486" name="Text 1"/>
+          <p:cNvPr id="756741554" name="Text 1"/>
           <p:cNvSpPr/>
           <p:nvPr/>
         </p:nvSpPr>
@@ -7163,7 +7045,7 @@
       </p:sp>
       <p:sp>
         <p:nvSpPr>
-          <p:cNvPr id="1102863839" name="Shape 2"/>
+          <p:cNvPr id="1935763609" name="Shape 2"/>
           <p:cNvSpPr/>
           <p:nvPr/>
         </p:nvSpPr>
@@ -7188,7 +7070,7 @@
       </p:sp>
       <p:sp>
         <p:nvSpPr>
-          <p:cNvPr id="1820103822" name="Text 3"/>
+          <p:cNvPr id="1421896947" name="Text 3"/>
           <p:cNvSpPr/>
           <p:nvPr/>
         </p:nvSpPr>
@@ -7228,7 +7110,7 @@
       </p:sp>
       <p:grpSp>
         <p:nvGrpSpPr>
-          <p:cNvPr id="1583501093" name=""/>
+          <p:cNvPr id="818822246" name=""/>
           <p:cNvGrpSpPr/>
           <p:nvPr/>
         </p:nvGrpSpPr>
@@ -7330,7 +7212,7 @@
       </p:grpSp>
       <p:grpSp>
         <p:nvGrpSpPr>
-          <p:cNvPr id="1347959176" name=""/>
+          <p:cNvPr id="261405463" name=""/>
           <p:cNvGrpSpPr/>
           <p:nvPr/>
         </p:nvGrpSpPr>
@@ -7507,7 +7389,7 @@
       </p:grpSp>
       <p:sp>
         <p:nvSpPr>
-          <p:cNvPr id="1321497680" name="Shape 29"/>
+          <p:cNvPr id="1008123494" name="Shape 29"/>
           <p:cNvSpPr/>
           <p:nvPr/>
         </p:nvSpPr>
@@ -7530,7 +7412,7 @@
       </p:sp>
       <p:grpSp>
         <p:nvGrpSpPr>
-          <p:cNvPr id="452975052" name=""/>
+          <p:cNvPr id="332537248" name=""/>
           <p:cNvGrpSpPr/>
           <p:nvPr/>
         </p:nvGrpSpPr>
@@ -7707,7 +7589,7 @@
       </p:grpSp>
       <p:sp>
         <p:nvSpPr>
-          <p:cNvPr id="2109636821" name="Shape 29"/>
+          <p:cNvPr id="1282562385" name="Shape 29"/>
           <p:cNvSpPr/>
           <p:nvPr/>
         </p:nvSpPr>
@@ -7725,29 +7607,6 @@
               <a:srgbClr val="7F7F7F"/>
             </a:solidFill>
             <a:prstDash val="solid"/>
-          </a:ln>
-        </p:spPr>
-      </p:sp>
-      <p:sp>
-        <p:nvSpPr>
-          <p:cNvPr id="1371377885" name="Shape 29"/>
-          <p:cNvSpPr/>
-          <p:nvPr/>
-        </p:nvSpPr>
-        <p:spPr bwMode="auto">
-          <a:xfrm flipH="1" flipV="1">
-            <a:off x="3070044" y="1795831"/>
-            <a:ext cx="2659776" cy="0"/>
-          </a:xfrm>
-          <a:prstGeom prst="line">
-            <a:avLst/>
-          </a:prstGeom>
-          <a:noFill/>
-          <a:ln w="15240">
-            <a:solidFill>
-              <a:srgbClr val="7F7F7F"/>
-            </a:solidFill>
-            <a:prstDash val="dash"/>
           </a:ln>
         </p:spPr>
       </p:sp>
@@ -7793,7 +7652,7 @@
       </p:grpSpPr>
       <p:sp>
         <p:nvSpPr>
-          <p:cNvPr id="789973257" name="Shape 0"/>
+          <p:cNvPr id="1131884772" name="Shape 0"/>
           <p:cNvSpPr/>
           <p:nvPr/>
         </p:nvSpPr>
@@ -7818,7 +7677,7 @@
       </p:sp>
       <p:sp>
         <p:nvSpPr>
-          <p:cNvPr id="1580706496" name="Text 1"/>
+          <p:cNvPr id="1676049647" name="Text 1"/>
           <p:cNvSpPr/>
           <p:nvPr/>
         </p:nvSpPr>
@@ -7858,7 +7717,7 @@
       </p:sp>
       <p:grpSp>
         <p:nvGrpSpPr>
-          <p:cNvPr id="1460376541" name=""/>
+          <p:cNvPr id="1868722092" name=""/>
           <p:cNvGrpSpPr/>
           <p:nvPr/>
         </p:nvGrpSpPr>

</xml_diff>

<commit_message>
added placeholder for team picture
</commit_message>
<xml_diff>
--- a/docs/Mini_Jira_UseCases_EN.pptx
+++ b/docs/Mini_Jira_UseCases_EN.pptx
@@ -5,7 +5,7 @@
     <p:sldMasterId id="2147483648" r:id="rId1"/>
   </p:sldMasterIdLst>
   <p:notesMasterIdLst>
-    <p:notesMasterId r:id="rId9"/>
+    <p:notesMasterId r:id="rId10"/>
   </p:notesMasterIdLst>
   <p:sldIdLst>
     <p:sldId id="256" r:id="rId3"/>
@@ -14,6 +14,7 @@
     <p:sldId id="259" r:id="rId6"/>
     <p:sldId id="260" r:id="rId7"/>
     <p:sldId id="261" r:id="rId8"/>
+    <p:sldId id="262" r:id="rId9"/>
   </p:sldIdLst>
   <p:sldSz cx="9144000" cy="5143500"/>
   <p:notesSz cx="5143500" cy="9144000"/>
@@ -136,7 +137,7 @@
       </p:grpSpPr>
       <p:sp>
         <p:nvSpPr>
-          <p:cNvPr id="1054183668" name="Header Placeholder 1"/>
+          <p:cNvPr id="1245280865" name="Header Placeholder 1"/>
           <p:cNvSpPr>
             <a:spLocks noGrp="1"/>
           </p:cNvSpPr>
@@ -170,7 +171,7 @@
       </p:sp>
       <p:sp>
         <p:nvSpPr>
-          <p:cNvPr id="1400685746" name="Date Placeholder 2"/>
+          <p:cNvPr id="1614068449" name="Date Placeholder 2"/>
           <p:cNvSpPr>
             <a:spLocks noGrp="1"/>
           </p:cNvSpPr>
@@ -208,7 +209,7 @@
       </p:sp>
       <p:sp>
         <p:nvSpPr>
-          <p:cNvPr id="1969557186" name="Slide Image Placeholder 3"/>
+          <p:cNvPr id="2096728543" name="Slide Image Placeholder 3"/>
           <p:cNvSpPr>
             <a:spLocks noChangeAspect="1" noGrp="1" noRot="1"/>
           </p:cNvSpPr>
@@ -244,7 +245,7 @@
       </p:sp>
       <p:sp>
         <p:nvSpPr>
-          <p:cNvPr id="1589529951" name="Notes Placeholder 4"/>
+          <p:cNvPr id="327201737" name="Notes Placeholder 4"/>
           <p:cNvSpPr>
             <a:spLocks noGrp="1"/>
           </p:cNvSpPr>
@@ -318,7 +319,7 @@
       </p:sp>
       <p:sp>
         <p:nvSpPr>
-          <p:cNvPr id="2078592688" name="Footer Placeholder 5"/>
+          <p:cNvPr id="188414506" name="Footer Placeholder 5"/>
           <p:cNvSpPr>
             <a:spLocks noGrp="1"/>
           </p:cNvSpPr>
@@ -352,7 +353,7 @@
       </p:sp>
       <p:sp>
         <p:nvSpPr>
-          <p:cNvPr id="774738728" name="Slide Number Placeholder 6"/>
+          <p:cNvPr id="116204263" name="Slide Number Placeholder 6"/>
           <p:cNvSpPr>
             <a:spLocks noGrp="1"/>
           </p:cNvSpPr>
@@ -505,7 +506,7 @@
       </p:grpSpPr>
       <p:sp>
         <p:nvSpPr>
-          <p:cNvPr id="996531784" name="Slide Image Placeholder 1"/>
+          <p:cNvPr id="674105350" name="Slide Image Placeholder 1"/>
           <p:cNvSpPr>
             <a:spLocks noChangeAspect="1" noGrp="1" noRot="1"/>
           </p:cNvSpPr>
@@ -517,7 +518,7 @@
       </p:sp>
       <p:sp>
         <p:nvSpPr>
-          <p:cNvPr id="1207822963" name="Notes Placeholder 2"/>
+          <p:cNvPr id="2058601038" name="Notes Placeholder 2"/>
           <p:cNvSpPr>
             <a:spLocks noGrp="1"/>
           </p:cNvSpPr>
@@ -539,7 +540,7 @@
       </p:sp>
       <p:sp>
         <p:nvSpPr>
-          <p:cNvPr id="422526474" name="Slide Number Placeholder 3"/>
+          <p:cNvPr id="2027838660" name="Slide Number Placeholder 3"/>
           <p:cNvSpPr>
             <a:spLocks noGrp="1"/>
           </p:cNvSpPr>
@@ -590,7 +591,7 @@
       </p:grpSpPr>
       <p:sp>
         <p:nvSpPr>
-          <p:cNvPr id="1435823515" name="Slide Image Placeholder 1"/>
+          <p:cNvPr id="1239800363" name="Slide Image Placeholder 1"/>
           <p:cNvSpPr>
             <a:spLocks noChangeAspect="1" noGrp="1" noRot="1"/>
           </p:cNvSpPr>
@@ -602,7 +603,7 @@
       </p:sp>
       <p:sp>
         <p:nvSpPr>
-          <p:cNvPr id="122082874" name="Notes Placeholder 2"/>
+          <p:cNvPr id="2083532716" name="Notes Placeholder 2"/>
           <p:cNvSpPr>
             <a:spLocks noGrp="1"/>
           </p:cNvSpPr>
@@ -624,7 +625,7 @@
       </p:sp>
       <p:sp>
         <p:nvSpPr>
-          <p:cNvPr id="910054068" name="Slide Number Placeholder 3"/>
+          <p:cNvPr id="1962760289" name="Slide Number Placeholder 3"/>
           <p:cNvSpPr>
             <a:spLocks noGrp="1"/>
           </p:cNvSpPr>
@@ -675,7 +676,7 @@
       </p:grpSpPr>
       <p:sp>
         <p:nvSpPr>
-          <p:cNvPr id="440157739" name="Slide Image Placeholder 1"/>
+          <p:cNvPr id="1129161874" name="Slide Image Placeholder 1"/>
           <p:cNvSpPr>
             <a:spLocks noChangeAspect="1" noGrp="1" noRot="1"/>
           </p:cNvSpPr>
@@ -687,7 +688,7 @@
       </p:sp>
       <p:sp>
         <p:nvSpPr>
-          <p:cNvPr id="1382425080" name="Notes Placeholder 2"/>
+          <p:cNvPr id="1524598497" name="Notes Placeholder 2"/>
           <p:cNvSpPr>
             <a:spLocks noGrp="1"/>
           </p:cNvSpPr>
@@ -709,7 +710,7 @@
       </p:sp>
       <p:sp>
         <p:nvSpPr>
-          <p:cNvPr id="1358328411" name="Slide Number Placeholder 3"/>
+          <p:cNvPr id="1895298982" name="Slide Number Placeholder 3"/>
           <p:cNvSpPr>
             <a:spLocks noGrp="1"/>
           </p:cNvSpPr>
@@ -725,7 +726,7 @@
             <a:pPr>
               <a:defRPr/>
             </a:pPr>
-            <a:fld id="{0208E325-F849-A203-B3CC-E685AAE7F131}" type="slidenum">
+            <a:fld id="{F6F08F0D-7539-486C-00E3-B9F988617589}" type="slidenum">
               <a:rPr lang="en-US"/>
               <a:t/>
             </a:fld>
@@ -760,7 +761,7 @@
       </p:grpSpPr>
       <p:sp>
         <p:nvSpPr>
-          <p:cNvPr id="1978529338" name="Slide Image Placeholder 1"/>
+          <p:cNvPr id="1880140206" name="Slide Image Placeholder 1"/>
           <p:cNvSpPr>
             <a:spLocks noChangeAspect="1" noGrp="1" noRot="1"/>
           </p:cNvSpPr>
@@ -772,7 +773,7 @@
       </p:sp>
       <p:sp>
         <p:nvSpPr>
-          <p:cNvPr id="1830958618" name="Notes Placeholder 2"/>
+          <p:cNvPr id="1852563317" name="Notes Placeholder 2"/>
           <p:cNvSpPr>
             <a:spLocks noGrp="1"/>
           </p:cNvSpPr>
@@ -794,7 +795,7 @@
       </p:sp>
       <p:sp>
         <p:nvSpPr>
-          <p:cNvPr id="1625340009" name="Slide Number Placeholder 3"/>
+          <p:cNvPr id="2015389531" name="Slide Number Placeholder 3"/>
           <p:cNvSpPr>
             <a:spLocks noGrp="1"/>
           </p:cNvSpPr>
@@ -810,9 +811,9 @@
             <a:pPr>
               <a:defRPr/>
             </a:pPr>
-            <a:fld id="{F7021451-1387-4CA6-816F-3879F97B5CBC}" type="slidenum">
+            <a:fld id="{0208E325-F849-A203-B3CC-E685AAE7F131}" type="slidenum">
               <a:rPr lang="en-US"/>
-              <a:t>3</a:t>
+              <a:t/>
             </a:fld>
             <a:endParaRPr lang="en-US"/>
           </a:p>
@@ -845,7 +846,7 @@
       </p:grpSpPr>
       <p:sp>
         <p:nvSpPr>
-          <p:cNvPr id="1367301000" name="Slide Image Placeholder 1"/>
+          <p:cNvPr id="1432002875" name="Slide Image Placeholder 1"/>
           <p:cNvSpPr>
             <a:spLocks noChangeAspect="1" noGrp="1" noRot="1"/>
           </p:cNvSpPr>
@@ -857,7 +858,7 @@
       </p:sp>
       <p:sp>
         <p:nvSpPr>
-          <p:cNvPr id="2129414632" name="Notes Placeholder 2"/>
+          <p:cNvPr id="1334705840" name="Notes Placeholder 2"/>
           <p:cNvSpPr>
             <a:spLocks noGrp="1"/>
           </p:cNvSpPr>
@@ -879,7 +880,7 @@
       </p:sp>
       <p:sp>
         <p:nvSpPr>
-          <p:cNvPr id="619094009" name="Slide Number Placeholder 3"/>
+          <p:cNvPr id="1100867754" name="Slide Number Placeholder 3"/>
           <p:cNvSpPr>
             <a:spLocks noGrp="1"/>
           </p:cNvSpPr>
@@ -897,7 +898,7 @@
             </a:pPr>
             <a:fld id="{F7021451-1387-4CA6-816F-3879F97B5CBC}" type="slidenum">
               <a:rPr lang="en-US"/>
-              <a:t>4</a:t>
+              <a:t>3</a:t>
             </a:fld>
             <a:endParaRPr lang="en-US"/>
           </a:p>
@@ -930,7 +931,7 @@
       </p:grpSpPr>
       <p:sp>
         <p:nvSpPr>
-          <p:cNvPr id="1079116141" name="Slide Image Placeholder 1"/>
+          <p:cNvPr id="2001735549" name="Slide Image Placeholder 1"/>
           <p:cNvSpPr>
             <a:spLocks noChangeAspect="1" noGrp="1" noRot="1"/>
           </p:cNvSpPr>
@@ -942,7 +943,7 @@
       </p:sp>
       <p:sp>
         <p:nvSpPr>
-          <p:cNvPr id="516337436" name="Notes Placeholder 2"/>
+          <p:cNvPr id="54324828" name="Notes Placeholder 2"/>
           <p:cNvSpPr>
             <a:spLocks noGrp="1"/>
           </p:cNvSpPr>
@@ -964,7 +965,92 @@
       </p:sp>
       <p:sp>
         <p:nvSpPr>
-          <p:cNvPr id="286037378" name="Slide Number Placeholder 3"/>
+          <p:cNvPr id="1252292324" name="Slide Number Placeholder 3"/>
+          <p:cNvSpPr>
+            <a:spLocks noGrp="1"/>
+          </p:cNvSpPr>
+          <p:nvPr>
+            <p:ph type="sldNum" sz="quarter" idx="10"/>
+          </p:nvPr>
+        </p:nvSpPr>
+        <p:spPr bwMode="auto"/>
+        <p:txBody>
+          <a:bodyPr/>
+          <a:lstStyle/>
+          <a:p>
+            <a:pPr>
+              <a:defRPr/>
+            </a:pPr>
+            <a:fld id="{F7021451-1387-4CA6-816F-3879F97B5CBC}" type="slidenum">
+              <a:rPr lang="en-US"/>
+              <a:t>4</a:t>
+            </a:fld>
+            <a:endParaRPr lang="en-US"/>
+          </a:p>
+        </p:txBody>
+      </p:sp>
+    </p:spTree>
+  </p:cSld>
+  <p:clrMapOvr>
+    <a:masterClrMapping/>
+  </p:clrMapOvr>
+</p:notes>
+</file>
+
+<file path=ppt/notesSlides/notesSlide7.xml><?xml version="1.0" encoding="utf-8"?>
+<p:notes xmlns:a="http://schemas.openxmlformats.org/drawingml/2006/main" xmlns:r="http://schemas.openxmlformats.org/officeDocument/2006/relationships" xmlns:p="http://schemas.openxmlformats.org/presentationml/2006/main" xmlns:m="http://schemas.openxmlformats.org/officeDocument/2006/math" xmlns:w="http://schemas.openxmlformats.org/wordprocessingml/2006/main">
+  <p:cSld name="">
+    <p:spTree>
+      <p:nvGrpSpPr>
+        <p:cNvPr id="1" name=""/>
+        <p:cNvGrpSpPr/>
+        <p:nvPr/>
+      </p:nvGrpSpPr>
+      <p:grpSpPr bwMode="auto">
+        <a:xfrm>
+          <a:off x="0" y="0"/>
+          <a:ext cx="0" cy="0"/>
+          <a:chOff x="0" y="0"/>
+          <a:chExt cx="0" cy="0"/>
+        </a:xfrm>
+      </p:grpSpPr>
+      <p:sp>
+        <p:nvSpPr>
+          <p:cNvPr id="1928271887" name="Slide Image Placeholder 1"/>
+          <p:cNvSpPr>
+            <a:spLocks noChangeAspect="1" noGrp="1" noRot="1"/>
+          </p:cNvSpPr>
+          <p:nvPr>
+            <p:ph type="sldImg"/>
+          </p:nvPr>
+        </p:nvSpPr>
+        <p:spPr bwMode="auto"/>
+      </p:sp>
+      <p:sp>
+        <p:nvSpPr>
+          <p:cNvPr id="1336880434" name="Notes Placeholder 2"/>
+          <p:cNvSpPr>
+            <a:spLocks noGrp="1"/>
+          </p:cNvSpPr>
+          <p:nvPr>
+            <p:ph type="body" idx="1"/>
+          </p:nvPr>
+        </p:nvSpPr>
+        <p:spPr bwMode="auto"/>
+        <p:txBody>
+          <a:bodyPr/>
+          <a:lstStyle/>
+          <a:p>
+            <a:pPr>
+              <a:defRPr/>
+            </a:pPr>
+            <a:endParaRPr lang="en-US"/>
+          </a:p>
+        </p:txBody>
+      </p:sp>
+      <p:sp>
+        <p:nvSpPr>
+          <p:cNvPr id="1421387250" name="Slide Number Placeholder 3"/>
           <p:cNvSpPr>
             <a:spLocks noGrp="1"/>
           </p:cNvSpPr>
@@ -1329,7 +1415,7 @@
       </p:grpSpPr>
       <p:sp>
         <p:nvSpPr>
-          <p:cNvPr id="862000286" name="Shape 0"/>
+          <p:cNvPr id="1585185129" name="Shape 0"/>
           <p:cNvSpPr/>
           <p:nvPr/>
         </p:nvSpPr>
@@ -1354,7 +1440,7 @@
       </p:sp>
       <p:sp>
         <p:nvSpPr>
-          <p:cNvPr id="116444741" name="Shape 1"/>
+          <p:cNvPr id="1023229040" name="Shape 1"/>
           <p:cNvSpPr/>
           <p:nvPr/>
         </p:nvSpPr>
@@ -1383,7 +1469,7 @@
       </p:sp>
       <p:sp>
         <p:nvSpPr>
-          <p:cNvPr id="127521551" name="Shape 2"/>
+          <p:cNvPr id="26456648" name="Shape 2"/>
           <p:cNvSpPr/>
           <p:nvPr/>
         </p:nvSpPr>
@@ -1412,7 +1498,7 @@
       </p:sp>
       <p:sp>
         <p:nvSpPr>
-          <p:cNvPr id="1173225182" name="Shape 3"/>
+          <p:cNvPr id="1519134280" name="Shape 3"/>
           <p:cNvSpPr/>
           <p:nvPr/>
         </p:nvSpPr>
@@ -1441,7 +1527,7 @@
       </p:sp>
       <p:sp>
         <p:nvSpPr>
-          <p:cNvPr id="2018651950" name="Shape 4"/>
+          <p:cNvPr id="1689348922" name="Shape 4"/>
           <p:cNvSpPr/>
           <p:nvPr/>
         </p:nvSpPr>
@@ -1470,7 +1556,7 @@
       </p:sp>
       <p:sp>
         <p:nvSpPr>
-          <p:cNvPr id="1817504058" name="Shape 5"/>
+          <p:cNvPr id="87373052" name="Shape 5"/>
           <p:cNvSpPr/>
           <p:nvPr/>
         </p:nvSpPr>
@@ -1499,7 +1585,7 @@
       </p:sp>
       <p:sp>
         <p:nvSpPr>
-          <p:cNvPr id="1152622363" name="Text 6"/>
+          <p:cNvPr id="1885791790" name="Text 6"/>
           <p:cNvSpPr/>
           <p:nvPr/>
         </p:nvSpPr>
@@ -1539,7 +1625,7 @@
       </p:sp>
       <p:sp>
         <p:nvSpPr>
-          <p:cNvPr id="1766386390" name="Text 7"/>
+          <p:cNvPr id="73157080" name="Text 7"/>
           <p:cNvSpPr/>
           <p:nvPr/>
         </p:nvSpPr>
@@ -1579,7 +1665,7 @@
       </p:sp>
       <p:sp>
         <p:nvSpPr>
-          <p:cNvPr id="2071072652" name="Shape 8"/>
+          <p:cNvPr id="149352817" name="Shape 8"/>
           <p:cNvSpPr/>
           <p:nvPr/>
         </p:nvSpPr>
@@ -1604,7 +1690,7 @@
       </p:sp>
       <p:sp>
         <p:nvSpPr>
-          <p:cNvPr id="1320957384" name="Text 9"/>
+          <p:cNvPr id="604663554" name="Text 9"/>
           <p:cNvSpPr/>
           <p:nvPr/>
         </p:nvSpPr>
@@ -1684,7 +1770,7 @@
       </p:grpSpPr>
       <p:sp>
         <p:nvSpPr>
-          <p:cNvPr id="954146544" name="Shape 0"/>
+          <p:cNvPr id="197802393" name="Shape 0"/>
           <p:cNvSpPr/>
           <p:nvPr/>
         </p:nvSpPr>
@@ -1709,7 +1795,7 @@
       </p:sp>
       <p:sp>
         <p:nvSpPr>
-          <p:cNvPr id="2090543943" name="Text 1"/>
+          <p:cNvPr id="709022521" name="Text 1"/>
           <p:cNvSpPr/>
           <p:nvPr/>
         </p:nvSpPr>
@@ -1741,7 +1827,7 @@
                 <a:ea typeface="Calibri"/>
                 <a:cs typeface="Calibri"/>
               </a:rPr>
-              <a:t>Project Idea</a:t>
+              <a:t>The Team</a:t>
             </a:r>
             <a:endParaRPr lang="en-US" sz="2200"/>
           </a:p>
@@ -1749,506 +1835,33 @@
       </p:sp>
       <p:sp>
         <p:nvSpPr>
-          <p:cNvPr id="584057493" name="Shape 2"/>
-          <p:cNvSpPr/>
-          <p:nvPr/>
-        </p:nvSpPr>
-        <p:spPr bwMode="auto">
-          <a:xfrm flipH="0" flipV="0">
-            <a:off x="206302" y="995774"/>
-            <a:ext cx="8731394" cy="770700"/>
-          </a:xfrm>
-          <a:prstGeom prst="flowChartAlternateProcess">
-            <a:avLst/>
-          </a:prstGeom>
-          <a:solidFill>
-            <a:srgbClr val="FFFFFF"/>
-          </a:solidFill>
-          <a:ln w="12700">
-            <a:solidFill>
-              <a:srgbClr val="CBD5E1"/>
-            </a:solidFill>
-            <a:prstDash val="solid"/>
-          </a:ln>
-          <a:effectLst>
-            <a:outerShdw blurRad="101600" dist="25400" dir="8100000" sx="100000" sy="100000" kx="0" ky="0" algn="bl" rotWithShape="0">
-              <a:srgbClr val="000000">
-                <a:alpha val="10000"/>
-              </a:srgbClr>
-            </a:outerShdw>
-          </a:effectLst>
-        </p:spPr>
-      </p:sp>
-      <p:sp>
-        <p:nvSpPr>
-          <p:cNvPr id="2067347522" name="Shape 2"/>
-          <p:cNvSpPr/>
-          <p:nvPr/>
-        </p:nvSpPr>
-        <p:spPr bwMode="auto">
-          <a:xfrm flipH="0" flipV="0">
-            <a:off x="206302" y="1901717"/>
-            <a:ext cx="8731394" cy="770700"/>
-          </a:xfrm>
-          <a:prstGeom prst="flowChartAlternateProcess">
-            <a:avLst/>
-          </a:prstGeom>
-          <a:solidFill>
-            <a:srgbClr val="FFFFFF"/>
-          </a:solidFill>
-          <a:ln w="12700">
-            <a:solidFill>
-              <a:srgbClr val="CBD5E1"/>
-            </a:solidFill>
-            <a:prstDash val="solid"/>
-          </a:ln>
-          <a:effectLst>
-            <a:outerShdw blurRad="101600" dist="25400" dir="8100000" sx="100000" sy="100000" kx="0" ky="0" algn="bl" rotWithShape="0">
-              <a:srgbClr val="000000">
-                <a:alpha val="10000"/>
-              </a:srgbClr>
-            </a:outerShdw>
-          </a:effectLst>
-        </p:spPr>
-      </p:sp>
-      <p:sp>
-        <p:nvSpPr>
-          <p:cNvPr id="714190439" name="Shape 2"/>
-          <p:cNvSpPr/>
-          <p:nvPr/>
-        </p:nvSpPr>
-        <p:spPr bwMode="auto">
-          <a:xfrm flipH="0" flipV="0">
-            <a:off x="206302" y="2807661"/>
-            <a:ext cx="8731394" cy="770700"/>
-          </a:xfrm>
-          <a:prstGeom prst="flowChartAlternateProcess">
-            <a:avLst/>
-          </a:prstGeom>
-          <a:solidFill>
-            <a:srgbClr val="FFFFFF"/>
-          </a:solidFill>
-          <a:ln w="12700">
-            <a:solidFill>
-              <a:srgbClr val="CBD5E1"/>
-            </a:solidFill>
-            <a:prstDash val="solid"/>
-          </a:ln>
-          <a:effectLst>
-            <a:outerShdw blurRad="101600" dist="25400" dir="8100000" sx="100000" sy="100000" kx="0" ky="0" algn="bl" rotWithShape="0">
-              <a:srgbClr val="000000">
-                <a:alpha val="10000"/>
-              </a:srgbClr>
-            </a:outerShdw>
-          </a:effectLst>
-        </p:spPr>
-      </p:sp>
-      <p:sp>
-        <p:nvSpPr>
-          <p:cNvPr id="926168423" name="Shape 2"/>
-          <p:cNvSpPr/>
-          <p:nvPr/>
-        </p:nvSpPr>
-        <p:spPr bwMode="auto">
-          <a:xfrm flipH="0" flipV="0">
-            <a:off x="206302" y="3713604"/>
-            <a:ext cx="8731394" cy="770700"/>
-          </a:xfrm>
-          <a:prstGeom prst="flowChartAlternateProcess">
-            <a:avLst/>
-          </a:prstGeom>
-          <a:solidFill>
-            <a:srgbClr val="FFFFFF"/>
-          </a:solidFill>
-          <a:ln w="12700">
-            <a:solidFill>
-              <a:srgbClr val="CBD5E1"/>
-            </a:solidFill>
-            <a:prstDash val="solid"/>
-          </a:ln>
-          <a:effectLst>
-            <a:outerShdw blurRad="101600" dist="25400" dir="8100000" sx="100000" sy="100000" kx="0" ky="0" algn="bl" rotWithShape="0">
-              <a:srgbClr val="000000">
-                <a:alpha val="10000"/>
-              </a:srgbClr>
-            </a:outerShdw>
-          </a:effectLst>
-        </p:spPr>
-      </p:sp>
-      <p:sp modelId="{A8BC8CD6-8738-41EA-9E71-3CD4C9AF2582}">
-        <p:nvSpPr>
-          <p:cNvPr id="748801556" name=""/>
-          <p:cNvSpPr/>
-          <p:nvPr/>
-        </p:nvSpPr>
-        <p:spPr bwMode="auto">
-          <a:xfrm>
-            <a:off x="345747" y="1039316"/>
-            <a:ext cx="683613" cy="683613"/>
+          <p:cNvPr id="2015799492" name=""/>
+          <p:cNvSpPr txBox="1"/>
+          <p:nvPr/>
+        </p:nvSpPr>
+        <p:spPr bwMode="auto">
+          <a:xfrm rot="0" flipH="0" flipV="0">
+            <a:off x="3294519" y="2388689"/>
+            <a:ext cx="2554961" cy="366119"/>
           </a:xfrm>
           <a:prstGeom prst="rect">
             <a:avLst/>
           </a:prstGeom>
-          <a:blipFill rotWithShape="1">
-            <a:blip r:embed="rId3"/>
-            <a:stretch/>
-          </a:blipFill>
-          <a:ln w="19050" cap="flat" cmpd="sng" algn="ctr">
-            <a:solidFill>
-              <a:schemeClr val="lt1">
-                <a:hueOff val="0"/>
-                <a:satOff val="0"/>
-                <a:lumOff val="0"/>
-                <a:alphaOff val="0"/>
-              </a:schemeClr>
-            </a:solidFill>
-            <a:prstDash val="solid"/>
-            <a:miter lim="800000"/>
-          </a:ln>
-          <a:effectLst/>
-        </p:spPr>
-        <p:style>
-          <a:lnRef idx="2">
-            <a:srgbClr val="000000"/>
-          </a:lnRef>
-          <a:fillRef idx="1">
-            <a:srgbClr val="000000"/>
-          </a:fillRef>
-          <a:effectRef idx="0">
-            <a:srgbClr val="000000"/>
-          </a:effectRef>
-          <a:fontRef idx="minor">
-            <a:schemeClr val="lt1"/>
-          </a:fontRef>
-        </p:style>
-      </p:sp>
-      <p:sp modelId="{B63312C8-A8E7-471C-BDC7-E288FC589C93}">
-        <p:nvSpPr>
-          <p:cNvPr id="1019157395" name=""/>
-          <p:cNvSpPr/>
-          <p:nvPr/>
-        </p:nvSpPr>
-        <p:spPr bwMode="auto">
-          <a:xfrm>
-            <a:off x="345747" y="1945261"/>
-            <a:ext cx="683613" cy="683613"/>
-          </a:xfrm>
-          <a:prstGeom prst="rect">
-            <a:avLst/>
-          </a:prstGeom>
-          <a:blipFill rotWithShape="1">
-            <a:blip r:embed="rId4"/>
-            <a:stretch/>
-          </a:blipFill>
-          <a:ln w="19050" cap="flat" cmpd="sng" algn="ctr">
-            <a:solidFill>
-              <a:schemeClr val="lt1">
-                <a:hueOff val="0"/>
-                <a:satOff val="0"/>
-                <a:lumOff val="0"/>
-                <a:alphaOff val="0"/>
-              </a:schemeClr>
-            </a:solidFill>
-            <a:prstDash val="solid"/>
-            <a:miter lim="800000"/>
-          </a:ln>
-          <a:effectLst/>
-        </p:spPr>
-        <p:style>
-          <a:lnRef idx="2">
-            <a:srgbClr val="000000"/>
-          </a:lnRef>
-          <a:fillRef idx="1">
-            <a:srgbClr val="000000"/>
-          </a:fillRef>
-          <a:effectRef idx="0">
-            <a:srgbClr val="000000"/>
-          </a:effectRef>
-          <a:fontRef idx="minor">
-            <a:schemeClr val="lt1"/>
-          </a:fontRef>
-        </p:style>
-      </p:sp>
-      <p:sp modelId="{CA7E8371-02DB-4E6B-BDD4-4E6725844AB0}">
-        <p:nvSpPr>
-          <p:cNvPr id="304136446" name=""/>
-          <p:cNvSpPr/>
-          <p:nvPr/>
-        </p:nvSpPr>
-        <p:spPr bwMode="auto">
-          <a:xfrm>
-            <a:off x="345747" y="2851204"/>
-            <a:ext cx="683613" cy="683613"/>
-          </a:xfrm>
-          <a:prstGeom prst="rect">
-            <a:avLst/>
-          </a:prstGeom>
-          <a:blipFill rotWithShape="1">
-            <a:blip r:embed="rId5"/>
-            <a:stretch/>
-          </a:blipFill>
-          <a:ln w="19050" cap="flat" cmpd="sng" algn="ctr">
-            <a:solidFill>
-              <a:schemeClr val="lt1">
-                <a:hueOff val="0"/>
-                <a:satOff val="0"/>
-                <a:lumOff val="0"/>
-                <a:alphaOff val="0"/>
-              </a:schemeClr>
-            </a:solidFill>
-            <a:prstDash val="solid"/>
-            <a:miter lim="800000"/>
-          </a:ln>
-          <a:effectLst/>
-        </p:spPr>
-        <p:style>
-          <a:lnRef idx="2">
-            <a:srgbClr val="000000"/>
-          </a:lnRef>
-          <a:fillRef idx="1">
-            <a:srgbClr val="000000"/>
-          </a:fillRef>
-          <a:effectRef idx="0">
-            <a:srgbClr val="000000"/>
-          </a:effectRef>
-          <a:fontRef idx="minor">
-            <a:schemeClr val="lt1"/>
-          </a:fontRef>
-        </p:style>
-      </p:sp>
-      <p:sp modelId="{CA7E8371-02DB-4E6B-BDD4-4E6725844AB0}">
-        <p:nvSpPr>
-          <p:cNvPr id="1870385085" name=""/>
-          <p:cNvSpPr/>
-          <p:nvPr/>
-        </p:nvSpPr>
-        <p:spPr bwMode="auto">
-          <a:xfrm>
-            <a:off x="345747" y="3757147"/>
-            <a:ext cx="683613" cy="683613"/>
-          </a:xfrm>
-          <a:prstGeom prst="rect">
-            <a:avLst/>
-          </a:prstGeom>
-          <a:blipFill rotWithShape="1">
-            <a:blip r:embed="rId6"/>
-            <a:stretch/>
-          </a:blipFill>
-          <a:ln w="19050" cap="flat" cmpd="sng" algn="ctr">
-            <a:noFill/>
-            <a:prstDash val="solid"/>
-            <a:miter lim="800000"/>
-          </a:ln>
-          <a:effectLst/>
-        </p:spPr>
-        <p:style>
-          <a:lnRef idx="2">
-            <a:srgbClr val="000000"/>
-          </a:lnRef>
-          <a:fillRef idx="1">
-            <a:srgbClr val="000000"/>
-          </a:fillRef>
-          <a:effectRef idx="0">
-            <a:srgbClr val="000000"/>
-          </a:effectRef>
-          <a:fontRef idx="minor">
-            <a:schemeClr val="lt1"/>
-          </a:fontRef>
-        </p:style>
+          <a:noFill/>
+        </p:spPr>
         <p:txBody>
-          <a:bodyPr anchor="ctr"/>
-          <a:p>
-            <a:pPr algn="ctr">
-              <a:defRPr/>
-            </a:pPr>
-            <a:endParaRPr/>
-          </a:p>
-        </p:txBody>
-      </p:sp>
-      <p:sp>
-        <p:nvSpPr>
-          <p:cNvPr id="602153185" name=""/>
-          <p:cNvSpPr txBox="1"/>
-          <p:nvPr/>
-        </p:nvSpPr>
-        <p:spPr bwMode="auto">
-          <a:xfrm rot="0" flipH="0" flipV="0">
-            <a:off x="1029361" y="1198244"/>
-            <a:ext cx="7567077" cy="366119"/>
-          </a:xfrm>
-          <a:prstGeom prst="rect">
-            <a:avLst/>
-          </a:prstGeom>
-          <a:noFill/>
-        </p:spPr>
-        <p:txBody>
-          <a:bodyPr vertOverflow="overflow" horzOverflow="overflow" vert="horz" wrap="square" lIns="91440" tIns="45720" rIns="91440" bIns="45720" numCol="1" spcCol="0" rtlCol="0" fromWordArt="0" anchor="t" anchorCtr="0" forceAA="0" upright="0" compatLnSpc="0">
+          <a:bodyPr vertOverflow="overflow" horzOverflow="overflow" vert="horz" wrap="none" lIns="91440" tIns="45720" rIns="91440" bIns="45720" numCol="1" spcCol="0" rtlCol="0" fromWordArt="0" anchor="t" anchorCtr="0" forceAA="0" upright="0" compatLnSpc="0">
             <a:spAutoFit/>
           </a:bodyPr>
           <a:p>
-            <a:pPr marL="0" lvl="0" indent="0" algn="l" defTabSz="1111249">
-              <a:lnSpc>
-                <a:spcPct val="100000"/>
-              </a:lnSpc>
-              <a:spcBef>
-                <a:spcPts val="0"/>
-              </a:spcBef>
-              <a:spcAft>
-                <a:spcPts val="0"/>
-              </a:spcAft>
-              <a:buNone/>
+            <a:pPr>
               <a:defRPr/>
             </a:pPr>
             <a:r>
-              <a:rPr lang="de-DE" sz="1800" b="0" i="0" u="none" strike="noStrike" cap="none" spc="0">
-                <a:solidFill>
-                  <a:schemeClr val="tx1"/>
-                </a:solidFill>
-                <a:latin typeface="+mn-lt"/>
-                <a:ea typeface="+mn-ea"/>
-                <a:cs typeface="+mn-cs"/>
-              </a:rPr>
-              <a:t>Task Management Web Service</a:t>
+              <a:rPr lang="de-DE"/>
+              <a:t>Add Picture of Team here</a:t>
             </a:r>
-            <a:endParaRPr sz="1800"/>
-          </a:p>
-        </p:txBody>
-      </p:sp>
-      <p:sp>
-        <p:nvSpPr>
-          <p:cNvPr id="243456283" name=""/>
-          <p:cNvSpPr txBox="1"/>
-          <p:nvPr/>
-        </p:nvSpPr>
-        <p:spPr bwMode="auto">
-          <a:xfrm rot="0" flipH="0" flipV="0">
-            <a:off x="1029361" y="2104008"/>
-            <a:ext cx="7567077" cy="366119"/>
-          </a:xfrm>
-          <a:prstGeom prst="rect">
-            <a:avLst/>
-          </a:prstGeom>
-          <a:noFill/>
-        </p:spPr>
-        <p:txBody>
-          <a:bodyPr vertOverflow="overflow" horzOverflow="overflow" vert="horz" wrap="square" lIns="91440" tIns="45720" rIns="91440" bIns="45720" numCol="1" spcCol="0" rtlCol="0" fromWordArt="0" anchor="t" anchorCtr="0" forceAA="0" upright="0" compatLnSpc="0">
-            <a:spAutoFit/>
-          </a:bodyPr>
-          <a:p>
-            <a:pPr marL="0" lvl="0" indent="0" algn="l" defTabSz="1111249">
-              <a:lnSpc>
-                <a:spcPct val="100000"/>
-              </a:lnSpc>
-              <a:spcBef>
-                <a:spcPts val="0"/>
-              </a:spcBef>
-              <a:spcAft>
-                <a:spcPts val="0"/>
-              </a:spcAft>
-              <a:buNone/>
-              <a:defRPr/>
-            </a:pPr>
-            <a:r>
-              <a:rPr lang="de-DE" sz="1800" b="0" i="0" u="none" strike="noStrike" cap="none" spc="0">
-                <a:solidFill>
-                  <a:schemeClr val="tx1"/>
-                </a:solidFill>
-                <a:latin typeface="+mn-lt"/>
-                <a:ea typeface="+mn-ea"/>
-                <a:cs typeface="+mn-cs"/>
-              </a:rPr>
-              <a:t>Simple, scalable, role-based system</a:t>
-            </a:r>
-            <a:endParaRPr sz="1800"/>
-          </a:p>
-        </p:txBody>
-      </p:sp>
-      <p:sp>
-        <p:nvSpPr>
-          <p:cNvPr id="1249558843" name=""/>
-          <p:cNvSpPr txBox="1"/>
-          <p:nvPr/>
-        </p:nvSpPr>
-        <p:spPr bwMode="auto">
-          <a:xfrm rot="0" flipH="0" flipV="0">
-            <a:off x="1029361" y="3009951"/>
-            <a:ext cx="7567077" cy="366119"/>
-          </a:xfrm>
-          <a:prstGeom prst="rect">
-            <a:avLst/>
-          </a:prstGeom>
-          <a:noFill/>
-        </p:spPr>
-        <p:txBody>
-          <a:bodyPr vertOverflow="overflow" horzOverflow="overflow" vert="horz" wrap="square" lIns="91440" tIns="45720" rIns="91440" bIns="45720" numCol="1" spcCol="0" rtlCol="0" fromWordArt="0" anchor="t" anchorCtr="0" forceAA="0" upright="0" compatLnSpc="0">
-            <a:spAutoFit/>
-          </a:bodyPr>
-          <a:p>
-            <a:pPr marL="0" lvl="0" indent="0" algn="l" defTabSz="1111249">
-              <a:lnSpc>
-                <a:spcPct val="100000"/>
-              </a:lnSpc>
-              <a:spcBef>
-                <a:spcPts val="0"/>
-              </a:spcBef>
-              <a:spcAft>
-                <a:spcPts val="0"/>
-              </a:spcAft>
-              <a:buNone/>
-              <a:defRPr/>
-            </a:pPr>
-            <a:r>
-              <a:rPr lang="de-DE" sz="1800" b="0" i="0" u="none" strike="noStrike" cap="none" spc="0">
-                <a:solidFill>
-                  <a:schemeClr val="tx1"/>
-                </a:solidFill>
-                <a:latin typeface="+mn-lt"/>
-                <a:ea typeface="+mn-ea"/>
-                <a:cs typeface="+mn-cs"/>
-              </a:rPr>
-              <a:t>Designed for teams &amp; project collaboration</a:t>
-            </a:r>
-            <a:endParaRPr sz="1800"/>
-          </a:p>
-        </p:txBody>
-      </p:sp>
-      <p:sp>
-        <p:nvSpPr>
-          <p:cNvPr id="1919790884" name=""/>
-          <p:cNvSpPr txBox="1"/>
-          <p:nvPr/>
-        </p:nvSpPr>
-        <p:spPr bwMode="auto">
-          <a:xfrm rot="0" flipH="0" flipV="0">
-            <a:off x="1028282" y="3915894"/>
-            <a:ext cx="7568876" cy="366119"/>
-          </a:xfrm>
-          <a:prstGeom prst="rect">
-            <a:avLst/>
-          </a:prstGeom>
-          <a:noFill/>
-        </p:spPr>
-        <p:txBody>
-          <a:bodyPr vertOverflow="overflow" horzOverflow="overflow" vert="horz" wrap="square" lIns="91440" tIns="45720" rIns="91440" bIns="45720" numCol="1" spcCol="0" rtlCol="0" fromWordArt="0" anchor="t" anchorCtr="0" forceAA="0" upright="0" compatLnSpc="0">
-            <a:spAutoFit/>
-          </a:bodyPr>
-          <a:p>
-            <a:pPr marL="0" indent="0" algn="l">
-              <a:buNone/>
-              <a:defRPr/>
-            </a:pPr>
-            <a:r>
-              <a:rPr lang="de-DE">
-                <a:solidFill>
-                  <a:srgbClr val="0F172A"/>
-                </a:solidFill>
-                <a:latin typeface="Calibri"/>
-                <a:ea typeface="Calibri"/>
-                <a:cs typeface="Calibri"/>
-              </a:rPr>
-              <a:t>AI Assistant for task organization</a:t>
-            </a:r>
-            <a:endParaRPr lang="en-US" sz="1000"/>
+            <a:endParaRPr/>
           </a:p>
         </p:txBody>
       </p:sp>
@@ -2294,7 +1907,7 @@
       </p:grpSpPr>
       <p:sp>
         <p:nvSpPr>
-          <p:cNvPr id="670078398" name="Shape 0"/>
+          <p:cNvPr id="11413654" name="Shape 0"/>
           <p:cNvSpPr/>
           <p:nvPr/>
         </p:nvSpPr>
@@ -2319,7 +1932,617 @@
       </p:sp>
       <p:sp>
         <p:nvSpPr>
-          <p:cNvPr id="2013971289" name="Text 1"/>
+          <p:cNvPr id="701849693" name="Text 1"/>
+          <p:cNvSpPr/>
+          <p:nvPr/>
+        </p:nvSpPr>
+        <p:spPr bwMode="auto">
+          <a:xfrm>
+            <a:off x="365760" y="0"/>
+            <a:ext cx="8229600" cy="685800"/>
+          </a:xfrm>
+          <a:prstGeom prst="rect">
+            <a:avLst/>
+          </a:prstGeom>
+          <a:noFill/>
+          <a:ln/>
+        </p:spPr>
+        <p:txBody>
+          <a:bodyPr wrap="square" lIns="0" tIns="0" rIns="0" bIns="0" rtlCol="0" anchor="ctr"/>
+          <a:lstStyle/>
+          <a:p>
+            <a:pPr marL="0" indent="0">
+              <a:buNone/>
+              <a:defRPr/>
+            </a:pPr>
+            <a:r>
+              <a:rPr lang="de-DE" sz="2200" b="1">
+                <a:solidFill>
+                  <a:srgbClr val="FFFFFF"/>
+                </a:solidFill>
+                <a:latin typeface="Calibri"/>
+                <a:ea typeface="Calibri"/>
+                <a:cs typeface="Calibri"/>
+              </a:rPr>
+              <a:t>Project Idea</a:t>
+            </a:r>
+            <a:endParaRPr lang="en-US" sz="2200"/>
+          </a:p>
+        </p:txBody>
+      </p:sp>
+      <p:sp>
+        <p:nvSpPr>
+          <p:cNvPr id="1376518645" name="Shape 2"/>
+          <p:cNvSpPr/>
+          <p:nvPr/>
+        </p:nvSpPr>
+        <p:spPr bwMode="auto">
+          <a:xfrm flipH="0" flipV="0">
+            <a:off x="206301" y="995773"/>
+            <a:ext cx="8731393" cy="770699"/>
+          </a:xfrm>
+          <a:prstGeom prst="flowChartAlternateProcess">
+            <a:avLst/>
+          </a:prstGeom>
+          <a:solidFill>
+            <a:srgbClr val="FFFFFF"/>
+          </a:solidFill>
+          <a:ln w="12700">
+            <a:solidFill>
+              <a:srgbClr val="CBD5E1"/>
+            </a:solidFill>
+            <a:prstDash val="solid"/>
+          </a:ln>
+          <a:effectLst>
+            <a:outerShdw blurRad="101600" dist="25400" dir="8100000" sx="100000" sy="100000" kx="0" ky="0" algn="bl" rotWithShape="0">
+              <a:srgbClr val="000000">
+                <a:alpha val="10000"/>
+              </a:srgbClr>
+            </a:outerShdw>
+          </a:effectLst>
+        </p:spPr>
+      </p:sp>
+      <p:sp>
+        <p:nvSpPr>
+          <p:cNvPr id="1736576367" name="Shape 2"/>
+          <p:cNvSpPr/>
+          <p:nvPr/>
+        </p:nvSpPr>
+        <p:spPr bwMode="auto">
+          <a:xfrm flipH="0" flipV="0">
+            <a:off x="206301" y="1901716"/>
+            <a:ext cx="8731393" cy="770699"/>
+          </a:xfrm>
+          <a:prstGeom prst="flowChartAlternateProcess">
+            <a:avLst/>
+          </a:prstGeom>
+          <a:solidFill>
+            <a:srgbClr val="FFFFFF"/>
+          </a:solidFill>
+          <a:ln w="12700">
+            <a:solidFill>
+              <a:srgbClr val="CBD5E1"/>
+            </a:solidFill>
+            <a:prstDash val="solid"/>
+          </a:ln>
+          <a:effectLst>
+            <a:outerShdw blurRad="101600" dist="25400" dir="8100000" sx="100000" sy="100000" kx="0" ky="0" algn="bl" rotWithShape="0">
+              <a:srgbClr val="000000">
+                <a:alpha val="10000"/>
+              </a:srgbClr>
+            </a:outerShdw>
+          </a:effectLst>
+        </p:spPr>
+      </p:sp>
+      <p:sp>
+        <p:nvSpPr>
+          <p:cNvPr id="419068424" name="Shape 2"/>
+          <p:cNvSpPr/>
+          <p:nvPr/>
+        </p:nvSpPr>
+        <p:spPr bwMode="auto">
+          <a:xfrm flipH="0" flipV="0">
+            <a:off x="206301" y="2807660"/>
+            <a:ext cx="8731393" cy="770699"/>
+          </a:xfrm>
+          <a:prstGeom prst="flowChartAlternateProcess">
+            <a:avLst/>
+          </a:prstGeom>
+          <a:solidFill>
+            <a:srgbClr val="FFFFFF"/>
+          </a:solidFill>
+          <a:ln w="12700">
+            <a:solidFill>
+              <a:srgbClr val="CBD5E1"/>
+            </a:solidFill>
+            <a:prstDash val="solid"/>
+          </a:ln>
+          <a:effectLst>
+            <a:outerShdw blurRad="101600" dist="25400" dir="8100000" sx="100000" sy="100000" kx="0" ky="0" algn="bl" rotWithShape="0">
+              <a:srgbClr val="000000">
+                <a:alpha val="10000"/>
+              </a:srgbClr>
+            </a:outerShdw>
+          </a:effectLst>
+        </p:spPr>
+      </p:sp>
+      <p:sp>
+        <p:nvSpPr>
+          <p:cNvPr id="406374053" name="Shape 2"/>
+          <p:cNvSpPr/>
+          <p:nvPr/>
+        </p:nvSpPr>
+        <p:spPr bwMode="auto">
+          <a:xfrm flipH="0" flipV="0">
+            <a:off x="206301" y="3713603"/>
+            <a:ext cx="8731393" cy="770699"/>
+          </a:xfrm>
+          <a:prstGeom prst="flowChartAlternateProcess">
+            <a:avLst/>
+          </a:prstGeom>
+          <a:solidFill>
+            <a:srgbClr val="FFFFFF"/>
+          </a:solidFill>
+          <a:ln w="12700">
+            <a:solidFill>
+              <a:srgbClr val="CBD5E1"/>
+            </a:solidFill>
+            <a:prstDash val="solid"/>
+          </a:ln>
+          <a:effectLst>
+            <a:outerShdw blurRad="101600" dist="25400" dir="8100000" sx="100000" sy="100000" kx="0" ky="0" algn="bl" rotWithShape="0">
+              <a:srgbClr val="000000">
+                <a:alpha val="10000"/>
+              </a:srgbClr>
+            </a:outerShdw>
+          </a:effectLst>
+        </p:spPr>
+      </p:sp>
+      <p:sp modelId="{A8BC8CD6-8738-41EA-9E71-3CD4C9AF2582}">
+        <p:nvSpPr>
+          <p:cNvPr id="1983877742" name=""/>
+          <p:cNvSpPr/>
+          <p:nvPr/>
+        </p:nvSpPr>
+        <p:spPr bwMode="auto">
+          <a:xfrm>
+            <a:off x="345746" y="1039316"/>
+            <a:ext cx="683612" cy="683612"/>
+          </a:xfrm>
+          <a:prstGeom prst="rect">
+            <a:avLst/>
+          </a:prstGeom>
+          <a:blipFill rotWithShape="1">
+            <a:blip r:embed="rId3"/>
+            <a:stretch/>
+          </a:blipFill>
+          <a:ln w="19050" cap="flat" cmpd="sng" algn="ctr">
+            <a:solidFill>
+              <a:schemeClr val="lt1">
+                <a:hueOff val="0"/>
+                <a:satOff val="0"/>
+                <a:lumOff val="0"/>
+                <a:alphaOff val="0"/>
+              </a:schemeClr>
+            </a:solidFill>
+            <a:prstDash val="solid"/>
+            <a:miter lim="800000"/>
+          </a:ln>
+          <a:effectLst/>
+        </p:spPr>
+        <p:style>
+          <a:lnRef idx="2">
+            <a:srgbClr val="000000"/>
+          </a:lnRef>
+          <a:fillRef idx="1">
+            <a:srgbClr val="000000"/>
+          </a:fillRef>
+          <a:effectRef idx="0">
+            <a:srgbClr val="000000"/>
+          </a:effectRef>
+          <a:fontRef idx="minor">
+            <a:schemeClr val="lt1"/>
+          </a:fontRef>
+        </p:style>
+      </p:sp>
+      <p:sp modelId="{B63312C8-A8E7-471C-BDC7-E288FC589C93}">
+        <p:nvSpPr>
+          <p:cNvPr id="56121892" name=""/>
+          <p:cNvSpPr/>
+          <p:nvPr/>
+        </p:nvSpPr>
+        <p:spPr bwMode="auto">
+          <a:xfrm>
+            <a:off x="345746" y="1945260"/>
+            <a:ext cx="683612" cy="683612"/>
+          </a:xfrm>
+          <a:prstGeom prst="rect">
+            <a:avLst/>
+          </a:prstGeom>
+          <a:blipFill rotWithShape="1">
+            <a:blip r:embed="rId4"/>
+            <a:stretch/>
+          </a:blipFill>
+          <a:ln w="19050" cap="flat" cmpd="sng" algn="ctr">
+            <a:solidFill>
+              <a:schemeClr val="lt1">
+                <a:hueOff val="0"/>
+                <a:satOff val="0"/>
+                <a:lumOff val="0"/>
+                <a:alphaOff val="0"/>
+              </a:schemeClr>
+            </a:solidFill>
+            <a:prstDash val="solid"/>
+            <a:miter lim="800000"/>
+          </a:ln>
+          <a:effectLst/>
+        </p:spPr>
+        <p:style>
+          <a:lnRef idx="2">
+            <a:srgbClr val="000000"/>
+          </a:lnRef>
+          <a:fillRef idx="1">
+            <a:srgbClr val="000000"/>
+          </a:fillRef>
+          <a:effectRef idx="0">
+            <a:srgbClr val="000000"/>
+          </a:effectRef>
+          <a:fontRef idx="minor">
+            <a:schemeClr val="lt1"/>
+          </a:fontRef>
+        </p:style>
+      </p:sp>
+      <p:sp modelId="{CA7E8371-02DB-4E6B-BDD4-4E6725844AB0}">
+        <p:nvSpPr>
+          <p:cNvPr id="1228927024" name=""/>
+          <p:cNvSpPr/>
+          <p:nvPr/>
+        </p:nvSpPr>
+        <p:spPr bwMode="auto">
+          <a:xfrm>
+            <a:off x="345746" y="2851203"/>
+            <a:ext cx="683612" cy="683612"/>
+          </a:xfrm>
+          <a:prstGeom prst="rect">
+            <a:avLst/>
+          </a:prstGeom>
+          <a:blipFill rotWithShape="1">
+            <a:blip r:embed="rId5"/>
+            <a:stretch/>
+          </a:blipFill>
+          <a:ln w="19050" cap="flat" cmpd="sng" algn="ctr">
+            <a:solidFill>
+              <a:schemeClr val="lt1">
+                <a:hueOff val="0"/>
+                <a:satOff val="0"/>
+                <a:lumOff val="0"/>
+                <a:alphaOff val="0"/>
+              </a:schemeClr>
+            </a:solidFill>
+            <a:prstDash val="solid"/>
+            <a:miter lim="800000"/>
+          </a:ln>
+          <a:effectLst/>
+        </p:spPr>
+        <p:style>
+          <a:lnRef idx="2">
+            <a:srgbClr val="000000"/>
+          </a:lnRef>
+          <a:fillRef idx="1">
+            <a:srgbClr val="000000"/>
+          </a:fillRef>
+          <a:effectRef idx="0">
+            <a:srgbClr val="000000"/>
+          </a:effectRef>
+          <a:fontRef idx="minor">
+            <a:schemeClr val="lt1"/>
+          </a:fontRef>
+        </p:style>
+      </p:sp>
+      <p:sp modelId="{CA7E8371-02DB-4E6B-BDD4-4E6725844AB0}">
+        <p:nvSpPr>
+          <p:cNvPr id="432296538" name=""/>
+          <p:cNvSpPr/>
+          <p:nvPr/>
+        </p:nvSpPr>
+        <p:spPr bwMode="auto">
+          <a:xfrm>
+            <a:off x="345746" y="3757146"/>
+            <a:ext cx="683612" cy="683612"/>
+          </a:xfrm>
+          <a:prstGeom prst="rect">
+            <a:avLst/>
+          </a:prstGeom>
+          <a:blipFill rotWithShape="1">
+            <a:blip r:embed="rId6"/>
+            <a:stretch/>
+          </a:blipFill>
+          <a:ln w="19050" cap="flat" cmpd="sng" algn="ctr">
+            <a:noFill/>
+            <a:prstDash val="solid"/>
+            <a:miter lim="800000"/>
+          </a:ln>
+          <a:effectLst/>
+        </p:spPr>
+        <p:style>
+          <a:lnRef idx="2">
+            <a:srgbClr val="000000"/>
+          </a:lnRef>
+          <a:fillRef idx="1">
+            <a:srgbClr val="000000"/>
+          </a:fillRef>
+          <a:effectRef idx="0">
+            <a:srgbClr val="000000"/>
+          </a:effectRef>
+          <a:fontRef idx="minor">
+            <a:schemeClr val="lt1"/>
+          </a:fontRef>
+        </p:style>
+        <p:txBody>
+          <a:bodyPr anchor="ctr"/>
+          <a:p>
+            <a:pPr algn="ctr">
+              <a:defRPr/>
+            </a:pPr>
+            <a:endParaRPr/>
+          </a:p>
+        </p:txBody>
+      </p:sp>
+      <p:sp>
+        <p:nvSpPr>
+          <p:cNvPr id="1428342454" name=""/>
+          <p:cNvSpPr txBox="1"/>
+          <p:nvPr/>
+        </p:nvSpPr>
+        <p:spPr bwMode="auto">
+          <a:xfrm rot="0" flipH="0" flipV="0">
+            <a:off x="1029360" y="1198243"/>
+            <a:ext cx="7567076" cy="366118"/>
+          </a:xfrm>
+          <a:prstGeom prst="rect">
+            <a:avLst/>
+          </a:prstGeom>
+          <a:noFill/>
+        </p:spPr>
+        <p:txBody>
+          <a:bodyPr vertOverflow="overflow" horzOverflow="overflow" vert="horz" wrap="square" lIns="91440" tIns="45720" rIns="91440" bIns="45720" numCol="1" spcCol="0" rtlCol="0" fromWordArt="0" anchor="t" anchorCtr="0" forceAA="0" upright="0" compatLnSpc="0">
+            <a:spAutoFit/>
+          </a:bodyPr>
+          <a:p>
+            <a:pPr marL="0" lvl="0" indent="0" algn="l" defTabSz="1111248">
+              <a:lnSpc>
+                <a:spcPct val="100000"/>
+              </a:lnSpc>
+              <a:spcBef>
+                <a:spcPts val="0"/>
+              </a:spcBef>
+              <a:spcAft>
+                <a:spcPts val="0"/>
+              </a:spcAft>
+              <a:buNone/>
+              <a:defRPr/>
+            </a:pPr>
+            <a:r>
+              <a:rPr lang="de-DE" sz="1800" b="0" i="0" u="none" strike="noStrike" cap="none" spc="0">
+                <a:solidFill>
+                  <a:schemeClr val="tx1"/>
+                </a:solidFill>
+                <a:latin typeface="Calibri"/>
+                <a:ea typeface="Arial"/>
+                <a:cs typeface="Arial"/>
+              </a:rPr>
+              <a:t>Task Management Web Service</a:t>
+            </a:r>
+            <a:endParaRPr sz="1800"/>
+          </a:p>
+        </p:txBody>
+      </p:sp>
+      <p:sp>
+        <p:nvSpPr>
+          <p:cNvPr id="1555854711" name=""/>
+          <p:cNvSpPr txBox="1"/>
+          <p:nvPr/>
+        </p:nvSpPr>
+        <p:spPr bwMode="auto">
+          <a:xfrm rot="0" flipH="0" flipV="0">
+            <a:off x="1029360" y="2104007"/>
+            <a:ext cx="7567076" cy="366118"/>
+          </a:xfrm>
+          <a:prstGeom prst="rect">
+            <a:avLst/>
+          </a:prstGeom>
+          <a:noFill/>
+        </p:spPr>
+        <p:txBody>
+          <a:bodyPr vertOverflow="overflow" horzOverflow="overflow" vert="horz" wrap="square" lIns="91440" tIns="45720" rIns="91440" bIns="45720" numCol="1" spcCol="0" rtlCol="0" fromWordArt="0" anchor="t" anchorCtr="0" forceAA="0" upright="0" compatLnSpc="0">
+            <a:spAutoFit/>
+          </a:bodyPr>
+          <a:p>
+            <a:pPr marL="0" lvl="0" indent="0" algn="l" defTabSz="1111248">
+              <a:lnSpc>
+                <a:spcPct val="100000"/>
+              </a:lnSpc>
+              <a:spcBef>
+                <a:spcPts val="0"/>
+              </a:spcBef>
+              <a:spcAft>
+                <a:spcPts val="0"/>
+              </a:spcAft>
+              <a:buNone/>
+              <a:defRPr/>
+            </a:pPr>
+            <a:r>
+              <a:rPr lang="de-DE" sz="1800" b="0" i="0" u="none" strike="noStrike" cap="none" spc="0">
+                <a:solidFill>
+                  <a:schemeClr val="tx1"/>
+                </a:solidFill>
+                <a:latin typeface="Calibri"/>
+                <a:ea typeface="Arial"/>
+                <a:cs typeface="Arial"/>
+              </a:rPr>
+              <a:t>Simple, scalable, role-based system</a:t>
+            </a:r>
+            <a:endParaRPr sz="1800"/>
+          </a:p>
+        </p:txBody>
+      </p:sp>
+      <p:sp>
+        <p:nvSpPr>
+          <p:cNvPr id="196038368" name=""/>
+          <p:cNvSpPr txBox="1"/>
+          <p:nvPr/>
+        </p:nvSpPr>
+        <p:spPr bwMode="auto">
+          <a:xfrm rot="0" flipH="0" flipV="0">
+            <a:off x="1029360" y="3009951"/>
+            <a:ext cx="7567076" cy="366118"/>
+          </a:xfrm>
+          <a:prstGeom prst="rect">
+            <a:avLst/>
+          </a:prstGeom>
+          <a:noFill/>
+        </p:spPr>
+        <p:txBody>
+          <a:bodyPr vertOverflow="overflow" horzOverflow="overflow" vert="horz" wrap="square" lIns="91440" tIns="45720" rIns="91440" bIns="45720" numCol="1" spcCol="0" rtlCol="0" fromWordArt="0" anchor="t" anchorCtr="0" forceAA="0" upright="0" compatLnSpc="0">
+            <a:spAutoFit/>
+          </a:bodyPr>
+          <a:p>
+            <a:pPr marL="0" lvl="0" indent="0" algn="l" defTabSz="1111248">
+              <a:lnSpc>
+                <a:spcPct val="100000"/>
+              </a:lnSpc>
+              <a:spcBef>
+                <a:spcPts val="0"/>
+              </a:spcBef>
+              <a:spcAft>
+                <a:spcPts val="0"/>
+              </a:spcAft>
+              <a:buNone/>
+              <a:defRPr/>
+            </a:pPr>
+            <a:r>
+              <a:rPr lang="de-DE" sz="1800" b="0" i="0" u="none" strike="noStrike" cap="none" spc="0">
+                <a:solidFill>
+                  <a:schemeClr val="tx1"/>
+                </a:solidFill>
+                <a:latin typeface="Calibri"/>
+                <a:ea typeface="Arial"/>
+                <a:cs typeface="Arial"/>
+              </a:rPr>
+              <a:t>Designed for teams &amp; project collaboration</a:t>
+            </a:r>
+            <a:endParaRPr sz="1800"/>
+          </a:p>
+        </p:txBody>
+      </p:sp>
+      <p:sp>
+        <p:nvSpPr>
+          <p:cNvPr id="2125783183" name=""/>
+          <p:cNvSpPr txBox="1"/>
+          <p:nvPr/>
+        </p:nvSpPr>
+        <p:spPr bwMode="auto">
+          <a:xfrm rot="0" flipH="0" flipV="0">
+            <a:off x="1028281" y="3915893"/>
+            <a:ext cx="7568875" cy="366118"/>
+          </a:xfrm>
+          <a:prstGeom prst="rect">
+            <a:avLst/>
+          </a:prstGeom>
+          <a:noFill/>
+        </p:spPr>
+        <p:txBody>
+          <a:bodyPr vertOverflow="overflow" horzOverflow="overflow" vert="horz" wrap="square" lIns="91440" tIns="45720" rIns="91440" bIns="45720" numCol="1" spcCol="0" rtlCol="0" fromWordArt="0" anchor="t" anchorCtr="0" forceAA="0" upright="0" compatLnSpc="0">
+            <a:spAutoFit/>
+          </a:bodyPr>
+          <a:p>
+            <a:pPr marL="0" indent="0" algn="l">
+              <a:buNone/>
+              <a:defRPr/>
+            </a:pPr>
+            <a:r>
+              <a:rPr lang="de-DE">
+                <a:solidFill>
+                  <a:srgbClr val="0F172A"/>
+                </a:solidFill>
+                <a:latin typeface="Calibri"/>
+                <a:ea typeface="Calibri"/>
+                <a:cs typeface="Calibri"/>
+              </a:rPr>
+              <a:t>AI Assistant for task organization</a:t>
+            </a:r>
+            <a:endParaRPr lang="en-US" sz="1000"/>
+          </a:p>
+        </p:txBody>
+      </p:sp>
+    </p:spTree>
+  </p:cSld>
+  <p:clrMapOvr>
+    <a:masterClrMapping/>
+  </p:clrMapOvr>
+  <mc:AlternateContent xmlns:mc="http://schemas.openxmlformats.org/markup-compatibility/2006">
+    <mc:Choice xmlns:p159="http://schemas.microsoft.com/office/powerpoint/2015/09/main" xmlns:p14="http://schemas.microsoft.com/office/powerpoint/2010/main" Requires="p159">
+      <p:transition p14:dur="500" advClick="1"/>
+    </mc:Choice>
+    <mc:Fallback>
+      <p:transition advClick="1"/>
+    </mc:Fallback>
+  </mc:AlternateContent>
+</p:sld>
+</file>
+
+<file path=ppt/slides/slide4.xml><?xml version="1.0" encoding="utf-8"?>
+<p:sld xmlns:a="http://schemas.openxmlformats.org/drawingml/2006/main" xmlns:r="http://schemas.openxmlformats.org/officeDocument/2006/relationships" xmlns:p="http://schemas.openxmlformats.org/presentationml/2006/main" xmlns:m="http://schemas.openxmlformats.org/officeDocument/2006/math" xmlns:w="http://schemas.openxmlformats.org/wordprocessingml/2006/main" xmlns:mc="http://schemas.openxmlformats.org/markup-compatibility/2006" showMasterPhAnim="0" showMasterSp="1" show="1">
+  <p:cSld name="Slide 2">
+    <p:bg>
+      <p:bgPr shadeToTitle="0">
+        <a:solidFill>
+          <a:srgbClr val="F8FAFC"/>
+        </a:solidFill>
+      </p:bgPr>
+    </p:bg>
+    <p:spTree>
+      <p:nvGrpSpPr>
+        <p:cNvPr id="1" name=""/>
+        <p:cNvGrpSpPr/>
+        <p:nvPr/>
+      </p:nvGrpSpPr>
+      <p:grpSpPr bwMode="auto">
+        <a:xfrm>
+          <a:off x="0" y="0"/>
+          <a:ext cx="0" cy="0"/>
+          <a:chOff x="0" y="0"/>
+          <a:chExt cx="0" cy="0"/>
+        </a:xfrm>
+      </p:grpSpPr>
+      <p:sp>
+        <p:nvSpPr>
+          <p:cNvPr id="345997393" name="Shape 0"/>
+          <p:cNvSpPr/>
+          <p:nvPr/>
+        </p:nvSpPr>
+        <p:spPr bwMode="auto">
+          <a:xfrm>
+            <a:off x="0" y="0"/>
+            <a:ext cx="9144000" cy="685800"/>
+          </a:xfrm>
+          <a:prstGeom prst="rect">
+            <a:avLst/>
+          </a:prstGeom>
+          <a:solidFill>
+            <a:srgbClr val="1A2B4A"/>
+          </a:solidFill>
+          <a:ln w="12700">
+            <a:solidFill>
+              <a:srgbClr val="1A2B4A"/>
+            </a:solidFill>
+            <a:prstDash val="solid"/>
+          </a:ln>
+        </p:spPr>
+      </p:sp>
+      <p:sp>
+        <p:nvSpPr>
+          <p:cNvPr id="2102479022" name="Text 1"/>
           <p:cNvSpPr/>
           <p:nvPr/>
         </p:nvSpPr>
@@ -2359,7 +2582,7 @@
       </p:sp>
       <p:sp>
         <p:nvSpPr>
-          <p:cNvPr id="1023021624" name="Shape 2"/>
+          <p:cNvPr id="279940241" name="Shape 2"/>
           <p:cNvSpPr/>
           <p:nvPr/>
         </p:nvSpPr>
@@ -2391,7 +2614,7 @@
       </p:sp>
       <p:sp>
         <p:nvSpPr>
-          <p:cNvPr id="1357908812" name="Shape 3"/>
+          <p:cNvPr id="949440880" name="Shape 3"/>
           <p:cNvSpPr/>
           <p:nvPr/>
         </p:nvSpPr>
@@ -2416,7 +2639,7 @@
       </p:sp>
       <p:sp>
         <p:nvSpPr>
-          <p:cNvPr id="2061089712" name="Shape 4"/>
+          <p:cNvPr id="1106525165" name="Shape 4"/>
           <p:cNvSpPr/>
           <p:nvPr/>
         </p:nvSpPr>
@@ -2441,7 +2664,7 @@
       </p:sp>
       <p:pic>
         <p:nvPicPr>
-          <p:cNvPr id="29794053" name="Image 0" descr="preencoded.png"/>
+          <p:cNvPr id="1722493398" name="Image 0" descr="preencoded.png"/>
           <p:cNvPicPr>
             <a:picLocks noChangeAspect="1"/>
           </p:cNvPicPr>
@@ -2463,7 +2686,7 @@
       </p:pic>
       <p:sp>
         <p:nvSpPr>
-          <p:cNvPr id="1189167288" name="Text 5"/>
+          <p:cNvPr id="260161535" name="Text 5"/>
           <p:cNvSpPr/>
           <p:nvPr/>
         </p:nvSpPr>
@@ -2503,7 +2726,7 @@
       </p:sp>
       <p:sp>
         <p:nvSpPr>
-          <p:cNvPr id="15212801" name="Text 6"/>
+          <p:cNvPr id="865027311" name="Text 6"/>
           <p:cNvSpPr/>
           <p:nvPr/>
         </p:nvSpPr>
@@ -2554,7 +2777,7 @@
       </p:sp>
       <p:sp>
         <p:nvSpPr>
-          <p:cNvPr id="1872047947" name="Shape 7"/>
+          <p:cNvPr id="2059648819" name="Shape 7"/>
           <p:cNvSpPr/>
           <p:nvPr/>
         </p:nvSpPr>
@@ -2579,7 +2802,7 @@
       </p:sp>
       <p:sp>
         <p:nvSpPr>
-          <p:cNvPr id="2084784501" name="Shape 10"/>
+          <p:cNvPr id="1534475478" name="Shape 10"/>
           <p:cNvSpPr/>
           <p:nvPr/>
         </p:nvSpPr>
@@ -2604,7 +2827,7 @@
       </p:sp>
       <p:sp>
         <p:nvSpPr>
-          <p:cNvPr id="817095608" name="Text 11"/>
+          <p:cNvPr id="1142716195" name="Text 11"/>
           <p:cNvSpPr/>
           <p:nvPr/>
         </p:nvSpPr>
@@ -2666,7 +2889,7 @@
       </p:sp>
       <p:sp>
         <p:nvSpPr>
-          <p:cNvPr id="1357713650" name="Shape 12"/>
+          <p:cNvPr id="1170045242" name="Shape 12"/>
           <p:cNvSpPr/>
           <p:nvPr/>
         </p:nvSpPr>
@@ -2691,7 +2914,7 @@
       </p:sp>
       <p:sp>
         <p:nvSpPr>
-          <p:cNvPr id="521455736" name="Text 13"/>
+          <p:cNvPr id="1942377503" name="Text 13"/>
           <p:cNvSpPr/>
           <p:nvPr/>
         </p:nvSpPr>
@@ -2742,7 +2965,7 @@
       </p:sp>
       <p:sp>
         <p:nvSpPr>
-          <p:cNvPr id="235156541" name="Shape 14"/>
+          <p:cNvPr id="1651745658" name="Shape 14"/>
           <p:cNvSpPr/>
           <p:nvPr/>
         </p:nvSpPr>
@@ -2767,7 +2990,7 @@
       </p:sp>
       <p:sp>
         <p:nvSpPr>
-          <p:cNvPr id="1269331725" name="Text 15"/>
+          <p:cNvPr id="734580209" name="Text 15"/>
           <p:cNvSpPr/>
           <p:nvPr/>
         </p:nvSpPr>
@@ -2807,7 +3030,7 @@
       </p:sp>
       <p:sp>
         <p:nvSpPr>
-          <p:cNvPr id="811895043" name="Shape 16"/>
+          <p:cNvPr id="366621515" name="Shape 16"/>
           <p:cNvSpPr/>
           <p:nvPr/>
         </p:nvSpPr>
@@ -2832,7 +3055,7 @@
       </p:sp>
       <p:sp>
         <p:nvSpPr>
-          <p:cNvPr id="1309116935" name="Text 17"/>
+          <p:cNvPr id="2087669724" name="Text 17"/>
           <p:cNvSpPr/>
           <p:nvPr/>
         </p:nvSpPr>
@@ -2872,7 +3095,7 @@
       </p:sp>
       <p:sp>
         <p:nvSpPr>
-          <p:cNvPr id="1519710710" name="Shape 18"/>
+          <p:cNvPr id="252443199" name="Shape 18"/>
           <p:cNvSpPr/>
           <p:nvPr/>
         </p:nvSpPr>
@@ -2897,7 +3120,7 @@
       </p:sp>
       <p:sp>
         <p:nvSpPr>
-          <p:cNvPr id="1013378917" name="Text 19"/>
+          <p:cNvPr id="619694399" name="Text 19"/>
           <p:cNvSpPr/>
           <p:nvPr/>
         </p:nvSpPr>
@@ -2937,7 +3160,7 @@
       </p:sp>
       <p:sp>
         <p:nvSpPr>
-          <p:cNvPr id="396068197" name="Shape 20"/>
+          <p:cNvPr id="323600883" name="Shape 20"/>
           <p:cNvSpPr/>
           <p:nvPr/>
         </p:nvSpPr>
@@ -2969,7 +3192,7 @@
       </p:sp>
       <p:sp>
         <p:nvSpPr>
-          <p:cNvPr id="1242411567" name="Shape 21"/>
+          <p:cNvPr id="1908581719" name="Shape 21"/>
           <p:cNvSpPr/>
           <p:nvPr/>
         </p:nvSpPr>
@@ -2994,7 +3217,7 @@
       </p:sp>
       <p:sp>
         <p:nvSpPr>
-          <p:cNvPr id="789935851" name="Shape 22"/>
+          <p:cNvPr id="1909084096" name="Shape 22"/>
           <p:cNvSpPr/>
           <p:nvPr/>
         </p:nvSpPr>
@@ -3019,7 +3242,7 @@
       </p:sp>
       <p:pic>
         <p:nvPicPr>
-          <p:cNvPr id="797655607" name="Image 1" descr="preencoded.png"/>
+          <p:cNvPr id="700473001" name="Image 1" descr="preencoded.png"/>
           <p:cNvPicPr>
             <a:picLocks noChangeAspect="1"/>
           </p:cNvPicPr>
@@ -3041,7 +3264,7 @@
       </p:pic>
       <p:sp>
         <p:nvSpPr>
-          <p:cNvPr id="210583851" name="Text 23"/>
+          <p:cNvPr id="1457045212" name="Text 23"/>
           <p:cNvSpPr/>
           <p:nvPr/>
         </p:nvSpPr>
@@ -3081,7 +3304,7 @@
       </p:sp>
       <p:sp>
         <p:nvSpPr>
-          <p:cNvPr id="311790057" name="Text 24"/>
+          <p:cNvPr id="478980198" name="Text 24"/>
           <p:cNvSpPr/>
           <p:nvPr/>
         </p:nvSpPr>
@@ -3121,7 +3344,7 @@
       </p:sp>
       <p:sp>
         <p:nvSpPr>
-          <p:cNvPr id="241321205" name="Shape 25"/>
+          <p:cNvPr id="2019453208" name="Shape 25"/>
           <p:cNvSpPr/>
           <p:nvPr/>
         </p:nvSpPr>
@@ -3146,7 +3369,7 @@
       </p:sp>
       <p:sp>
         <p:nvSpPr>
-          <p:cNvPr id="622355933" name="Shape 26"/>
+          <p:cNvPr id="66600363" name="Shape 26"/>
           <p:cNvSpPr/>
           <p:nvPr/>
         </p:nvSpPr>
@@ -3171,7 +3394,7 @@
       </p:sp>
       <p:sp>
         <p:nvSpPr>
-          <p:cNvPr id="1173502568" name="Text 27"/>
+          <p:cNvPr id="351845439" name="Text 27"/>
           <p:cNvSpPr/>
           <p:nvPr/>
         </p:nvSpPr>
@@ -3211,7 +3434,7 @@
       </p:sp>
       <p:sp>
         <p:nvSpPr>
-          <p:cNvPr id="1027500873" name="Shape 28"/>
+          <p:cNvPr id="1836986978" name="Shape 28"/>
           <p:cNvSpPr/>
           <p:nvPr/>
         </p:nvSpPr>
@@ -3236,7 +3459,7 @@
       </p:sp>
       <p:sp>
         <p:nvSpPr>
-          <p:cNvPr id="1228084125" name="Text 29"/>
+          <p:cNvPr id="1324995932" name="Text 29"/>
           <p:cNvSpPr/>
           <p:nvPr/>
         </p:nvSpPr>
@@ -3276,7 +3499,7 @@
       </p:sp>
       <p:sp>
         <p:nvSpPr>
-          <p:cNvPr id="1528424712" name="Shape 36"/>
+          <p:cNvPr id="1268976981" name="Shape 36"/>
           <p:cNvSpPr/>
           <p:nvPr/>
         </p:nvSpPr>
@@ -3308,7 +3531,7 @@
       </p:sp>
       <p:sp>
         <p:nvSpPr>
-          <p:cNvPr id="1855132235" name="Shape 37"/>
+          <p:cNvPr id="2111800316" name="Shape 37"/>
           <p:cNvSpPr/>
           <p:nvPr/>
         </p:nvSpPr>
@@ -3333,7 +3556,7 @@
       </p:sp>
       <p:sp>
         <p:nvSpPr>
-          <p:cNvPr id="1206856816" name="Shape 38"/>
+          <p:cNvPr id="1247980996" name="Shape 38"/>
           <p:cNvSpPr/>
           <p:nvPr/>
         </p:nvSpPr>
@@ -3358,7 +3581,7 @@
       </p:sp>
       <p:pic>
         <p:nvPicPr>
-          <p:cNvPr id="1770707744" name="Image 2" descr="preencoded.png"/>
+          <p:cNvPr id="269124010" name="Image 2" descr="preencoded.png"/>
           <p:cNvPicPr>
             <a:picLocks noChangeAspect="1"/>
           </p:cNvPicPr>
@@ -3380,7 +3603,7 @@
       </p:pic>
       <p:sp>
         <p:nvSpPr>
-          <p:cNvPr id="496690762" name="Text 39"/>
+          <p:cNvPr id="1259748514" name="Text 39"/>
           <p:cNvSpPr/>
           <p:nvPr/>
         </p:nvSpPr>
@@ -3420,7 +3643,7 @@
       </p:sp>
       <p:sp>
         <p:nvSpPr>
-          <p:cNvPr id="579602599" name="Text 40"/>
+          <p:cNvPr id="1483091674" name="Text 40"/>
           <p:cNvSpPr/>
           <p:nvPr/>
         </p:nvSpPr>
@@ -3460,7 +3683,7 @@
       </p:sp>
       <p:sp>
         <p:nvSpPr>
-          <p:cNvPr id="1444879556" name="Shape 41"/>
+          <p:cNvPr id="1807257056" name="Shape 41"/>
           <p:cNvSpPr/>
           <p:nvPr/>
         </p:nvSpPr>
@@ -3485,7 +3708,7 @@
       </p:sp>
       <p:sp>
         <p:nvSpPr>
-          <p:cNvPr id="1485808050" name="Shape 42"/>
+          <p:cNvPr id="1740750586" name="Shape 42"/>
           <p:cNvSpPr/>
           <p:nvPr/>
         </p:nvSpPr>
@@ -3510,7 +3733,7 @@
       </p:sp>
       <p:sp>
         <p:nvSpPr>
-          <p:cNvPr id="1526286699" name="Text 43"/>
+          <p:cNvPr id="2056562103" name="Text 43"/>
           <p:cNvSpPr/>
           <p:nvPr/>
         </p:nvSpPr>
@@ -3550,7 +3773,7 @@
       </p:sp>
       <p:grpSp>
         <p:nvGrpSpPr>
-          <p:cNvPr id="1810874068" name=""/>
+          <p:cNvPr id="2023879216" name=""/>
           <p:cNvGrpSpPr/>
           <p:nvPr/>
         </p:nvGrpSpPr>
@@ -3630,7 +3853,7 @@
       </p:grpSp>
       <p:sp>
         <p:nvSpPr>
-          <p:cNvPr id="1530407485" name="Shape 18"/>
+          <p:cNvPr id="548097460" name="Shape 18"/>
           <p:cNvSpPr/>
           <p:nvPr/>
         </p:nvSpPr>
@@ -3655,7 +3878,7 @@
       </p:sp>
       <p:sp>
         <p:nvSpPr>
-          <p:cNvPr id="1983218102" name="Text 19"/>
+          <p:cNvPr id="1714504025" name="Text 19"/>
           <p:cNvSpPr/>
           <p:nvPr/>
         </p:nvSpPr>
@@ -3695,7 +3918,7 @@
       </p:sp>
       <p:sp>
         <p:nvSpPr>
-          <p:cNvPr id="195418996" name="Text 29"/>
+          <p:cNvPr id="512148673" name="Text 29"/>
           <p:cNvSpPr/>
           <p:nvPr/>
         </p:nvSpPr>
@@ -3735,7 +3958,7 @@
       </p:sp>
       <p:sp>
         <p:nvSpPr>
-          <p:cNvPr id="1087350516" name="Shape 28"/>
+          <p:cNvPr id="1404560550" name="Shape 28"/>
           <p:cNvSpPr/>
           <p:nvPr/>
         </p:nvSpPr>
@@ -3774,7 +3997,7 @@
 </p:sld>
 </file>
 
-<file path=ppt/slides/slide4.xml><?xml version="1.0" encoding="utf-8"?>
+<file path=ppt/slides/slide5.xml><?xml version="1.0" encoding="utf-8"?>
 <p:sld xmlns:a="http://schemas.openxmlformats.org/drawingml/2006/main" xmlns:r="http://schemas.openxmlformats.org/officeDocument/2006/relationships" xmlns:p="http://schemas.openxmlformats.org/presentationml/2006/main" xmlns:m="http://schemas.openxmlformats.org/officeDocument/2006/math" xmlns:w="http://schemas.openxmlformats.org/wordprocessingml/2006/main" xmlns:mc="http://schemas.openxmlformats.org/markup-compatibility/2006" showMasterPhAnim="0" showMasterSp="1" show="1">
   <p:cSld name="Slide 3">
     <p:bg>
@@ -3800,7 +4023,7 @@
       </p:grpSpPr>
       <p:sp>
         <p:nvSpPr>
-          <p:cNvPr id="794237452" name="Shape 0"/>
+          <p:cNvPr id="1911626101" name="Shape 0"/>
           <p:cNvSpPr/>
           <p:nvPr/>
         </p:nvSpPr>
@@ -3825,7 +4048,7 @@
       </p:sp>
       <p:sp>
         <p:nvSpPr>
-          <p:cNvPr id="905596500" name="Text 1"/>
+          <p:cNvPr id="433814086" name="Text 1"/>
           <p:cNvSpPr/>
           <p:nvPr/>
         </p:nvSpPr>
@@ -3865,7 +4088,7 @@
       </p:sp>
       <p:sp>
         <p:nvSpPr>
-          <p:cNvPr id="753153369" name="Shape 4"/>
+          <p:cNvPr id="753940476" name="Shape 4"/>
           <p:cNvSpPr/>
           <p:nvPr/>
         </p:nvSpPr>
@@ -3897,7 +4120,7 @@
       </p:sp>
       <p:sp>
         <p:nvSpPr>
-          <p:cNvPr id="1120677527" name="Shape 5"/>
+          <p:cNvPr id="637753671" name="Shape 5"/>
           <p:cNvSpPr/>
           <p:nvPr/>
         </p:nvSpPr>
@@ -3922,7 +4145,7 @@
       </p:sp>
       <p:sp>
         <p:nvSpPr>
-          <p:cNvPr id="1057612885" name="Text 6"/>
+          <p:cNvPr id="1052258573" name="Text 6"/>
           <p:cNvSpPr/>
           <p:nvPr/>
         </p:nvSpPr>
@@ -3962,7 +4185,7 @@
       </p:sp>
       <p:grpSp>
         <p:nvGrpSpPr>
-          <p:cNvPr id="2028416445" name=""/>
+          <p:cNvPr id="1496944718" name=""/>
           <p:cNvGrpSpPr/>
           <p:nvPr/>
         </p:nvGrpSpPr>
@@ -4064,7 +4287,7 @@
       </p:grpSp>
       <p:grpSp>
         <p:nvGrpSpPr>
-          <p:cNvPr id="1043956862" name=""/>
+          <p:cNvPr id="1776818074" name=""/>
           <p:cNvGrpSpPr/>
           <p:nvPr/>
         </p:nvGrpSpPr>
@@ -4306,7 +4529,7 @@
       </p:grpSp>
       <p:grpSp>
         <p:nvGrpSpPr>
-          <p:cNvPr id="1766865330" name=""/>
+          <p:cNvPr id="343176029" name=""/>
           <p:cNvGrpSpPr/>
           <p:nvPr/>
         </p:nvGrpSpPr>
@@ -4483,7 +4706,7 @@
       </p:grpSp>
       <p:grpSp>
         <p:nvGrpSpPr>
-          <p:cNvPr id="602103311" name=""/>
+          <p:cNvPr id="897913427" name=""/>
           <p:cNvGrpSpPr/>
           <p:nvPr/>
         </p:nvGrpSpPr>
@@ -4790,7 +5013,7 @@
       </p:grpSp>
       <p:grpSp>
         <p:nvGrpSpPr>
-          <p:cNvPr id="1664359303" name=""/>
+          <p:cNvPr id="1896039867" name=""/>
           <p:cNvGrpSpPr/>
           <p:nvPr/>
         </p:nvGrpSpPr>
@@ -5097,7 +5320,7 @@
       </p:grpSp>
       <p:sp>
         <p:nvSpPr>
-          <p:cNvPr id="60019720" name="Text 16"/>
+          <p:cNvPr id="1241085968" name="Text 16"/>
           <p:cNvSpPr/>
           <p:nvPr/>
         </p:nvSpPr>
@@ -5126,7 +5349,7 @@
       </p:sp>
       <p:grpSp>
         <p:nvGrpSpPr>
-          <p:cNvPr id="382523036" name=""/>
+          <p:cNvPr id="354856091" name=""/>
           <p:cNvGrpSpPr/>
           <p:nvPr/>
         </p:nvGrpSpPr>
@@ -5206,7 +5429,7 @@
       </p:grpSp>
       <p:grpSp>
         <p:nvGrpSpPr>
-          <p:cNvPr id="1095896344" name=""/>
+          <p:cNvPr id="645469806" name=""/>
           <p:cNvGrpSpPr/>
           <p:nvPr/>
         </p:nvGrpSpPr>
@@ -5286,7 +5509,7 @@
       </p:grpSp>
       <p:grpSp>
         <p:nvGrpSpPr>
-          <p:cNvPr id="2076596407" name=""/>
+          <p:cNvPr id="608700685" name=""/>
           <p:cNvGrpSpPr/>
           <p:nvPr/>
         </p:nvGrpSpPr>
@@ -5366,7 +5589,7 @@
       </p:grpSp>
       <p:grpSp>
         <p:nvGrpSpPr>
-          <p:cNvPr id="713209664" name=""/>
+          <p:cNvPr id="678057513" name=""/>
           <p:cNvGrpSpPr/>
           <p:nvPr/>
         </p:nvGrpSpPr>
@@ -5446,7 +5669,7 @@
       </p:grpSp>
       <p:grpSp>
         <p:nvGrpSpPr>
-          <p:cNvPr id="130355326" name=""/>
+          <p:cNvPr id="605995650" name=""/>
           <p:cNvGrpSpPr/>
           <p:nvPr/>
         </p:nvGrpSpPr>
@@ -5526,7 +5749,7 @@
       </p:grpSp>
       <p:grpSp>
         <p:nvGrpSpPr>
-          <p:cNvPr id="404431465" name=""/>
+          <p:cNvPr id="1853658912" name=""/>
           <p:cNvGrpSpPr/>
           <p:nvPr/>
         </p:nvGrpSpPr>
@@ -5606,7 +5829,7 @@
       </p:grpSp>
       <p:grpSp>
         <p:nvGrpSpPr>
-          <p:cNvPr id="728931045" name=""/>
+          <p:cNvPr id="1228955472" name=""/>
           <p:cNvGrpSpPr/>
           <p:nvPr/>
         </p:nvGrpSpPr>
@@ -5686,7 +5909,7 @@
       </p:grpSp>
       <p:grpSp>
         <p:nvGrpSpPr>
-          <p:cNvPr id="192485265" name=""/>
+          <p:cNvPr id="1647598188" name=""/>
           <p:cNvGrpSpPr/>
           <p:nvPr/>
         </p:nvGrpSpPr>
@@ -5766,7 +5989,7 @@
       </p:grpSp>
       <p:grpSp>
         <p:nvGrpSpPr>
-          <p:cNvPr id="101512939" name=""/>
+          <p:cNvPr id="1848125293" name=""/>
           <p:cNvGrpSpPr/>
           <p:nvPr/>
         </p:nvGrpSpPr>
@@ -5846,7 +6069,7 @@
       </p:grpSp>
       <p:grpSp>
         <p:nvGrpSpPr>
-          <p:cNvPr id="389953627" name=""/>
+          <p:cNvPr id="280254001" name=""/>
           <p:cNvGrpSpPr/>
           <p:nvPr/>
         </p:nvGrpSpPr>
@@ -5926,7 +6149,7 @@
       </p:grpSp>
       <p:sp>
         <p:nvSpPr>
-          <p:cNvPr id="1274897343" name="Shape 29"/>
+          <p:cNvPr id="967577274" name="Shape 29"/>
           <p:cNvSpPr/>
           <p:nvPr/>
         </p:nvSpPr>
@@ -5949,7 +6172,7 @@
       </p:sp>
       <p:sp>
         <p:nvSpPr>
-          <p:cNvPr id="970153979" name="Shape 29"/>
+          <p:cNvPr id="2028221266" name="Shape 29"/>
           <p:cNvSpPr/>
           <p:nvPr/>
         </p:nvSpPr>
@@ -5972,7 +6195,7 @@
       </p:sp>
       <p:sp>
         <p:nvSpPr>
-          <p:cNvPr id="924895091" name="Shape 29"/>
+          <p:cNvPr id="268736655" name="Shape 29"/>
           <p:cNvSpPr/>
           <p:nvPr/>
         </p:nvSpPr>
@@ -5995,7 +6218,7 @@
       </p:sp>
       <p:sp>
         <p:nvSpPr>
-          <p:cNvPr id="295250131" name="Shape 29"/>
+          <p:cNvPr id="2123147085" name="Shape 29"/>
           <p:cNvSpPr/>
           <p:nvPr/>
         </p:nvSpPr>
@@ -6018,7 +6241,7 @@
       </p:sp>
       <p:sp>
         <p:nvSpPr>
-          <p:cNvPr id="1425310887" name="Shape 29"/>
+          <p:cNvPr id="589763610" name="Shape 29"/>
           <p:cNvSpPr/>
           <p:nvPr/>
         </p:nvSpPr>
@@ -6055,7 +6278,7 @@
 </p:sld>
 </file>
 
-<file path=ppt/slides/slide5.xml><?xml version="1.0" encoding="utf-8"?>
+<file path=ppt/slides/slide6.xml><?xml version="1.0" encoding="utf-8"?>
 <p:sld xmlns:a="http://schemas.openxmlformats.org/drawingml/2006/main" xmlns:r="http://schemas.openxmlformats.org/officeDocument/2006/relationships" xmlns:p="http://schemas.openxmlformats.org/presentationml/2006/main" xmlns:m="http://schemas.openxmlformats.org/officeDocument/2006/math" xmlns:w="http://schemas.openxmlformats.org/wordprocessingml/2006/main" xmlns:mc="http://schemas.openxmlformats.org/markup-compatibility/2006" showMasterPhAnim="0" showMasterSp="1" show="1">
   <p:cSld name="Slide 4">
     <p:bg>
@@ -6081,7 +6304,7 @@
       </p:grpSpPr>
       <p:sp>
         <p:nvSpPr>
-          <p:cNvPr id="2052398206" name="Shape 0"/>
+          <p:cNvPr id="1866365320" name="Shape 0"/>
           <p:cNvSpPr/>
           <p:nvPr/>
         </p:nvSpPr>
@@ -6106,7 +6329,7 @@
       </p:sp>
       <p:sp>
         <p:nvSpPr>
-          <p:cNvPr id="413069466" name="Text 1"/>
+          <p:cNvPr id="498579675" name="Text 1"/>
           <p:cNvSpPr/>
           <p:nvPr/>
         </p:nvSpPr>
@@ -6146,7 +6369,7 @@
       </p:sp>
       <p:sp>
         <p:nvSpPr>
-          <p:cNvPr id="986132724" name="Shape 2"/>
+          <p:cNvPr id="1175134472" name="Shape 2"/>
           <p:cNvSpPr/>
           <p:nvPr/>
         </p:nvSpPr>
@@ -6171,7 +6394,7 @@
       </p:sp>
       <p:sp>
         <p:nvSpPr>
-          <p:cNvPr id="1622339369" name="Text 3"/>
+          <p:cNvPr id="749732965" name="Text 3"/>
           <p:cNvSpPr/>
           <p:nvPr/>
         </p:nvSpPr>
@@ -6211,7 +6434,7 @@
       </p:sp>
       <p:sp>
         <p:nvSpPr>
-          <p:cNvPr id="2067364522" name="Shape 29"/>
+          <p:cNvPr id="157613297" name="Shape 29"/>
           <p:cNvSpPr/>
           <p:nvPr/>
         </p:nvSpPr>
@@ -6234,7 +6457,7 @@
       </p:sp>
       <p:grpSp>
         <p:nvGrpSpPr>
-          <p:cNvPr id="1272209418" name=""/>
+          <p:cNvPr id="978952486" name=""/>
           <p:cNvGrpSpPr/>
           <p:nvPr/>
         </p:nvGrpSpPr>
@@ -6336,7 +6559,7 @@
       </p:grpSp>
       <p:grpSp>
         <p:nvGrpSpPr>
-          <p:cNvPr id="966734658" name=""/>
+          <p:cNvPr id="1050779226" name=""/>
           <p:cNvGrpSpPr/>
           <p:nvPr/>
         </p:nvGrpSpPr>
@@ -6589,7 +6812,7 @@
       </p:grpSp>
       <p:sp>
         <p:nvSpPr>
-          <p:cNvPr id="840761609" name="Shape 29"/>
+          <p:cNvPr id="804249382" name="Shape 29"/>
           <p:cNvSpPr/>
           <p:nvPr/>
         </p:nvSpPr>
@@ -6612,7 +6835,7 @@
       </p:sp>
       <p:grpSp>
         <p:nvGrpSpPr>
-          <p:cNvPr id="2083964868" name=""/>
+          <p:cNvPr id="2121285808" name=""/>
           <p:cNvGrpSpPr/>
           <p:nvPr/>
         </p:nvGrpSpPr>
@@ -6868,7 +7091,7 @@
 </p:sld>
 </file>
 
-<file path=ppt/slides/slide6.xml><?xml version="1.0" encoding="utf-8"?>
+<file path=ppt/slides/slide7.xml><?xml version="1.0" encoding="utf-8"?>
 <p:sld xmlns:a="http://schemas.openxmlformats.org/drawingml/2006/main" xmlns:r="http://schemas.openxmlformats.org/officeDocument/2006/relationships" xmlns:p="http://schemas.openxmlformats.org/presentationml/2006/main" xmlns:m="http://schemas.openxmlformats.org/officeDocument/2006/math" xmlns:w="http://schemas.openxmlformats.org/wordprocessingml/2006/main" xmlns:mc="http://schemas.openxmlformats.org/markup-compatibility/2006" showMasterPhAnim="0" showMasterSp="1" show="1">
   <p:cSld name="Slide 5">
     <p:bg>
@@ -6894,7 +7117,7 @@
       </p:grpSpPr>
       <p:sp>
         <p:nvSpPr>
-          <p:cNvPr id="1028650791" name="Shape 0"/>
+          <p:cNvPr id="1392288489" name="Shape 0"/>
           <p:cNvSpPr/>
           <p:nvPr/>
         </p:nvSpPr>
@@ -6919,7 +7142,7 @@
       </p:sp>
       <p:sp>
         <p:nvSpPr>
-          <p:cNvPr id="621428687" name="Text 1"/>
+          <p:cNvPr id="394260581" name="Text 1"/>
           <p:cNvSpPr/>
           <p:nvPr/>
         </p:nvSpPr>
@@ -6959,7 +7182,7 @@
       </p:sp>
       <p:sp>
         <p:nvSpPr>
-          <p:cNvPr id="713825178" name="Shape 2"/>
+          <p:cNvPr id="52822599" name="Shape 2"/>
           <p:cNvSpPr/>
           <p:nvPr/>
         </p:nvSpPr>
@@ -6984,7 +7207,7 @@
       </p:sp>
       <p:sp>
         <p:nvSpPr>
-          <p:cNvPr id="2140194647" name="Text 3"/>
+          <p:cNvPr id="1547585626" name="Text 3"/>
           <p:cNvSpPr/>
           <p:nvPr/>
         </p:nvSpPr>
@@ -7024,7 +7247,7 @@
       </p:sp>
       <p:grpSp>
         <p:nvGrpSpPr>
-          <p:cNvPr id="514072402" name=""/>
+          <p:cNvPr id="1060357958" name=""/>
           <p:cNvGrpSpPr/>
           <p:nvPr/>
         </p:nvGrpSpPr>
@@ -7126,7 +7349,7 @@
       </p:grpSp>
       <p:sp>
         <p:nvSpPr>
-          <p:cNvPr id="974258352" name="Shape 29"/>
+          <p:cNvPr id="217592280" name="Shape 29"/>
           <p:cNvSpPr/>
           <p:nvPr/>
         </p:nvSpPr>
@@ -7149,7 +7372,7 @@
       </p:sp>
       <p:grpSp>
         <p:nvGrpSpPr>
-          <p:cNvPr id="1826834349" name=""/>
+          <p:cNvPr id="1917792386" name=""/>
           <p:cNvGrpSpPr/>
           <p:nvPr/>
         </p:nvGrpSpPr>
@@ -7326,7 +7549,7 @@
       </p:grpSp>
       <p:sp>
         <p:nvSpPr>
-          <p:cNvPr id="85493455" name="Shape 29"/>
+          <p:cNvPr id="1096905989" name="Shape 29"/>
           <p:cNvSpPr/>
           <p:nvPr/>
         </p:nvSpPr>

</xml_diff>

<commit_message>
changed background for slides
</commit_message>
<xml_diff>
--- a/docs/Mini_Jira_UseCases_EN.pptx
+++ b/docs/Mini_Jira_UseCases_EN.pptx
@@ -137,7 +137,7 @@
       </p:grpSpPr>
       <p:sp>
         <p:nvSpPr>
-          <p:cNvPr id="1245280865" name="Header Placeholder 1"/>
+          <p:cNvPr id="1773353537" name="Header Placeholder 1"/>
           <p:cNvSpPr>
             <a:spLocks noGrp="1"/>
           </p:cNvSpPr>
@@ -171,7 +171,7 @@
       </p:sp>
       <p:sp>
         <p:nvSpPr>
-          <p:cNvPr id="1614068449" name="Date Placeholder 2"/>
+          <p:cNvPr id="799580607" name="Date Placeholder 2"/>
           <p:cNvSpPr>
             <a:spLocks noGrp="1"/>
           </p:cNvSpPr>
@@ -209,7 +209,7 @@
       </p:sp>
       <p:sp>
         <p:nvSpPr>
-          <p:cNvPr id="2096728543" name="Slide Image Placeholder 3"/>
+          <p:cNvPr id="1658878560" name="Slide Image Placeholder 3"/>
           <p:cNvSpPr>
             <a:spLocks noChangeAspect="1" noGrp="1" noRot="1"/>
           </p:cNvSpPr>
@@ -245,7 +245,7 @@
       </p:sp>
       <p:sp>
         <p:nvSpPr>
-          <p:cNvPr id="327201737" name="Notes Placeholder 4"/>
+          <p:cNvPr id="165941191" name="Notes Placeholder 4"/>
           <p:cNvSpPr>
             <a:spLocks noGrp="1"/>
           </p:cNvSpPr>
@@ -319,7 +319,7 @@
       </p:sp>
       <p:sp>
         <p:nvSpPr>
-          <p:cNvPr id="188414506" name="Footer Placeholder 5"/>
+          <p:cNvPr id="1831568027" name="Footer Placeholder 5"/>
           <p:cNvSpPr>
             <a:spLocks noGrp="1"/>
           </p:cNvSpPr>
@@ -353,7 +353,7 @@
       </p:sp>
       <p:sp>
         <p:nvSpPr>
-          <p:cNvPr id="116204263" name="Slide Number Placeholder 6"/>
+          <p:cNvPr id="1734372878" name="Slide Number Placeholder 6"/>
           <p:cNvSpPr>
             <a:spLocks noGrp="1"/>
           </p:cNvSpPr>
@@ -506,7 +506,7 @@
       </p:grpSpPr>
       <p:sp>
         <p:nvSpPr>
-          <p:cNvPr id="674105350" name="Slide Image Placeholder 1"/>
+          <p:cNvPr id="1725351292" name="Slide Image Placeholder 1"/>
           <p:cNvSpPr>
             <a:spLocks noChangeAspect="1" noGrp="1" noRot="1"/>
           </p:cNvSpPr>
@@ -518,7 +518,7 @@
       </p:sp>
       <p:sp>
         <p:nvSpPr>
-          <p:cNvPr id="2058601038" name="Notes Placeholder 2"/>
+          <p:cNvPr id="1380391059" name="Notes Placeholder 2"/>
           <p:cNvSpPr>
             <a:spLocks noGrp="1"/>
           </p:cNvSpPr>
@@ -540,7 +540,7 @@
       </p:sp>
       <p:sp>
         <p:nvSpPr>
-          <p:cNvPr id="2027838660" name="Slide Number Placeholder 3"/>
+          <p:cNvPr id="1559608256" name="Slide Number Placeholder 3"/>
           <p:cNvSpPr>
             <a:spLocks noGrp="1"/>
           </p:cNvSpPr>
@@ -591,7 +591,7 @@
       </p:grpSpPr>
       <p:sp>
         <p:nvSpPr>
-          <p:cNvPr id="1239800363" name="Slide Image Placeholder 1"/>
+          <p:cNvPr id="1743582920" name="Slide Image Placeholder 1"/>
           <p:cNvSpPr>
             <a:spLocks noChangeAspect="1" noGrp="1" noRot="1"/>
           </p:cNvSpPr>
@@ -603,7 +603,7 @@
       </p:sp>
       <p:sp>
         <p:nvSpPr>
-          <p:cNvPr id="2083532716" name="Notes Placeholder 2"/>
+          <p:cNvPr id="110159531" name="Notes Placeholder 2"/>
           <p:cNvSpPr>
             <a:spLocks noGrp="1"/>
           </p:cNvSpPr>
@@ -625,7 +625,7 @@
       </p:sp>
       <p:sp>
         <p:nvSpPr>
-          <p:cNvPr id="1962760289" name="Slide Number Placeholder 3"/>
+          <p:cNvPr id="1332211802" name="Slide Number Placeholder 3"/>
           <p:cNvSpPr>
             <a:spLocks noGrp="1"/>
           </p:cNvSpPr>
@@ -761,7 +761,7 @@
       </p:grpSpPr>
       <p:sp>
         <p:nvSpPr>
-          <p:cNvPr id="1880140206" name="Slide Image Placeholder 1"/>
+          <p:cNvPr id="1090224040" name="Slide Image Placeholder 1"/>
           <p:cNvSpPr>
             <a:spLocks noChangeAspect="1" noGrp="1" noRot="1"/>
           </p:cNvSpPr>
@@ -773,7 +773,7 @@
       </p:sp>
       <p:sp>
         <p:nvSpPr>
-          <p:cNvPr id="1852563317" name="Notes Placeholder 2"/>
+          <p:cNvPr id="1567833417" name="Notes Placeholder 2"/>
           <p:cNvSpPr>
             <a:spLocks noGrp="1"/>
           </p:cNvSpPr>
@@ -795,7 +795,7 @@
       </p:sp>
       <p:sp>
         <p:nvSpPr>
-          <p:cNvPr id="2015389531" name="Slide Number Placeholder 3"/>
+          <p:cNvPr id="1810869536" name="Slide Number Placeholder 3"/>
           <p:cNvSpPr>
             <a:spLocks noGrp="1"/>
           </p:cNvSpPr>
@@ -846,7 +846,7 @@
       </p:grpSpPr>
       <p:sp>
         <p:nvSpPr>
-          <p:cNvPr id="1432002875" name="Slide Image Placeholder 1"/>
+          <p:cNvPr id="666265878" name="Slide Image Placeholder 1"/>
           <p:cNvSpPr>
             <a:spLocks noChangeAspect="1" noGrp="1" noRot="1"/>
           </p:cNvSpPr>
@@ -858,7 +858,7 @@
       </p:sp>
       <p:sp>
         <p:nvSpPr>
-          <p:cNvPr id="1334705840" name="Notes Placeholder 2"/>
+          <p:cNvPr id="787626525" name="Notes Placeholder 2"/>
           <p:cNvSpPr>
             <a:spLocks noGrp="1"/>
           </p:cNvSpPr>
@@ -880,7 +880,7 @@
       </p:sp>
       <p:sp>
         <p:nvSpPr>
-          <p:cNvPr id="1100867754" name="Slide Number Placeholder 3"/>
+          <p:cNvPr id="1124832147" name="Slide Number Placeholder 3"/>
           <p:cNvSpPr>
             <a:spLocks noGrp="1"/>
           </p:cNvSpPr>
@@ -931,7 +931,7 @@
       </p:grpSpPr>
       <p:sp>
         <p:nvSpPr>
-          <p:cNvPr id="2001735549" name="Slide Image Placeholder 1"/>
+          <p:cNvPr id="753244270" name="Slide Image Placeholder 1"/>
           <p:cNvSpPr>
             <a:spLocks noChangeAspect="1" noGrp="1" noRot="1"/>
           </p:cNvSpPr>
@@ -943,7 +943,7 @@
       </p:sp>
       <p:sp>
         <p:nvSpPr>
-          <p:cNvPr id="54324828" name="Notes Placeholder 2"/>
+          <p:cNvPr id="353112738" name="Notes Placeholder 2"/>
           <p:cNvSpPr>
             <a:spLocks noGrp="1"/>
           </p:cNvSpPr>
@@ -965,7 +965,7 @@
       </p:sp>
       <p:sp>
         <p:nvSpPr>
-          <p:cNvPr id="1252292324" name="Slide Number Placeholder 3"/>
+          <p:cNvPr id="1071298871" name="Slide Number Placeholder 3"/>
           <p:cNvSpPr>
             <a:spLocks noGrp="1"/>
           </p:cNvSpPr>
@@ -1016,7 +1016,7 @@
       </p:grpSpPr>
       <p:sp>
         <p:nvSpPr>
-          <p:cNvPr id="1928271887" name="Slide Image Placeholder 1"/>
+          <p:cNvPr id="651021965" name="Slide Image Placeholder 1"/>
           <p:cNvSpPr>
             <a:spLocks noChangeAspect="1" noGrp="1" noRot="1"/>
           </p:cNvSpPr>
@@ -1028,7 +1028,7 @@
       </p:sp>
       <p:sp>
         <p:nvSpPr>
-          <p:cNvPr id="1336880434" name="Notes Placeholder 2"/>
+          <p:cNvPr id="1116319946" name="Notes Placeholder 2"/>
           <p:cNvSpPr>
             <a:spLocks noGrp="1"/>
           </p:cNvSpPr>
@@ -1050,7 +1050,7 @@
       </p:sp>
       <p:sp>
         <p:nvSpPr>
-          <p:cNvPr id="1421387250" name="Slide Number Placeholder 3"/>
+          <p:cNvPr id="1142851542" name="Slide Number Placeholder 3"/>
           <p:cNvSpPr>
             <a:spLocks noGrp="1"/>
           </p:cNvSpPr>
@@ -1395,7 +1395,9 @@
     <p:bg>
       <p:bgPr shadeToTitle="0">
         <a:solidFill>
-          <a:srgbClr val="1A2B4A"/>
+          <a:schemeClr val="bg1">
+            <a:lumMod val="95000"/>
+          </a:schemeClr>
         </a:solidFill>
       </p:bgPr>
     </p:bg>
@@ -1415,7 +1417,7 @@
       </p:grpSpPr>
       <p:sp>
         <p:nvSpPr>
-          <p:cNvPr id="1585185129" name="Shape 0"/>
+          <p:cNvPr id="846361877" name="Shape 0"/>
           <p:cNvSpPr/>
           <p:nvPr/>
         </p:nvSpPr>
@@ -1440,7 +1442,7 @@
       </p:sp>
       <p:sp>
         <p:nvSpPr>
-          <p:cNvPr id="1023229040" name="Shape 1"/>
+          <p:cNvPr id="1546817239" name="Shape 1"/>
           <p:cNvSpPr/>
           <p:nvPr/>
         </p:nvSpPr>
@@ -1469,7 +1471,7 @@
       </p:sp>
       <p:sp>
         <p:nvSpPr>
-          <p:cNvPr id="26456648" name="Shape 2"/>
+          <p:cNvPr id="1171658607" name="Shape 2"/>
           <p:cNvSpPr/>
           <p:nvPr/>
         </p:nvSpPr>
@@ -1498,7 +1500,7 @@
       </p:sp>
       <p:sp>
         <p:nvSpPr>
-          <p:cNvPr id="1519134280" name="Shape 3"/>
+          <p:cNvPr id="2130318316" name="Shape 3"/>
           <p:cNvSpPr/>
           <p:nvPr/>
         </p:nvSpPr>
@@ -1527,7 +1529,7 @@
       </p:sp>
       <p:sp>
         <p:nvSpPr>
-          <p:cNvPr id="1689348922" name="Shape 4"/>
+          <p:cNvPr id="1064263494" name="Shape 4"/>
           <p:cNvSpPr/>
           <p:nvPr/>
         </p:nvSpPr>
@@ -1556,7 +1558,7 @@
       </p:sp>
       <p:sp>
         <p:nvSpPr>
-          <p:cNvPr id="87373052" name="Shape 5"/>
+          <p:cNvPr id="61086871" name="Shape 5"/>
           <p:cNvSpPr/>
           <p:nvPr/>
         </p:nvSpPr>
@@ -1585,7 +1587,7 @@
       </p:sp>
       <p:sp>
         <p:nvSpPr>
-          <p:cNvPr id="1885791790" name="Text 6"/>
+          <p:cNvPr id="940712605" name="Text 6"/>
           <p:cNvSpPr/>
           <p:nvPr/>
         </p:nvSpPr>
@@ -1611,7 +1613,7 @@
             <a:r>
               <a:rPr lang="en-US" sz="5200" b="1">
                 <a:solidFill>
-                  <a:srgbClr val="FFFFFF"/>
+                  <a:schemeClr val="tx1"/>
                 </a:solidFill>
                 <a:latin typeface="Calibri"/>
                 <a:ea typeface="Calibri"/>
@@ -1619,13 +1621,17 @@
               </a:rPr>
               <a:t>Mini Jira</a:t>
             </a:r>
-            <a:endParaRPr lang="en-US" sz="5200"/>
+            <a:endParaRPr sz="5200">
+              <a:solidFill>
+                <a:schemeClr val="tx1"/>
+              </a:solidFill>
+            </a:endParaRPr>
           </a:p>
         </p:txBody>
       </p:sp>
       <p:sp>
         <p:nvSpPr>
-          <p:cNvPr id="73157080" name="Text 7"/>
+          <p:cNvPr id="1210472871" name="Text 7"/>
           <p:cNvSpPr/>
           <p:nvPr/>
         </p:nvSpPr>
@@ -1665,7 +1671,7 @@
       </p:sp>
       <p:sp>
         <p:nvSpPr>
-          <p:cNvPr id="149352817" name="Shape 8"/>
+          <p:cNvPr id="1036911702" name="Shape 8"/>
           <p:cNvSpPr/>
           <p:nvPr/>
         </p:nvSpPr>
@@ -1690,7 +1696,7 @@
       </p:sp>
       <p:sp>
         <p:nvSpPr>
-          <p:cNvPr id="604663554" name="Text 9"/>
+          <p:cNvPr id="263645498" name="Text 9"/>
           <p:cNvSpPr/>
           <p:nvPr/>
         </p:nvSpPr>
@@ -1716,7 +1722,10 @@
             <a:r>
               <a:rPr lang="en-US" sz="1400">
                 <a:solidFill>
-                  <a:srgbClr val="CBD5E1"/>
+                  <a:schemeClr val="tx1">
+                    <a:lumMod val="50000"/>
+                    <a:lumOff val="50000"/>
+                  </a:schemeClr>
                 </a:solidFill>
                 <a:latin typeface="Calibri"/>
                 <a:ea typeface="Calibri"/>
@@ -1724,7 +1733,14 @@
               </a:rPr>
               <a:t>Task, Project &amp; Team Management</a:t>
             </a:r>
-            <a:endParaRPr lang="en-US" sz="1400"/>
+            <a:endParaRPr sz="1400">
+              <a:solidFill>
+                <a:schemeClr val="tx1">
+                  <a:lumMod val="50000"/>
+                  <a:lumOff val="50000"/>
+                </a:schemeClr>
+              </a:solidFill>
+            </a:endParaRPr>
           </a:p>
         </p:txBody>
       </p:sp>
@@ -1750,7 +1766,9 @@
     <p:bg>
       <p:bgPr shadeToTitle="0">
         <a:solidFill>
-          <a:srgbClr val="F8FAFC"/>
+          <a:schemeClr val="bg1">
+            <a:lumMod val="95000"/>
+          </a:schemeClr>
         </a:solidFill>
       </p:bgPr>
     </p:bg>
@@ -1770,7 +1788,7 @@
       </p:grpSpPr>
       <p:sp>
         <p:nvSpPr>
-          <p:cNvPr id="197802393" name="Shape 0"/>
+          <p:cNvPr id="472878718" name="Shape 0"/>
           <p:cNvSpPr/>
           <p:nvPr/>
         </p:nvSpPr>
@@ -1795,7 +1813,7 @@
       </p:sp>
       <p:sp>
         <p:nvSpPr>
-          <p:cNvPr id="709022521" name="Text 1"/>
+          <p:cNvPr id="1246338364" name="Text 1"/>
           <p:cNvSpPr/>
           <p:nvPr/>
         </p:nvSpPr>
@@ -1887,7 +1905,9 @@
     <p:bg>
       <p:bgPr shadeToTitle="0">
         <a:solidFill>
-          <a:srgbClr val="F8FAFC"/>
+          <a:schemeClr val="bg1">
+            <a:lumMod val="95000"/>
+          </a:schemeClr>
         </a:solidFill>
       </p:bgPr>
     </p:bg>
@@ -2497,7 +2517,9 @@
     <p:bg>
       <p:bgPr shadeToTitle="0">
         <a:solidFill>
-          <a:srgbClr val="F8FAFC"/>
+          <a:schemeClr val="bg1">
+            <a:lumMod val="95000"/>
+          </a:schemeClr>
         </a:solidFill>
       </p:bgPr>
     </p:bg>
@@ -2517,7 +2539,7 @@
       </p:grpSpPr>
       <p:sp>
         <p:nvSpPr>
-          <p:cNvPr id="345997393" name="Shape 0"/>
+          <p:cNvPr id="972858799" name="Shape 0"/>
           <p:cNvSpPr/>
           <p:nvPr/>
         </p:nvSpPr>
@@ -2542,7 +2564,7 @@
       </p:sp>
       <p:sp>
         <p:nvSpPr>
-          <p:cNvPr id="2102479022" name="Text 1"/>
+          <p:cNvPr id="985941082" name="Text 1"/>
           <p:cNvSpPr/>
           <p:nvPr/>
         </p:nvSpPr>
@@ -2582,7 +2604,7 @@
       </p:sp>
       <p:sp>
         <p:nvSpPr>
-          <p:cNvPr id="279940241" name="Shape 2"/>
+          <p:cNvPr id="1597755350" name="Shape 2"/>
           <p:cNvSpPr/>
           <p:nvPr/>
         </p:nvSpPr>
@@ -2614,7 +2636,7 @@
       </p:sp>
       <p:sp>
         <p:nvSpPr>
-          <p:cNvPr id="949440880" name="Shape 3"/>
+          <p:cNvPr id="1651482133" name="Shape 3"/>
           <p:cNvSpPr/>
           <p:nvPr/>
         </p:nvSpPr>
@@ -2639,7 +2661,7 @@
       </p:sp>
       <p:sp>
         <p:nvSpPr>
-          <p:cNvPr id="1106525165" name="Shape 4"/>
+          <p:cNvPr id="520226564" name="Shape 4"/>
           <p:cNvSpPr/>
           <p:nvPr/>
         </p:nvSpPr>
@@ -2664,7 +2686,7 @@
       </p:sp>
       <p:pic>
         <p:nvPicPr>
-          <p:cNvPr id="1722493398" name="Image 0" descr="preencoded.png"/>
+          <p:cNvPr id="1216213355" name="Image 0" descr="preencoded.png"/>
           <p:cNvPicPr>
             <a:picLocks noChangeAspect="1"/>
           </p:cNvPicPr>
@@ -2686,7 +2708,7 @@
       </p:pic>
       <p:sp>
         <p:nvSpPr>
-          <p:cNvPr id="260161535" name="Text 5"/>
+          <p:cNvPr id="2047590101" name="Text 5"/>
           <p:cNvSpPr/>
           <p:nvPr/>
         </p:nvSpPr>
@@ -2726,7 +2748,7 @@
       </p:sp>
       <p:sp>
         <p:nvSpPr>
-          <p:cNvPr id="865027311" name="Text 6"/>
+          <p:cNvPr id="1103509186" name="Text 6"/>
           <p:cNvSpPr/>
           <p:nvPr/>
         </p:nvSpPr>
@@ -2777,7 +2799,7 @@
       </p:sp>
       <p:sp>
         <p:nvSpPr>
-          <p:cNvPr id="2059648819" name="Shape 7"/>
+          <p:cNvPr id="469325892" name="Shape 7"/>
           <p:cNvSpPr/>
           <p:nvPr/>
         </p:nvSpPr>
@@ -2802,7 +2824,7 @@
       </p:sp>
       <p:sp>
         <p:nvSpPr>
-          <p:cNvPr id="1534475478" name="Shape 10"/>
+          <p:cNvPr id="776375762" name="Shape 10"/>
           <p:cNvSpPr/>
           <p:nvPr/>
         </p:nvSpPr>
@@ -2827,7 +2849,7 @@
       </p:sp>
       <p:sp>
         <p:nvSpPr>
-          <p:cNvPr id="1142716195" name="Text 11"/>
+          <p:cNvPr id="59832696" name="Text 11"/>
           <p:cNvSpPr/>
           <p:nvPr/>
         </p:nvSpPr>
@@ -2889,7 +2911,7 @@
       </p:sp>
       <p:sp>
         <p:nvSpPr>
-          <p:cNvPr id="1170045242" name="Shape 12"/>
+          <p:cNvPr id="1925255951" name="Shape 12"/>
           <p:cNvSpPr/>
           <p:nvPr/>
         </p:nvSpPr>
@@ -2914,7 +2936,7 @@
       </p:sp>
       <p:sp>
         <p:nvSpPr>
-          <p:cNvPr id="1942377503" name="Text 13"/>
+          <p:cNvPr id="605018589" name="Text 13"/>
           <p:cNvSpPr/>
           <p:nvPr/>
         </p:nvSpPr>
@@ -2965,7 +2987,7 @@
       </p:sp>
       <p:sp>
         <p:nvSpPr>
-          <p:cNvPr id="1651745658" name="Shape 14"/>
+          <p:cNvPr id="1451280852" name="Shape 14"/>
           <p:cNvSpPr/>
           <p:nvPr/>
         </p:nvSpPr>
@@ -2990,7 +3012,7 @@
       </p:sp>
       <p:sp>
         <p:nvSpPr>
-          <p:cNvPr id="734580209" name="Text 15"/>
+          <p:cNvPr id="617278547" name="Text 15"/>
           <p:cNvSpPr/>
           <p:nvPr/>
         </p:nvSpPr>
@@ -3030,7 +3052,7 @@
       </p:sp>
       <p:sp>
         <p:nvSpPr>
-          <p:cNvPr id="366621515" name="Shape 16"/>
+          <p:cNvPr id="1668212936" name="Shape 16"/>
           <p:cNvSpPr/>
           <p:nvPr/>
         </p:nvSpPr>
@@ -3055,7 +3077,7 @@
       </p:sp>
       <p:sp>
         <p:nvSpPr>
-          <p:cNvPr id="2087669724" name="Text 17"/>
+          <p:cNvPr id="1905845518" name="Text 17"/>
           <p:cNvSpPr/>
           <p:nvPr/>
         </p:nvSpPr>
@@ -3095,7 +3117,7 @@
       </p:sp>
       <p:sp>
         <p:nvSpPr>
-          <p:cNvPr id="252443199" name="Shape 18"/>
+          <p:cNvPr id="275320966" name="Shape 18"/>
           <p:cNvSpPr/>
           <p:nvPr/>
         </p:nvSpPr>
@@ -3120,7 +3142,7 @@
       </p:sp>
       <p:sp>
         <p:nvSpPr>
-          <p:cNvPr id="619694399" name="Text 19"/>
+          <p:cNvPr id="1929958858" name="Text 19"/>
           <p:cNvSpPr/>
           <p:nvPr/>
         </p:nvSpPr>
@@ -3160,7 +3182,7 @@
       </p:sp>
       <p:sp>
         <p:nvSpPr>
-          <p:cNvPr id="323600883" name="Shape 20"/>
+          <p:cNvPr id="1198403496" name="Shape 20"/>
           <p:cNvSpPr/>
           <p:nvPr/>
         </p:nvSpPr>
@@ -3192,7 +3214,7 @@
       </p:sp>
       <p:sp>
         <p:nvSpPr>
-          <p:cNvPr id="1908581719" name="Shape 21"/>
+          <p:cNvPr id="109435001" name="Shape 21"/>
           <p:cNvSpPr/>
           <p:nvPr/>
         </p:nvSpPr>
@@ -3217,7 +3239,7 @@
       </p:sp>
       <p:sp>
         <p:nvSpPr>
-          <p:cNvPr id="1909084096" name="Shape 22"/>
+          <p:cNvPr id="248900819" name="Shape 22"/>
           <p:cNvSpPr/>
           <p:nvPr/>
         </p:nvSpPr>
@@ -3242,7 +3264,7 @@
       </p:sp>
       <p:pic>
         <p:nvPicPr>
-          <p:cNvPr id="700473001" name="Image 1" descr="preencoded.png"/>
+          <p:cNvPr id="1024602385" name="Image 1" descr="preencoded.png"/>
           <p:cNvPicPr>
             <a:picLocks noChangeAspect="1"/>
           </p:cNvPicPr>
@@ -3264,7 +3286,7 @@
       </p:pic>
       <p:sp>
         <p:nvSpPr>
-          <p:cNvPr id="1457045212" name="Text 23"/>
+          <p:cNvPr id="810599601" name="Text 23"/>
           <p:cNvSpPr/>
           <p:nvPr/>
         </p:nvSpPr>
@@ -3304,7 +3326,7 @@
       </p:sp>
       <p:sp>
         <p:nvSpPr>
-          <p:cNvPr id="478980198" name="Text 24"/>
+          <p:cNvPr id="980817398" name="Text 24"/>
           <p:cNvSpPr/>
           <p:nvPr/>
         </p:nvSpPr>
@@ -3344,7 +3366,7 @@
       </p:sp>
       <p:sp>
         <p:nvSpPr>
-          <p:cNvPr id="2019453208" name="Shape 25"/>
+          <p:cNvPr id="2075255531" name="Shape 25"/>
           <p:cNvSpPr/>
           <p:nvPr/>
         </p:nvSpPr>
@@ -3369,7 +3391,7 @@
       </p:sp>
       <p:sp>
         <p:nvSpPr>
-          <p:cNvPr id="66600363" name="Shape 26"/>
+          <p:cNvPr id="1961601603" name="Shape 26"/>
           <p:cNvSpPr/>
           <p:nvPr/>
         </p:nvSpPr>
@@ -3394,7 +3416,7 @@
       </p:sp>
       <p:sp>
         <p:nvSpPr>
-          <p:cNvPr id="351845439" name="Text 27"/>
+          <p:cNvPr id="326249643" name="Text 27"/>
           <p:cNvSpPr/>
           <p:nvPr/>
         </p:nvSpPr>
@@ -3434,7 +3456,7 @@
       </p:sp>
       <p:sp>
         <p:nvSpPr>
-          <p:cNvPr id="1836986978" name="Shape 28"/>
+          <p:cNvPr id="1703301339" name="Shape 28"/>
           <p:cNvSpPr/>
           <p:nvPr/>
         </p:nvSpPr>
@@ -3459,7 +3481,7 @@
       </p:sp>
       <p:sp>
         <p:nvSpPr>
-          <p:cNvPr id="1324995932" name="Text 29"/>
+          <p:cNvPr id="244988075" name="Text 29"/>
           <p:cNvSpPr/>
           <p:nvPr/>
         </p:nvSpPr>
@@ -3499,7 +3521,7 @@
       </p:sp>
       <p:sp>
         <p:nvSpPr>
-          <p:cNvPr id="1268976981" name="Shape 36"/>
+          <p:cNvPr id="1745510608" name="Shape 36"/>
           <p:cNvSpPr/>
           <p:nvPr/>
         </p:nvSpPr>
@@ -3531,7 +3553,7 @@
       </p:sp>
       <p:sp>
         <p:nvSpPr>
-          <p:cNvPr id="2111800316" name="Shape 37"/>
+          <p:cNvPr id="1532956667" name="Shape 37"/>
           <p:cNvSpPr/>
           <p:nvPr/>
         </p:nvSpPr>
@@ -3556,7 +3578,7 @@
       </p:sp>
       <p:sp>
         <p:nvSpPr>
-          <p:cNvPr id="1247980996" name="Shape 38"/>
+          <p:cNvPr id="1980422390" name="Shape 38"/>
           <p:cNvSpPr/>
           <p:nvPr/>
         </p:nvSpPr>
@@ -3581,7 +3603,7 @@
       </p:sp>
       <p:pic>
         <p:nvPicPr>
-          <p:cNvPr id="269124010" name="Image 2" descr="preencoded.png"/>
+          <p:cNvPr id="2111435805" name="Image 2" descr="preencoded.png"/>
           <p:cNvPicPr>
             <a:picLocks noChangeAspect="1"/>
           </p:cNvPicPr>
@@ -3603,7 +3625,7 @@
       </p:pic>
       <p:sp>
         <p:nvSpPr>
-          <p:cNvPr id="1259748514" name="Text 39"/>
+          <p:cNvPr id="229508100" name="Text 39"/>
           <p:cNvSpPr/>
           <p:nvPr/>
         </p:nvSpPr>
@@ -3643,7 +3665,7 @@
       </p:sp>
       <p:sp>
         <p:nvSpPr>
-          <p:cNvPr id="1483091674" name="Text 40"/>
+          <p:cNvPr id="2086234781" name="Text 40"/>
           <p:cNvSpPr/>
           <p:nvPr/>
         </p:nvSpPr>
@@ -3683,7 +3705,7 @@
       </p:sp>
       <p:sp>
         <p:nvSpPr>
-          <p:cNvPr id="1807257056" name="Shape 41"/>
+          <p:cNvPr id="1624408864" name="Shape 41"/>
           <p:cNvSpPr/>
           <p:nvPr/>
         </p:nvSpPr>
@@ -3708,7 +3730,7 @@
       </p:sp>
       <p:sp>
         <p:nvSpPr>
-          <p:cNvPr id="1740750586" name="Shape 42"/>
+          <p:cNvPr id="1575720886" name="Shape 42"/>
           <p:cNvSpPr/>
           <p:nvPr/>
         </p:nvSpPr>
@@ -3733,7 +3755,7 @@
       </p:sp>
       <p:sp>
         <p:nvSpPr>
-          <p:cNvPr id="2056562103" name="Text 43"/>
+          <p:cNvPr id="974160814" name="Text 43"/>
           <p:cNvSpPr/>
           <p:nvPr/>
         </p:nvSpPr>
@@ -3773,7 +3795,7 @@
       </p:sp>
       <p:grpSp>
         <p:nvGrpSpPr>
-          <p:cNvPr id="2023879216" name=""/>
+          <p:cNvPr id="1876734150" name=""/>
           <p:cNvGrpSpPr/>
           <p:nvPr/>
         </p:nvGrpSpPr>
@@ -3853,7 +3875,7 @@
       </p:grpSp>
       <p:sp>
         <p:nvSpPr>
-          <p:cNvPr id="548097460" name="Shape 18"/>
+          <p:cNvPr id="1595146504" name="Shape 18"/>
           <p:cNvSpPr/>
           <p:nvPr/>
         </p:nvSpPr>
@@ -3878,7 +3900,7 @@
       </p:sp>
       <p:sp>
         <p:nvSpPr>
-          <p:cNvPr id="1714504025" name="Text 19"/>
+          <p:cNvPr id="56188084" name="Text 19"/>
           <p:cNvSpPr/>
           <p:nvPr/>
         </p:nvSpPr>
@@ -3918,7 +3940,7 @@
       </p:sp>
       <p:sp>
         <p:nvSpPr>
-          <p:cNvPr id="512148673" name="Text 29"/>
+          <p:cNvPr id="924717081" name="Text 29"/>
           <p:cNvSpPr/>
           <p:nvPr/>
         </p:nvSpPr>
@@ -3958,7 +3980,7 @@
       </p:sp>
       <p:sp>
         <p:nvSpPr>
-          <p:cNvPr id="1404560550" name="Shape 28"/>
+          <p:cNvPr id="102171071" name="Shape 28"/>
           <p:cNvSpPr/>
           <p:nvPr/>
         </p:nvSpPr>
@@ -4003,7 +4025,9 @@
     <p:bg>
       <p:bgPr shadeToTitle="0">
         <a:solidFill>
-          <a:srgbClr val="F8FAFC"/>
+          <a:schemeClr val="bg1">
+            <a:lumMod val="95000"/>
+          </a:schemeClr>
         </a:solidFill>
       </p:bgPr>
     </p:bg>
@@ -4023,7 +4047,7 @@
       </p:grpSpPr>
       <p:sp>
         <p:nvSpPr>
-          <p:cNvPr id="1911626101" name="Shape 0"/>
+          <p:cNvPr id="1146854383" name="Shape 0"/>
           <p:cNvSpPr/>
           <p:nvPr/>
         </p:nvSpPr>
@@ -4048,7 +4072,7 @@
       </p:sp>
       <p:sp>
         <p:nvSpPr>
-          <p:cNvPr id="433814086" name="Text 1"/>
+          <p:cNvPr id="1925387654" name="Text 1"/>
           <p:cNvSpPr/>
           <p:nvPr/>
         </p:nvSpPr>
@@ -4088,7 +4112,7 @@
       </p:sp>
       <p:sp>
         <p:nvSpPr>
-          <p:cNvPr id="753940476" name="Shape 4"/>
+          <p:cNvPr id="1063995969" name="Shape 4"/>
           <p:cNvSpPr/>
           <p:nvPr/>
         </p:nvSpPr>
@@ -4120,7 +4144,7 @@
       </p:sp>
       <p:sp>
         <p:nvSpPr>
-          <p:cNvPr id="637753671" name="Shape 5"/>
+          <p:cNvPr id="702341640" name="Shape 5"/>
           <p:cNvSpPr/>
           <p:nvPr/>
         </p:nvSpPr>
@@ -4145,7 +4169,7 @@
       </p:sp>
       <p:sp>
         <p:nvSpPr>
-          <p:cNvPr id="1052258573" name="Text 6"/>
+          <p:cNvPr id="1725364187" name="Text 6"/>
           <p:cNvSpPr/>
           <p:nvPr/>
         </p:nvSpPr>
@@ -4185,7 +4209,7 @@
       </p:sp>
       <p:grpSp>
         <p:nvGrpSpPr>
-          <p:cNvPr id="1496944718" name=""/>
+          <p:cNvPr id="1901520704" name=""/>
           <p:cNvGrpSpPr/>
           <p:nvPr/>
         </p:nvGrpSpPr>
@@ -4287,7 +4311,7 @@
       </p:grpSp>
       <p:grpSp>
         <p:nvGrpSpPr>
-          <p:cNvPr id="1776818074" name=""/>
+          <p:cNvPr id="550493900" name=""/>
           <p:cNvGrpSpPr/>
           <p:nvPr/>
         </p:nvGrpSpPr>
@@ -4529,7 +4553,7 @@
       </p:grpSp>
       <p:grpSp>
         <p:nvGrpSpPr>
-          <p:cNvPr id="343176029" name=""/>
+          <p:cNvPr id="72862429" name=""/>
           <p:cNvGrpSpPr/>
           <p:nvPr/>
         </p:nvGrpSpPr>
@@ -4706,7 +4730,7 @@
       </p:grpSp>
       <p:grpSp>
         <p:nvGrpSpPr>
-          <p:cNvPr id="897913427" name=""/>
+          <p:cNvPr id="456160677" name=""/>
           <p:cNvGrpSpPr/>
           <p:nvPr/>
         </p:nvGrpSpPr>
@@ -5013,7 +5037,7 @@
       </p:grpSp>
       <p:grpSp>
         <p:nvGrpSpPr>
-          <p:cNvPr id="1896039867" name=""/>
+          <p:cNvPr id="1166411386" name=""/>
           <p:cNvGrpSpPr/>
           <p:nvPr/>
         </p:nvGrpSpPr>
@@ -5320,7 +5344,7 @@
       </p:grpSp>
       <p:sp>
         <p:nvSpPr>
-          <p:cNvPr id="1241085968" name="Text 16"/>
+          <p:cNvPr id="162057119" name="Text 16"/>
           <p:cNvSpPr/>
           <p:nvPr/>
         </p:nvSpPr>
@@ -5349,7 +5373,7 @@
       </p:sp>
       <p:grpSp>
         <p:nvGrpSpPr>
-          <p:cNvPr id="354856091" name=""/>
+          <p:cNvPr id="1663097440" name=""/>
           <p:cNvGrpSpPr/>
           <p:nvPr/>
         </p:nvGrpSpPr>
@@ -5429,7 +5453,7 @@
       </p:grpSp>
       <p:grpSp>
         <p:nvGrpSpPr>
-          <p:cNvPr id="645469806" name=""/>
+          <p:cNvPr id="630773313" name=""/>
           <p:cNvGrpSpPr/>
           <p:nvPr/>
         </p:nvGrpSpPr>
@@ -5509,7 +5533,7 @@
       </p:grpSp>
       <p:grpSp>
         <p:nvGrpSpPr>
-          <p:cNvPr id="608700685" name=""/>
+          <p:cNvPr id="2125615672" name=""/>
           <p:cNvGrpSpPr/>
           <p:nvPr/>
         </p:nvGrpSpPr>
@@ -5589,7 +5613,7 @@
       </p:grpSp>
       <p:grpSp>
         <p:nvGrpSpPr>
-          <p:cNvPr id="678057513" name=""/>
+          <p:cNvPr id="21980623" name=""/>
           <p:cNvGrpSpPr/>
           <p:nvPr/>
         </p:nvGrpSpPr>
@@ -5669,7 +5693,7 @@
       </p:grpSp>
       <p:grpSp>
         <p:nvGrpSpPr>
-          <p:cNvPr id="605995650" name=""/>
+          <p:cNvPr id="1611543351" name=""/>
           <p:cNvGrpSpPr/>
           <p:nvPr/>
         </p:nvGrpSpPr>
@@ -5749,7 +5773,7 @@
       </p:grpSp>
       <p:grpSp>
         <p:nvGrpSpPr>
-          <p:cNvPr id="1853658912" name=""/>
+          <p:cNvPr id="818181742" name=""/>
           <p:cNvGrpSpPr/>
           <p:nvPr/>
         </p:nvGrpSpPr>
@@ -5829,7 +5853,7 @@
       </p:grpSp>
       <p:grpSp>
         <p:nvGrpSpPr>
-          <p:cNvPr id="1228955472" name=""/>
+          <p:cNvPr id="1883486366" name=""/>
           <p:cNvGrpSpPr/>
           <p:nvPr/>
         </p:nvGrpSpPr>
@@ -5909,7 +5933,7 @@
       </p:grpSp>
       <p:grpSp>
         <p:nvGrpSpPr>
-          <p:cNvPr id="1647598188" name=""/>
+          <p:cNvPr id="1089236089" name=""/>
           <p:cNvGrpSpPr/>
           <p:nvPr/>
         </p:nvGrpSpPr>
@@ -5989,7 +6013,7 @@
       </p:grpSp>
       <p:grpSp>
         <p:nvGrpSpPr>
-          <p:cNvPr id="1848125293" name=""/>
+          <p:cNvPr id="459840996" name=""/>
           <p:cNvGrpSpPr/>
           <p:nvPr/>
         </p:nvGrpSpPr>
@@ -6069,7 +6093,7 @@
       </p:grpSp>
       <p:grpSp>
         <p:nvGrpSpPr>
-          <p:cNvPr id="280254001" name=""/>
+          <p:cNvPr id="1091002730" name=""/>
           <p:cNvGrpSpPr/>
           <p:nvPr/>
         </p:nvGrpSpPr>
@@ -6149,7 +6173,7 @@
       </p:grpSp>
       <p:sp>
         <p:nvSpPr>
-          <p:cNvPr id="967577274" name="Shape 29"/>
+          <p:cNvPr id="1652948366" name="Shape 29"/>
           <p:cNvSpPr/>
           <p:nvPr/>
         </p:nvSpPr>
@@ -6172,7 +6196,7 @@
       </p:sp>
       <p:sp>
         <p:nvSpPr>
-          <p:cNvPr id="2028221266" name="Shape 29"/>
+          <p:cNvPr id="890895917" name="Shape 29"/>
           <p:cNvSpPr/>
           <p:nvPr/>
         </p:nvSpPr>
@@ -6195,7 +6219,7 @@
       </p:sp>
       <p:sp>
         <p:nvSpPr>
-          <p:cNvPr id="268736655" name="Shape 29"/>
+          <p:cNvPr id="1901167722" name="Shape 29"/>
           <p:cNvSpPr/>
           <p:nvPr/>
         </p:nvSpPr>
@@ -6218,7 +6242,7 @@
       </p:sp>
       <p:sp>
         <p:nvSpPr>
-          <p:cNvPr id="2123147085" name="Shape 29"/>
+          <p:cNvPr id="1204083780" name="Shape 29"/>
           <p:cNvSpPr/>
           <p:nvPr/>
         </p:nvSpPr>
@@ -6241,7 +6265,7 @@
       </p:sp>
       <p:sp>
         <p:nvSpPr>
-          <p:cNvPr id="589763610" name="Shape 29"/>
+          <p:cNvPr id="1336086657" name="Shape 29"/>
           <p:cNvSpPr/>
           <p:nvPr/>
         </p:nvSpPr>
@@ -6284,7 +6308,9 @@
     <p:bg>
       <p:bgPr shadeToTitle="0">
         <a:solidFill>
-          <a:srgbClr val="F8FAFC"/>
+          <a:schemeClr val="bg1">
+            <a:lumMod val="95000"/>
+          </a:schemeClr>
         </a:solidFill>
       </p:bgPr>
     </p:bg>
@@ -6304,7 +6330,7 @@
       </p:grpSpPr>
       <p:sp>
         <p:nvSpPr>
-          <p:cNvPr id="1866365320" name="Shape 0"/>
+          <p:cNvPr id="1189270757" name="Shape 0"/>
           <p:cNvSpPr/>
           <p:nvPr/>
         </p:nvSpPr>
@@ -6329,7 +6355,7 @@
       </p:sp>
       <p:sp>
         <p:nvSpPr>
-          <p:cNvPr id="498579675" name="Text 1"/>
+          <p:cNvPr id="2098578875" name="Text 1"/>
           <p:cNvSpPr/>
           <p:nvPr/>
         </p:nvSpPr>
@@ -6369,7 +6395,7 @@
       </p:sp>
       <p:sp>
         <p:nvSpPr>
-          <p:cNvPr id="1175134472" name="Shape 2"/>
+          <p:cNvPr id="146864079" name="Shape 2"/>
           <p:cNvSpPr/>
           <p:nvPr/>
         </p:nvSpPr>
@@ -6394,7 +6420,7 @@
       </p:sp>
       <p:sp>
         <p:nvSpPr>
-          <p:cNvPr id="749732965" name="Text 3"/>
+          <p:cNvPr id="1567321058" name="Text 3"/>
           <p:cNvSpPr/>
           <p:nvPr/>
         </p:nvSpPr>
@@ -6434,7 +6460,7 @@
       </p:sp>
       <p:sp>
         <p:nvSpPr>
-          <p:cNvPr id="157613297" name="Shape 29"/>
+          <p:cNvPr id="1024274937" name="Shape 29"/>
           <p:cNvSpPr/>
           <p:nvPr/>
         </p:nvSpPr>
@@ -6457,7 +6483,7 @@
       </p:sp>
       <p:grpSp>
         <p:nvGrpSpPr>
-          <p:cNvPr id="978952486" name=""/>
+          <p:cNvPr id="564140426" name=""/>
           <p:cNvGrpSpPr/>
           <p:nvPr/>
         </p:nvGrpSpPr>
@@ -6559,7 +6585,7 @@
       </p:grpSp>
       <p:grpSp>
         <p:nvGrpSpPr>
-          <p:cNvPr id="1050779226" name=""/>
+          <p:cNvPr id="1658739631" name=""/>
           <p:cNvGrpSpPr/>
           <p:nvPr/>
         </p:nvGrpSpPr>
@@ -6812,7 +6838,7 @@
       </p:grpSp>
       <p:sp>
         <p:nvSpPr>
-          <p:cNvPr id="804249382" name="Shape 29"/>
+          <p:cNvPr id="791151807" name="Shape 29"/>
           <p:cNvSpPr/>
           <p:nvPr/>
         </p:nvSpPr>
@@ -6835,7 +6861,7 @@
       </p:sp>
       <p:grpSp>
         <p:nvGrpSpPr>
-          <p:cNvPr id="2121285808" name=""/>
+          <p:cNvPr id="1022503775" name=""/>
           <p:cNvGrpSpPr/>
           <p:nvPr/>
         </p:nvGrpSpPr>
@@ -7097,7 +7123,9 @@
     <p:bg>
       <p:bgPr shadeToTitle="0">
         <a:solidFill>
-          <a:srgbClr val="F8FAFC"/>
+          <a:schemeClr val="bg1">
+            <a:lumMod val="95000"/>
+          </a:schemeClr>
         </a:solidFill>
       </p:bgPr>
     </p:bg>
@@ -7117,7 +7145,7 @@
       </p:grpSpPr>
       <p:sp>
         <p:nvSpPr>
-          <p:cNvPr id="1392288489" name="Shape 0"/>
+          <p:cNvPr id="1902551554" name="Shape 0"/>
           <p:cNvSpPr/>
           <p:nvPr/>
         </p:nvSpPr>
@@ -7142,7 +7170,7 @@
       </p:sp>
       <p:sp>
         <p:nvSpPr>
-          <p:cNvPr id="394260581" name="Text 1"/>
+          <p:cNvPr id="1827621038" name="Text 1"/>
           <p:cNvSpPr/>
           <p:nvPr/>
         </p:nvSpPr>
@@ -7182,7 +7210,7 @@
       </p:sp>
       <p:sp>
         <p:nvSpPr>
-          <p:cNvPr id="52822599" name="Shape 2"/>
+          <p:cNvPr id="1594154094" name="Shape 2"/>
           <p:cNvSpPr/>
           <p:nvPr/>
         </p:nvSpPr>
@@ -7207,7 +7235,7 @@
       </p:sp>
       <p:sp>
         <p:nvSpPr>
-          <p:cNvPr id="1547585626" name="Text 3"/>
+          <p:cNvPr id="47607525" name="Text 3"/>
           <p:cNvSpPr/>
           <p:nvPr/>
         </p:nvSpPr>
@@ -7247,7 +7275,7 @@
       </p:sp>
       <p:grpSp>
         <p:nvGrpSpPr>
-          <p:cNvPr id="1060357958" name=""/>
+          <p:cNvPr id="707970611" name=""/>
           <p:cNvGrpSpPr/>
           <p:nvPr/>
         </p:nvGrpSpPr>
@@ -7349,7 +7377,7 @@
       </p:grpSp>
       <p:sp>
         <p:nvSpPr>
-          <p:cNvPr id="217592280" name="Shape 29"/>
+          <p:cNvPr id="938224161" name="Shape 29"/>
           <p:cNvSpPr/>
           <p:nvPr/>
         </p:nvSpPr>
@@ -7372,7 +7400,7 @@
       </p:sp>
       <p:grpSp>
         <p:nvGrpSpPr>
-          <p:cNvPr id="1917792386" name=""/>
+          <p:cNvPr id="1395350226" name=""/>
           <p:cNvGrpSpPr/>
           <p:nvPr/>
         </p:nvGrpSpPr>
@@ -7549,7 +7577,7 @@
       </p:grpSp>
       <p:sp>
         <p:nvSpPr>
-          <p:cNvPr id="1096905989" name="Shape 29"/>
+          <p:cNvPr id="2044140067" name="Shape 29"/>
           <p:cNvSpPr/>
           <p:nvPr/>
         </p:nvSpPr>

</xml_diff>

<commit_message>
repaired presentation for powerpoint
</commit_message>
<xml_diff>
--- a/docs/Mini_Jira_UseCases_EN.pptx
+++ b/docs/Mini_Jira_UseCases_EN.pptx
@@ -1,22 +1,22 @@
 
 <file path=ppt/presentation.xml><?xml version="1.0" encoding="utf-8"?>
-<p:presentation xmlns:a="http://schemas.openxmlformats.org/drawingml/2006/main" xmlns:r="http://schemas.openxmlformats.org/officeDocument/2006/relationships" xmlns:p="http://schemas.openxmlformats.org/presentationml/2006/main" xmlns:m="http://schemas.openxmlformats.org/officeDocument/2006/math" xmlns:w="http://schemas.openxmlformats.org/wordprocessingml/2006/main" autoCompressPictures="0" saveSubsetFonts="1">
+<p:presentation xmlns:a="http://schemas.openxmlformats.org/drawingml/2006/main" xmlns:r="http://schemas.openxmlformats.org/officeDocument/2006/relationships" xmlns:p="http://schemas.openxmlformats.org/presentationml/2006/main" saveSubsetFonts="1" autoCompressPictures="0">
   <p:sldMasterIdLst>
     <p:sldMasterId id="2147483648" r:id="rId1"/>
   </p:sldMasterIdLst>
   <p:notesMasterIdLst>
-    <p:notesMasterId r:id="rId10"/>
+    <p:notesMasterId r:id="rId9"/>
   </p:notesMasterIdLst>
   <p:sldIdLst>
-    <p:sldId id="256" r:id="rId3"/>
-    <p:sldId id="257" r:id="rId4"/>
-    <p:sldId id="258" r:id="rId5"/>
-    <p:sldId id="259" r:id="rId6"/>
-    <p:sldId id="260" r:id="rId7"/>
-    <p:sldId id="261" r:id="rId8"/>
-    <p:sldId id="262" r:id="rId9"/>
+    <p:sldId id="256" r:id="rId2"/>
+    <p:sldId id="257" r:id="rId3"/>
+    <p:sldId id="258" r:id="rId4"/>
+    <p:sldId id="259" r:id="rId5"/>
+    <p:sldId id="260" r:id="rId6"/>
+    <p:sldId id="261" r:id="rId7"/>
+    <p:sldId id="262" r:id="rId8"/>
   </p:sldIdLst>
-  <p:sldSz cx="9144000" cy="5143500"/>
+  <p:sldSz cx="9144000" cy="5143500" type="screen16x9"/>
   <p:notesSz cx="5143500" cy="9144000"/>
   <p:defaultTextStyle>
     <a:lvl1pPr marL="0" algn="l" defTabSz="914400" rtl="0">
@@ -110,12 +110,28 @@
       </a:defRPr>
     </a:lvl9pPr>
   </p:defaultTextStyle>
+  <p:extLst>
+    <p:ext uri="{EFAFB233-063F-42B5-8137-9DF3F51BA10A}">
+      <p15:sldGuideLst xmlns:p15="http://schemas.microsoft.com/office/powerpoint/2012/main">
+        <p15:guide id="1" pos="2880">
+          <p15:clr>
+            <a:srgbClr val="A4A3A4"/>
+          </p15:clr>
+        </p15:guide>
+        <p15:guide id="2" orient="horz" pos="1620">
+          <p15:clr>
+            <a:srgbClr val="A4A3A4"/>
+          </p15:clr>
+        </p15:guide>
+      </p15:sldGuideLst>
+    </p:ext>
+  </p:extLst>
 </p:presentation>
 </file>
 
 <file path=ppt/notesMasters/notesMaster1.xml><?xml version="1.0" encoding="utf-8"?>
 <p:notesMaster xmlns:a="http://schemas.openxmlformats.org/drawingml/2006/main" xmlns:r="http://schemas.openxmlformats.org/officeDocument/2006/relationships" xmlns:p="http://schemas.openxmlformats.org/presentationml/2006/main">
-  <p:cSld name="">
+  <p:cSld>
     <p:bg>
       <p:bgRef idx="1001">
         <a:schemeClr val="bg1"/>
@@ -201,7 +217,7 @@
             </a:pPr>
             <a:fld id="{5282F153-3F37-0F45-9E97-73ACFA13230C}" type="datetimeFigureOut">
               <a:rPr lang="en-US"/>
-              <a:t>7/23/19</a:t>
+              <a:t>4/19/26</a:t>
             </a:fld>
             <a:endParaRPr lang="en-US"/>
           </a:p>
@@ -211,7 +227,7 @@
         <p:nvSpPr>
           <p:cNvPr id="1658878560" name="Slide Image Placeholder 3"/>
           <p:cNvSpPr>
-            <a:spLocks noChangeAspect="1" noGrp="1" noRot="1"/>
+            <a:spLocks noGrp="1" noRot="1" noChangeAspect="1"/>
           </p:cNvSpPr>
           <p:nvPr>
             <p:ph type="sldImg" idx="2"/>
@@ -488,8 +504,8 @@
 </file>
 
 <file path=ppt/notesSlides/notesSlide1.xml><?xml version="1.0" encoding="utf-8"?>
-<p:notes xmlns:a="http://schemas.openxmlformats.org/drawingml/2006/main" xmlns:r="http://schemas.openxmlformats.org/officeDocument/2006/relationships" xmlns:p="http://schemas.openxmlformats.org/presentationml/2006/main" xmlns:m="http://schemas.openxmlformats.org/officeDocument/2006/math" xmlns:w="http://schemas.openxmlformats.org/wordprocessingml/2006/main">
-  <p:cSld name="">
+<p:notes xmlns:a="http://schemas.openxmlformats.org/drawingml/2006/main" xmlns:r="http://schemas.openxmlformats.org/officeDocument/2006/relationships" xmlns:p="http://schemas.openxmlformats.org/presentationml/2006/main">
+  <p:cSld>
     <p:spTree>
       <p:nvGrpSpPr>
         <p:cNvPr id="1" name=""/>
@@ -508,7 +524,7 @@
         <p:nvSpPr>
           <p:cNvPr id="1725351292" name="Slide Image Placeholder 1"/>
           <p:cNvSpPr>
-            <a:spLocks noChangeAspect="1" noGrp="1" noRot="1"/>
+            <a:spLocks noGrp="1" noRot="1" noChangeAspect="1"/>
           </p:cNvSpPr>
           <p:nvPr>
             <p:ph type="sldImg"/>
@@ -573,8 +589,8 @@
 </file>
 
 <file path=ppt/notesSlides/notesSlide2.xml><?xml version="1.0" encoding="utf-8"?>
-<p:notes xmlns:a="http://schemas.openxmlformats.org/drawingml/2006/main" xmlns:r="http://schemas.openxmlformats.org/officeDocument/2006/relationships" xmlns:p="http://schemas.openxmlformats.org/presentationml/2006/main" xmlns:m="http://schemas.openxmlformats.org/officeDocument/2006/math" xmlns:w="http://schemas.openxmlformats.org/wordprocessingml/2006/main">
-  <p:cSld name="">
+<p:notes xmlns:a="http://schemas.openxmlformats.org/drawingml/2006/main" xmlns:r="http://schemas.openxmlformats.org/officeDocument/2006/relationships" xmlns:p="http://schemas.openxmlformats.org/presentationml/2006/main">
+  <p:cSld>
     <p:spTree>
       <p:nvGrpSpPr>
         <p:cNvPr id="1" name=""/>
@@ -593,7 +609,7 @@
         <p:nvSpPr>
           <p:cNvPr id="1743582920" name="Slide Image Placeholder 1"/>
           <p:cNvSpPr>
-            <a:spLocks noChangeAspect="1" noGrp="1" noRot="1"/>
+            <a:spLocks noGrp="1" noRot="1" noChangeAspect="1"/>
           </p:cNvSpPr>
           <p:nvPr>
             <p:ph type="sldImg"/>
@@ -658,8 +674,8 @@
 </file>
 
 <file path=ppt/notesSlides/notesSlide3.xml><?xml version="1.0" encoding="utf-8"?>
-<p:notes xmlns:a="http://schemas.openxmlformats.org/drawingml/2006/main" xmlns:r="http://schemas.openxmlformats.org/officeDocument/2006/relationships" xmlns:p="http://schemas.openxmlformats.org/presentationml/2006/main" xmlns:m="http://schemas.openxmlformats.org/officeDocument/2006/math" xmlns:w="http://schemas.openxmlformats.org/wordprocessingml/2006/main">
-  <p:cSld name="">
+<p:notes xmlns:a="http://schemas.openxmlformats.org/drawingml/2006/main" xmlns:r="http://schemas.openxmlformats.org/officeDocument/2006/relationships" xmlns:p="http://schemas.openxmlformats.org/presentationml/2006/main">
+  <p:cSld>
     <p:spTree>
       <p:nvGrpSpPr>
         <p:cNvPr id="1" name=""/>
@@ -678,7 +694,7 @@
         <p:nvSpPr>
           <p:cNvPr id="1129161874" name="Slide Image Placeholder 1"/>
           <p:cNvSpPr>
-            <a:spLocks noChangeAspect="1" noGrp="1" noRot="1"/>
+            <a:spLocks noGrp="1" noRot="1" noChangeAspect="1"/>
           </p:cNvSpPr>
           <p:nvPr>
             <p:ph type="sldImg"/>
@@ -728,7 +744,7 @@
             </a:pPr>
             <a:fld id="{F6F08F0D-7539-486C-00E3-B9F988617589}" type="slidenum">
               <a:rPr lang="en-US"/>
-              <a:t/>
+              <a:t>3</a:t>
             </a:fld>
             <a:endParaRPr lang="en-US"/>
           </a:p>
@@ -743,8 +759,8 @@
 </file>
 
 <file path=ppt/notesSlides/notesSlide4.xml><?xml version="1.0" encoding="utf-8"?>
-<p:notes xmlns:a="http://schemas.openxmlformats.org/drawingml/2006/main" xmlns:r="http://schemas.openxmlformats.org/officeDocument/2006/relationships" xmlns:p="http://schemas.openxmlformats.org/presentationml/2006/main" xmlns:m="http://schemas.openxmlformats.org/officeDocument/2006/math" xmlns:w="http://schemas.openxmlformats.org/wordprocessingml/2006/main">
-  <p:cSld name="">
+<p:notes xmlns:a="http://schemas.openxmlformats.org/drawingml/2006/main" xmlns:r="http://schemas.openxmlformats.org/officeDocument/2006/relationships" xmlns:p="http://schemas.openxmlformats.org/presentationml/2006/main">
+  <p:cSld>
     <p:spTree>
       <p:nvGrpSpPr>
         <p:cNvPr id="1" name=""/>
@@ -763,7 +779,7 @@
         <p:nvSpPr>
           <p:cNvPr id="1090224040" name="Slide Image Placeholder 1"/>
           <p:cNvSpPr>
-            <a:spLocks noChangeAspect="1" noGrp="1" noRot="1"/>
+            <a:spLocks noGrp="1" noRot="1" noChangeAspect="1"/>
           </p:cNvSpPr>
           <p:nvPr>
             <p:ph type="sldImg"/>
@@ -813,7 +829,7 @@
             </a:pPr>
             <a:fld id="{0208E325-F849-A203-B3CC-E685AAE7F131}" type="slidenum">
               <a:rPr lang="en-US"/>
-              <a:t/>
+              <a:t>4</a:t>
             </a:fld>
             <a:endParaRPr lang="en-US"/>
           </a:p>
@@ -828,8 +844,8 @@
 </file>
 
 <file path=ppt/notesSlides/notesSlide5.xml><?xml version="1.0" encoding="utf-8"?>
-<p:notes xmlns:a="http://schemas.openxmlformats.org/drawingml/2006/main" xmlns:r="http://schemas.openxmlformats.org/officeDocument/2006/relationships" xmlns:p="http://schemas.openxmlformats.org/presentationml/2006/main" xmlns:m="http://schemas.openxmlformats.org/officeDocument/2006/math" xmlns:w="http://schemas.openxmlformats.org/wordprocessingml/2006/main">
-  <p:cSld name="">
+<p:notes xmlns:a="http://schemas.openxmlformats.org/drawingml/2006/main" xmlns:r="http://schemas.openxmlformats.org/officeDocument/2006/relationships" xmlns:p="http://schemas.openxmlformats.org/presentationml/2006/main">
+  <p:cSld>
     <p:spTree>
       <p:nvGrpSpPr>
         <p:cNvPr id="1" name=""/>
@@ -848,7 +864,7 @@
         <p:nvSpPr>
           <p:cNvPr id="666265878" name="Slide Image Placeholder 1"/>
           <p:cNvSpPr>
-            <a:spLocks noChangeAspect="1" noGrp="1" noRot="1"/>
+            <a:spLocks noGrp="1" noRot="1" noChangeAspect="1"/>
           </p:cNvSpPr>
           <p:nvPr>
             <p:ph type="sldImg"/>
@@ -898,7 +914,7 @@
             </a:pPr>
             <a:fld id="{F7021451-1387-4CA6-816F-3879F97B5CBC}" type="slidenum">
               <a:rPr lang="en-US"/>
-              <a:t>3</a:t>
+              <a:t>5</a:t>
             </a:fld>
             <a:endParaRPr lang="en-US"/>
           </a:p>
@@ -913,8 +929,8 @@
 </file>
 
 <file path=ppt/notesSlides/notesSlide6.xml><?xml version="1.0" encoding="utf-8"?>
-<p:notes xmlns:a="http://schemas.openxmlformats.org/drawingml/2006/main" xmlns:r="http://schemas.openxmlformats.org/officeDocument/2006/relationships" xmlns:p="http://schemas.openxmlformats.org/presentationml/2006/main" xmlns:m="http://schemas.openxmlformats.org/officeDocument/2006/math" xmlns:w="http://schemas.openxmlformats.org/wordprocessingml/2006/main">
-  <p:cSld name="">
+<p:notes xmlns:a="http://schemas.openxmlformats.org/drawingml/2006/main" xmlns:r="http://schemas.openxmlformats.org/officeDocument/2006/relationships" xmlns:p="http://schemas.openxmlformats.org/presentationml/2006/main">
+  <p:cSld>
     <p:spTree>
       <p:nvGrpSpPr>
         <p:cNvPr id="1" name=""/>
@@ -933,7 +949,7 @@
         <p:nvSpPr>
           <p:cNvPr id="753244270" name="Slide Image Placeholder 1"/>
           <p:cNvSpPr>
-            <a:spLocks noChangeAspect="1" noGrp="1" noRot="1"/>
+            <a:spLocks noGrp="1" noRot="1" noChangeAspect="1"/>
           </p:cNvSpPr>
           <p:nvPr>
             <p:ph type="sldImg"/>
@@ -983,7 +999,7 @@
             </a:pPr>
             <a:fld id="{F7021451-1387-4CA6-816F-3879F97B5CBC}" type="slidenum">
               <a:rPr lang="en-US"/>
-              <a:t>4</a:t>
+              <a:t>6</a:t>
             </a:fld>
             <a:endParaRPr lang="en-US"/>
           </a:p>
@@ -998,8 +1014,8 @@
 </file>
 
 <file path=ppt/notesSlides/notesSlide7.xml><?xml version="1.0" encoding="utf-8"?>
-<p:notes xmlns:a="http://schemas.openxmlformats.org/drawingml/2006/main" xmlns:r="http://schemas.openxmlformats.org/officeDocument/2006/relationships" xmlns:p="http://schemas.openxmlformats.org/presentationml/2006/main" xmlns:m="http://schemas.openxmlformats.org/officeDocument/2006/math" xmlns:w="http://schemas.openxmlformats.org/wordprocessingml/2006/main">
-  <p:cSld name="">
+<p:notes xmlns:a="http://schemas.openxmlformats.org/drawingml/2006/main" xmlns:r="http://schemas.openxmlformats.org/officeDocument/2006/relationships" xmlns:p="http://schemas.openxmlformats.org/presentationml/2006/main">
+  <p:cSld>
     <p:spTree>
       <p:nvGrpSpPr>
         <p:cNvPr id="1" name=""/>
@@ -1018,7 +1034,7 @@
         <p:nvSpPr>
           <p:cNvPr id="651021965" name="Slide Image Placeholder 1"/>
           <p:cNvSpPr>
-            <a:spLocks noChangeAspect="1" noGrp="1" noRot="1"/>
+            <a:spLocks noGrp="1" noRot="1" noChangeAspect="1"/>
           </p:cNvSpPr>
           <p:nvPr>
             <p:ph type="sldImg"/>
@@ -1068,7 +1084,7 @@
             </a:pPr>
             <a:fld id="{F7021451-1387-4CA6-816F-3879F97B5CBC}" type="slidenum">
               <a:rPr lang="en-US"/>
-              <a:t>5</a:t>
+              <a:t>7</a:t>
             </a:fld>
             <a:endParaRPr lang="en-US"/>
           </a:p>
@@ -1083,7 +1099,7 @@
 </file>
 
 <file path=ppt/slideLayouts/slideLayout1.xml><?xml version="1.0" encoding="utf-8"?>
-<p:sldLayout xmlns:a="http://schemas.openxmlformats.org/drawingml/2006/main" xmlns:r="http://schemas.openxmlformats.org/officeDocument/2006/relationships" xmlns:p="http://schemas.openxmlformats.org/presentationml/2006/main" xmlns:m="http://schemas.openxmlformats.org/officeDocument/2006/math" xmlns:w="http://schemas.openxmlformats.org/wordprocessingml/2006/main" matchingName="" preserve="1" showMasterPhAnim="0" showMasterSp="1" userDrawn="1">
+<p:sldLayout xmlns:a="http://schemas.openxmlformats.org/drawingml/2006/main" xmlns:r="http://schemas.openxmlformats.org/officeDocument/2006/relationships" xmlns:p="http://schemas.openxmlformats.org/presentationml/2006/main" showMasterPhAnim="0" preserve="1" userDrawn="1">
   <p:cSld name="DEFAULT">
     <p:bg>
       <p:bgRef idx="1001">
@@ -1113,8 +1129,13 @@
 </file>
 
 <file path=ppt/slideMasters/slideMaster1.xml><?xml version="1.0" encoding="utf-8"?>
-<p:sldMaster xmlns:a="http://schemas.openxmlformats.org/drawingml/2006/main" xmlns:r="http://schemas.openxmlformats.org/officeDocument/2006/relationships" xmlns:p="http://schemas.openxmlformats.org/presentationml/2006/main" xmlns:m="http://schemas.openxmlformats.org/officeDocument/2006/math" xmlns:w="http://schemas.openxmlformats.org/wordprocessingml/2006/main" preserve="0">
-  <p:cSld name="">
+<p:sldMaster xmlns:a="http://schemas.openxmlformats.org/drawingml/2006/main" xmlns:r="http://schemas.openxmlformats.org/officeDocument/2006/relationships" xmlns:p="http://schemas.openxmlformats.org/presentationml/2006/main">
+  <p:cSld>
+    <p:bg>
+      <p:bgRef idx="1001">
+        <a:schemeClr val="bg1"/>
+      </p:bgRef>
+    </p:bg>
     <p:spTree>
       <p:nvGrpSpPr>
         <p:cNvPr id="1" name=""/>
@@ -1135,7 +1156,7 @@
   <p:sldLayoutIdLst>
     <p:sldLayoutId id="2147483649" r:id="rId1"/>
   </p:sldLayoutIdLst>
-  <p:hf dt="0" ftr="0" hdr="0" sldNum="0"/>
+  <p:hf sldNum="0" hdr="0" ftr="0" dt="0"/>
   <p:txStyles>
     <p:titleStyle>
       <a:lvl1pPr algn="ctr" defTabSz="914400" rtl="0">
@@ -1390,15 +1411,16 @@
 </file>
 
 <file path=ppt/slides/slide1.xml><?xml version="1.0" encoding="utf-8"?>
-<p:sld xmlns:a="http://schemas.openxmlformats.org/drawingml/2006/main" xmlns:r="http://schemas.openxmlformats.org/officeDocument/2006/relationships" xmlns:p="http://schemas.openxmlformats.org/presentationml/2006/main" xmlns:m="http://schemas.openxmlformats.org/officeDocument/2006/math" xmlns:w="http://schemas.openxmlformats.org/wordprocessingml/2006/main" xmlns:mc="http://schemas.openxmlformats.org/markup-compatibility/2006" showMasterPhAnim="0" showMasterSp="1" show="1">
+<p:sld xmlns:a="http://schemas.openxmlformats.org/drawingml/2006/main" xmlns:r="http://schemas.openxmlformats.org/officeDocument/2006/relationships" xmlns:p="http://schemas.openxmlformats.org/presentationml/2006/main" showMasterPhAnim="0">
   <p:cSld name="Slide 1">
     <p:bg>
-      <p:bgPr shadeToTitle="0">
+      <p:bgPr>
         <a:solidFill>
           <a:schemeClr val="bg1">
             <a:lumMod val="95000"/>
           </a:schemeClr>
         </a:solidFill>
+        <a:effectLst/>
       </p:bgPr>
     </p:bg>
     <p:spTree>
@@ -1439,6 +1461,13 @@
             <a:prstDash val="solid"/>
           </a:ln>
         </p:spPr>
+        <p:txBody>
+          <a:bodyPr/>
+          <a:lstStyle/>
+          <a:p>
+            <a:endParaRPr lang="en-US"/>
+          </a:p>
+        </p:txBody>
       </p:sp>
       <p:sp>
         <p:nvSpPr>
@@ -1468,6 +1497,13 @@
             <a:prstDash val="solid"/>
           </a:ln>
         </p:spPr>
+        <p:txBody>
+          <a:bodyPr/>
+          <a:lstStyle/>
+          <a:p>
+            <a:endParaRPr lang="en-US"/>
+          </a:p>
+        </p:txBody>
       </p:sp>
       <p:sp>
         <p:nvSpPr>
@@ -1497,6 +1533,13 @@
             <a:prstDash val="solid"/>
           </a:ln>
         </p:spPr>
+        <p:txBody>
+          <a:bodyPr/>
+          <a:lstStyle/>
+          <a:p>
+            <a:endParaRPr lang="en-US"/>
+          </a:p>
+        </p:txBody>
       </p:sp>
       <p:sp>
         <p:nvSpPr>
@@ -1526,6 +1569,13 @@
             <a:prstDash val="solid"/>
           </a:ln>
         </p:spPr>
+        <p:txBody>
+          <a:bodyPr/>
+          <a:lstStyle/>
+          <a:p>
+            <a:endParaRPr lang="en-US"/>
+          </a:p>
+        </p:txBody>
       </p:sp>
       <p:sp>
         <p:nvSpPr>
@@ -1555,6 +1605,13 @@
             <a:prstDash val="solid"/>
           </a:ln>
         </p:spPr>
+        <p:txBody>
+          <a:bodyPr/>
+          <a:lstStyle/>
+          <a:p>
+            <a:endParaRPr lang="en-US"/>
+          </a:p>
+        </p:txBody>
       </p:sp>
       <p:sp>
         <p:nvSpPr>
@@ -1584,6 +1641,13 @@
             <a:prstDash val="solid"/>
           </a:ln>
         </p:spPr>
+        <p:txBody>
+          <a:bodyPr/>
+          <a:lstStyle/>
+          <a:p>
+            <a:endParaRPr lang="en-US"/>
+          </a:p>
+        </p:txBody>
       </p:sp>
       <p:sp>
         <p:nvSpPr>
@@ -1693,6 +1757,13 @@
             <a:prstDash val="solid"/>
           </a:ln>
         </p:spPr>
+        <p:txBody>
+          <a:bodyPr/>
+          <a:lstStyle/>
+          <a:p>
+            <a:endParaRPr lang="en-US"/>
+          </a:p>
+        </p:txBody>
       </p:sp>
       <p:sp>
         <p:nvSpPr>
@@ -1749,11 +1820,11 @@
   <p:clrMapOvr>
     <a:masterClrMapping/>
   </p:clrMapOvr>
-  <mc:AlternateContent xmlns:mc="http://schemas.openxmlformats.org/markup-compatibility/2006">
-    <mc:Choice xmlns:p159="http://schemas.microsoft.com/office/powerpoint/2015/09/main" xmlns:p14="http://schemas.microsoft.com/office/powerpoint/2010/main" Requires="p159">
-      <p:transition p14:dur="500" advClick="1"/>
+  <mc:AlternateContent xmlns:mc="http://schemas.openxmlformats.org/markup-compatibility/2006" xmlns:p159="http://schemas.microsoft.com/office/powerpoint/2015/09/main">
+    <mc:Choice Requires="p159">
+      <p:transition/>
     </mc:Choice>
-    <mc:Fallback>
+    <mc:Fallback xmlns:w="http://schemas.openxmlformats.org/wordprocessingml/2006/main" xmlns:m="http://schemas.openxmlformats.org/officeDocument/2006/math" xmlns="">
       <p:transition advClick="1"/>
     </mc:Fallback>
   </mc:AlternateContent>
@@ -1761,15 +1832,16 @@
 </file>
 
 <file path=ppt/slides/slide2.xml><?xml version="1.0" encoding="utf-8"?>
-<p:sld xmlns:a="http://schemas.openxmlformats.org/drawingml/2006/main" xmlns:r="http://schemas.openxmlformats.org/officeDocument/2006/relationships" xmlns:p="http://schemas.openxmlformats.org/presentationml/2006/main" xmlns:m="http://schemas.openxmlformats.org/officeDocument/2006/math" xmlns:w="http://schemas.openxmlformats.org/wordprocessingml/2006/main" xmlns:mc="http://schemas.openxmlformats.org/markup-compatibility/2006" showMasterPhAnim="0" showMasterSp="1" show="1">
+<p:sld xmlns:a="http://schemas.openxmlformats.org/drawingml/2006/main" xmlns:r="http://schemas.openxmlformats.org/officeDocument/2006/relationships" xmlns:p="http://schemas.openxmlformats.org/presentationml/2006/main" showMasterPhAnim="0">
   <p:cSld name="Slide 2">
     <p:bg>
-      <p:bgPr shadeToTitle="0">
+      <p:bgPr>
         <a:solidFill>
           <a:schemeClr val="bg1">
             <a:lumMod val="95000"/>
           </a:schemeClr>
         </a:solidFill>
+        <a:effectLst/>
       </p:bgPr>
     </p:bg>
     <p:spTree>
@@ -1810,6 +1882,13 @@
             <a:prstDash val="solid"/>
           </a:ln>
         </p:spPr>
+        <p:txBody>
+          <a:bodyPr/>
+          <a:lstStyle/>
+          <a:p>
+            <a:endParaRPr lang="en-US"/>
+          </a:p>
+        </p:txBody>
       </p:sp>
       <p:sp>
         <p:nvSpPr>
@@ -1853,12 +1932,12 @@
       </p:sp>
       <p:sp>
         <p:nvSpPr>
-          <p:cNvPr id="2015799492" name=""/>
+          <p:cNvPr id="2015799492" name="TextBox 2015799491"/>
           <p:cNvSpPr txBox="1"/>
           <p:nvPr/>
         </p:nvSpPr>
         <p:spPr bwMode="auto">
-          <a:xfrm rot="0" flipH="0" flipV="0">
+          <a:xfrm>
             <a:off x="3294519" y="2388689"/>
             <a:ext cx="2554961" cy="366119"/>
           </a:xfrm>
@@ -1868,9 +1947,10 @@
           <a:noFill/>
         </p:spPr>
         <p:txBody>
-          <a:bodyPr vertOverflow="overflow" horzOverflow="overflow" vert="horz" wrap="none" lIns="91440" tIns="45720" rIns="91440" bIns="45720" numCol="1" spcCol="0" rtlCol="0" fromWordArt="0" anchor="t" anchorCtr="0" forceAA="0" upright="0" compatLnSpc="0">
+          <a:bodyPr vertOverflow="overflow" horzOverflow="overflow" vert="horz" wrap="none" lIns="91440" tIns="45720" rIns="91440" bIns="45720" numCol="1" spcCol="0" rtlCol="0" fromWordArt="0" anchor="t" anchorCtr="0" forceAA="0" compatLnSpc="0">
             <a:spAutoFit/>
           </a:bodyPr>
+          <a:lstStyle/>
           <a:p>
             <a:pPr>
               <a:defRPr/>
@@ -1888,11 +1968,11 @@
   <p:clrMapOvr>
     <a:masterClrMapping/>
   </p:clrMapOvr>
-  <mc:AlternateContent xmlns:mc="http://schemas.openxmlformats.org/markup-compatibility/2006">
-    <mc:Choice xmlns:p159="http://schemas.microsoft.com/office/powerpoint/2015/09/main" xmlns:p14="http://schemas.microsoft.com/office/powerpoint/2010/main" Requires="p159">
-      <p:transition p14:dur="500" advClick="1"/>
+  <mc:AlternateContent xmlns:mc="http://schemas.openxmlformats.org/markup-compatibility/2006" xmlns:p159="http://schemas.microsoft.com/office/powerpoint/2015/09/main">
+    <mc:Choice Requires="p159">
+      <p:transition/>
     </mc:Choice>
-    <mc:Fallback>
+    <mc:Fallback xmlns:w="http://schemas.openxmlformats.org/wordprocessingml/2006/main" xmlns:m="http://schemas.openxmlformats.org/officeDocument/2006/math" xmlns="">
       <p:transition advClick="1"/>
     </mc:Fallback>
   </mc:AlternateContent>
@@ -1900,15 +1980,16 @@
 </file>
 
 <file path=ppt/slides/slide3.xml><?xml version="1.0" encoding="utf-8"?>
-<p:sld xmlns:a="http://schemas.openxmlformats.org/drawingml/2006/main" xmlns:r="http://schemas.openxmlformats.org/officeDocument/2006/relationships" xmlns:p="http://schemas.openxmlformats.org/presentationml/2006/main" xmlns:m="http://schemas.openxmlformats.org/officeDocument/2006/math" xmlns:w="http://schemas.openxmlformats.org/wordprocessingml/2006/main" xmlns:mc="http://schemas.openxmlformats.org/markup-compatibility/2006" showMasterPhAnim="0" showMasterSp="1" show="1">
+<p:sld xmlns:a="http://schemas.openxmlformats.org/drawingml/2006/main" xmlns:r="http://schemas.openxmlformats.org/officeDocument/2006/relationships" xmlns:p="http://schemas.openxmlformats.org/presentationml/2006/main" showMasterPhAnim="0">
   <p:cSld name="Slide 2">
     <p:bg>
-      <p:bgPr shadeToTitle="0">
+      <p:bgPr>
         <a:solidFill>
           <a:schemeClr val="bg1">
             <a:lumMod val="95000"/>
           </a:schemeClr>
         </a:solidFill>
+        <a:effectLst/>
       </p:bgPr>
     </p:bg>
     <p:spTree>
@@ -1949,6 +2030,13 @@
             <a:prstDash val="solid"/>
           </a:ln>
         </p:spPr>
+        <p:txBody>
+          <a:bodyPr/>
+          <a:lstStyle/>
+          <a:p>
+            <a:endParaRPr lang="en-US"/>
+          </a:p>
+        </p:txBody>
       </p:sp>
       <p:sp>
         <p:nvSpPr>
@@ -1997,7 +2085,7 @@
           <p:nvPr/>
         </p:nvSpPr>
         <p:spPr bwMode="auto">
-          <a:xfrm flipH="0" flipV="0">
+          <a:xfrm>
             <a:off x="206301" y="995773"/>
             <a:ext cx="8731393" cy="770699"/>
           </a:xfrm>
@@ -2014,13 +2102,20 @@
             <a:prstDash val="solid"/>
           </a:ln>
           <a:effectLst>
-            <a:outerShdw blurRad="101600" dist="25400" dir="8100000" sx="100000" sy="100000" kx="0" ky="0" algn="bl" rotWithShape="0">
+            <a:outerShdw blurRad="101600" dist="25400" dir="8100000" algn="bl" rotWithShape="0">
               <a:srgbClr val="000000">
                 <a:alpha val="10000"/>
               </a:srgbClr>
             </a:outerShdw>
           </a:effectLst>
         </p:spPr>
+        <p:txBody>
+          <a:bodyPr/>
+          <a:lstStyle/>
+          <a:p>
+            <a:endParaRPr lang="en-US"/>
+          </a:p>
+        </p:txBody>
       </p:sp>
       <p:sp>
         <p:nvSpPr>
@@ -2029,7 +2124,7 @@
           <p:nvPr/>
         </p:nvSpPr>
         <p:spPr bwMode="auto">
-          <a:xfrm flipH="0" flipV="0">
+          <a:xfrm>
             <a:off x="206301" y="1901716"/>
             <a:ext cx="8731393" cy="770699"/>
           </a:xfrm>
@@ -2046,13 +2141,20 @@
             <a:prstDash val="solid"/>
           </a:ln>
           <a:effectLst>
-            <a:outerShdw blurRad="101600" dist="25400" dir="8100000" sx="100000" sy="100000" kx="0" ky="0" algn="bl" rotWithShape="0">
+            <a:outerShdw blurRad="101600" dist="25400" dir="8100000" algn="bl" rotWithShape="0">
               <a:srgbClr val="000000">
                 <a:alpha val="10000"/>
               </a:srgbClr>
             </a:outerShdw>
           </a:effectLst>
         </p:spPr>
+        <p:txBody>
+          <a:bodyPr/>
+          <a:lstStyle/>
+          <a:p>
+            <a:endParaRPr lang="en-US"/>
+          </a:p>
+        </p:txBody>
       </p:sp>
       <p:sp>
         <p:nvSpPr>
@@ -2061,7 +2163,7 @@
           <p:nvPr/>
         </p:nvSpPr>
         <p:spPr bwMode="auto">
-          <a:xfrm flipH="0" flipV="0">
+          <a:xfrm>
             <a:off x="206301" y="2807660"/>
             <a:ext cx="8731393" cy="770699"/>
           </a:xfrm>
@@ -2078,13 +2180,20 @@
             <a:prstDash val="solid"/>
           </a:ln>
           <a:effectLst>
-            <a:outerShdw blurRad="101600" dist="25400" dir="8100000" sx="100000" sy="100000" kx="0" ky="0" algn="bl" rotWithShape="0">
+            <a:outerShdw blurRad="101600" dist="25400" dir="8100000" algn="bl" rotWithShape="0">
               <a:srgbClr val="000000">
                 <a:alpha val="10000"/>
               </a:srgbClr>
             </a:outerShdw>
           </a:effectLst>
         </p:spPr>
+        <p:txBody>
+          <a:bodyPr/>
+          <a:lstStyle/>
+          <a:p>
+            <a:endParaRPr lang="en-US"/>
+          </a:p>
+        </p:txBody>
       </p:sp>
       <p:sp>
         <p:nvSpPr>
@@ -2093,7 +2202,7 @@
           <p:nvPr/>
         </p:nvSpPr>
         <p:spPr bwMode="auto">
-          <a:xfrm flipH="0" flipV="0">
+          <a:xfrm>
             <a:off x="206301" y="3713603"/>
             <a:ext cx="8731393" cy="770699"/>
           </a:xfrm>
@@ -2110,17 +2219,24 @@
             <a:prstDash val="solid"/>
           </a:ln>
           <a:effectLst>
-            <a:outerShdw blurRad="101600" dist="25400" dir="8100000" sx="100000" sy="100000" kx="0" ky="0" algn="bl" rotWithShape="0">
+            <a:outerShdw blurRad="101600" dist="25400" dir="8100000" algn="bl" rotWithShape="0">
               <a:srgbClr val="000000">
                 <a:alpha val="10000"/>
               </a:srgbClr>
             </a:outerShdw>
           </a:effectLst>
         </p:spPr>
-      </p:sp>
-      <p:sp modelId="{A8BC8CD6-8738-41EA-9E71-3CD4C9AF2582}">
-        <p:nvSpPr>
-          <p:cNvPr id="1983877742" name=""/>
+        <p:txBody>
+          <a:bodyPr/>
+          <a:lstStyle/>
+          <a:p>
+            <a:endParaRPr lang="en-US"/>
+          </a:p>
+        </p:txBody>
+      </p:sp>
+      <p:sp>
+        <p:nvSpPr>
+          <p:cNvPr id="1983877742" name="Rectangle 1983877741"/>
           <p:cNvSpPr/>
           <p:nvPr/>
         </p:nvSpPr>
@@ -2164,10 +2280,17 @@
             <a:schemeClr val="lt1"/>
           </a:fontRef>
         </p:style>
-      </p:sp>
-      <p:sp modelId="{B63312C8-A8E7-471C-BDC7-E288FC589C93}">
-        <p:nvSpPr>
-          <p:cNvPr id="56121892" name=""/>
+        <p:txBody>
+          <a:bodyPr/>
+          <a:lstStyle/>
+          <a:p>
+            <a:endParaRPr lang="en-US"/>
+          </a:p>
+        </p:txBody>
+      </p:sp>
+      <p:sp>
+        <p:nvSpPr>
+          <p:cNvPr id="56121892" name="Rectangle 56121891"/>
           <p:cNvSpPr/>
           <p:nvPr/>
         </p:nvSpPr>
@@ -2211,10 +2334,17 @@
             <a:schemeClr val="lt1"/>
           </a:fontRef>
         </p:style>
-      </p:sp>
-      <p:sp modelId="{CA7E8371-02DB-4E6B-BDD4-4E6725844AB0}">
-        <p:nvSpPr>
-          <p:cNvPr id="1228927024" name=""/>
+        <p:txBody>
+          <a:bodyPr/>
+          <a:lstStyle/>
+          <a:p>
+            <a:endParaRPr lang="en-US"/>
+          </a:p>
+        </p:txBody>
+      </p:sp>
+      <p:sp>
+        <p:nvSpPr>
+          <p:cNvPr id="1228927024" name="Rectangle 1228927023"/>
           <p:cNvSpPr/>
           <p:nvPr/>
         </p:nvSpPr>
@@ -2258,10 +2388,17 @@
             <a:schemeClr val="lt1"/>
           </a:fontRef>
         </p:style>
-      </p:sp>
-      <p:sp modelId="{CA7E8371-02DB-4E6B-BDD4-4E6725844AB0}">
-        <p:nvSpPr>
-          <p:cNvPr id="432296538" name=""/>
+        <p:txBody>
+          <a:bodyPr/>
+          <a:lstStyle/>
+          <a:p>
+            <a:endParaRPr lang="en-US"/>
+          </a:p>
+        </p:txBody>
+      </p:sp>
+      <p:sp>
+        <p:nvSpPr>
+          <p:cNvPr id="432296538" name="Rectangle 432296537"/>
           <p:cNvSpPr/>
           <p:nvPr/>
         </p:nvSpPr>
@@ -2300,6 +2437,7 @@
         </p:style>
         <p:txBody>
           <a:bodyPr anchor="ctr"/>
+          <a:lstStyle/>
           <a:p>
             <a:pPr algn="ctr">
               <a:defRPr/>
@@ -2310,12 +2448,12 @@
       </p:sp>
       <p:sp>
         <p:nvSpPr>
-          <p:cNvPr id="1428342454" name=""/>
+          <p:cNvPr id="1428342454" name="TextBox 1428342453"/>
           <p:cNvSpPr txBox="1"/>
           <p:nvPr/>
         </p:nvSpPr>
         <p:spPr bwMode="auto">
-          <a:xfrm rot="0" flipH="0" flipV="0">
+          <a:xfrm>
             <a:off x="1029360" y="1198243"/>
             <a:ext cx="7567076" cy="366118"/>
           </a:xfrm>
@@ -2325,9 +2463,10 @@
           <a:noFill/>
         </p:spPr>
         <p:txBody>
-          <a:bodyPr vertOverflow="overflow" horzOverflow="overflow" vert="horz" wrap="square" lIns="91440" tIns="45720" rIns="91440" bIns="45720" numCol="1" spcCol="0" rtlCol="0" fromWordArt="0" anchor="t" anchorCtr="0" forceAA="0" upright="0" compatLnSpc="0">
+          <a:bodyPr vertOverflow="overflow" horzOverflow="overflow" vert="horz" wrap="square" lIns="91440" tIns="45720" rIns="91440" bIns="45720" numCol="1" spcCol="0" rtlCol="0" fromWordArt="0" anchor="t" anchorCtr="0" forceAA="0" compatLnSpc="0">
             <a:spAutoFit/>
           </a:bodyPr>
+          <a:lstStyle/>
           <a:p>
             <a:pPr marL="0" lvl="0" indent="0" algn="l" defTabSz="1111248">
               <a:lnSpc>
@@ -2359,12 +2498,12 @@
       </p:sp>
       <p:sp>
         <p:nvSpPr>
-          <p:cNvPr id="1555854711" name=""/>
+          <p:cNvPr id="1555854711" name="TextBox 1555854710"/>
           <p:cNvSpPr txBox="1"/>
           <p:nvPr/>
         </p:nvSpPr>
         <p:spPr bwMode="auto">
-          <a:xfrm rot="0" flipH="0" flipV="0">
+          <a:xfrm>
             <a:off x="1029360" y="2104007"/>
             <a:ext cx="7567076" cy="366118"/>
           </a:xfrm>
@@ -2374,9 +2513,10 @@
           <a:noFill/>
         </p:spPr>
         <p:txBody>
-          <a:bodyPr vertOverflow="overflow" horzOverflow="overflow" vert="horz" wrap="square" lIns="91440" tIns="45720" rIns="91440" bIns="45720" numCol="1" spcCol="0" rtlCol="0" fromWordArt="0" anchor="t" anchorCtr="0" forceAA="0" upright="0" compatLnSpc="0">
+          <a:bodyPr vertOverflow="overflow" horzOverflow="overflow" vert="horz" wrap="square" lIns="91440" tIns="45720" rIns="91440" bIns="45720" numCol="1" spcCol="0" rtlCol="0" fromWordArt="0" anchor="t" anchorCtr="0" forceAA="0" compatLnSpc="0">
             <a:spAutoFit/>
           </a:bodyPr>
+          <a:lstStyle/>
           <a:p>
             <a:pPr marL="0" lvl="0" indent="0" algn="l" defTabSz="1111248">
               <a:lnSpc>
@@ -2408,12 +2548,12 @@
       </p:sp>
       <p:sp>
         <p:nvSpPr>
-          <p:cNvPr id="196038368" name=""/>
+          <p:cNvPr id="196038368" name="TextBox 196038367"/>
           <p:cNvSpPr txBox="1"/>
           <p:nvPr/>
         </p:nvSpPr>
         <p:spPr bwMode="auto">
-          <a:xfrm rot="0" flipH="0" flipV="0">
+          <a:xfrm>
             <a:off x="1029360" y="3009951"/>
             <a:ext cx="7567076" cy="366118"/>
           </a:xfrm>
@@ -2423,9 +2563,10 @@
           <a:noFill/>
         </p:spPr>
         <p:txBody>
-          <a:bodyPr vertOverflow="overflow" horzOverflow="overflow" vert="horz" wrap="square" lIns="91440" tIns="45720" rIns="91440" bIns="45720" numCol="1" spcCol="0" rtlCol="0" fromWordArt="0" anchor="t" anchorCtr="0" forceAA="0" upright="0" compatLnSpc="0">
+          <a:bodyPr vertOverflow="overflow" horzOverflow="overflow" vert="horz" wrap="square" lIns="91440" tIns="45720" rIns="91440" bIns="45720" numCol="1" spcCol="0" rtlCol="0" fromWordArt="0" anchor="t" anchorCtr="0" forceAA="0" compatLnSpc="0">
             <a:spAutoFit/>
           </a:bodyPr>
+          <a:lstStyle/>
           <a:p>
             <a:pPr marL="0" lvl="0" indent="0" algn="l" defTabSz="1111248">
               <a:lnSpc>
@@ -2457,12 +2598,12 @@
       </p:sp>
       <p:sp>
         <p:nvSpPr>
-          <p:cNvPr id="2125783183" name=""/>
+          <p:cNvPr id="2125783183" name="TextBox 2125783182"/>
           <p:cNvSpPr txBox="1"/>
           <p:nvPr/>
         </p:nvSpPr>
         <p:spPr bwMode="auto">
-          <a:xfrm rot="0" flipH="0" flipV="0">
+          <a:xfrm>
             <a:off x="1028281" y="3915893"/>
             <a:ext cx="7568875" cy="366118"/>
           </a:xfrm>
@@ -2472,9 +2613,10 @@
           <a:noFill/>
         </p:spPr>
         <p:txBody>
-          <a:bodyPr vertOverflow="overflow" horzOverflow="overflow" vert="horz" wrap="square" lIns="91440" tIns="45720" rIns="91440" bIns="45720" numCol="1" spcCol="0" rtlCol="0" fromWordArt="0" anchor="t" anchorCtr="0" forceAA="0" upright="0" compatLnSpc="0">
+          <a:bodyPr vertOverflow="overflow" horzOverflow="overflow" vert="horz" wrap="square" lIns="91440" tIns="45720" rIns="91440" bIns="45720" numCol="1" spcCol="0" rtlCol="0" fromWordArt="0" anchor="t" anchorCtr="0" forceAA="0" compatLnSpc="0">
             <a:spAutoFit/>
           </a:bodyPr>
+          <a:lstStyle/>
           <a:p>
             <a:pPr marL="0" indent="0" algn="l">
               <a:buNone/>
@@ -2500,11 +2642,11 @@
   <p:clrMapOvr>
     <a:masterClrMapping/>
   </p:clrMapOvr>
-  <mc:AlternateContent xmlns:mc="http://schemas.openxmlformats.org/markup-compatibility/2006">
-    <mc:Choice xmlns:p159="http://schemas.microsoft.com/office/powerpoint/2015/09/main" xmlns:p14="http://schemas.microsoft.com/office/powerpoint/2010/main" Requires="p159">
-      <p:transition p14:dur="500" advClick="1"/>
+  <mc:AlternateContent xmlns:mc="http://schemas.openxmlformats.org/markup-compatibility/2006" xmlns:p159="http://schemas.microsoft.com/office/powerpoint/2015/09/main">
+    <mc:Choice Requires="p159">
+      <p:transition/>
     </mc:Choice>
-    <mc:Fallback>
+    <mc:Fallback xmlns:w="http://schemas.openxmlformats.org/wordprocessingml/2006/main" xmlns:m="http://schemas.openxmlformats.org/officeDocument/2006/math" xmlns="">
       <p:transition advClick="1"/>
     </mc:Fallback>
   </mc:AlternateContent>
@@ -2512,15 +2654,16 @@
 </file>
 
 <file path=ppt/slides/slide4.xml><?xml version="1.0" encoding="utf-8"?>
-<p:sld xmlns:a="http://schemas.openxmlformats.org/drawingml/2006/main" xmlns:r="http://schemas.openxmlformats.org/officeDocument/2006/relationships" xmlns:p="http://schemas.openxmlformats.org/presentationml/2006/main" xmlns:m="http://schemas.openxmlformats.org/officeDocument/2006/math" xmlns:w="http://schemas.openxmlformats.org/wordprocessingml/2006/main" xmlns:mc="http://schemas.openxmlformats.org/markup-compatibility/2006" showMasterPhAnim="0" showMasterSp="1" show="1">
+<p:sld xmlns:a="http://schemas.openxmlformats.org/drawingml/2006/main" xmlns:r="http://schemas.openxmlformats.org/officeDocument/2006/relationships" xmlns:p="http://schemas.openxmlformats.org/presentationml/2006/main" showMasterPhAnim="0">
   <p:cSld name="Slide 2">
     <p:bg>
-      <p:bgPr shadeToTitle="0">
+      <p:bgPr>
         <a:solidFill>
           <a:schemeClr val="bg1">
             <a:lumMod val="95000"/>
           </a:schemeClr>
         </a:solidFill>
+        <a:effectLst/>
       </p:bgPr>
     </p:bg>
     <p:spTree>
@@ -2561,6 +2704,13 @@
             <a:prstDash val="solid"/>
           </a:ln>
         </p:spPr>
+        <p:txBody>
+          <a:bodyPr/>
+          <a:lstStyle/>
+          <a:p>
+            <a:endParaRPr lang="en-US"/>
+          </a:p>
+        </p:txBody>
       </p:sp>
       <p:sp>
         <p:nvSpPr>
@@ -2626,13 +2776,20 @@
             <a:prstDash val="solid"/>
           </a:ln>
           <a:effectLst>
-            <a:outerShdw blurRad="101600" dist="25400" dir="8100000" sx="100000" sy="100000" kx="0" ky="0" algn="bl" rotWithShape="0">
+            <a:outerShdw blurRad="101600" dist="25400" dir="8100000" algn="bl" rotWithShape="0">
               <a:srgbClr val="000000">
                 <a:alpha val="10000"/>
               </a:srgbClr>
             </a:outerShdw>
           </a:effectLst>
         </p:spPr>
+        <p:txBody>
+          <a:bodyPr/>
+          <a:lstStyle/>
+          <a:p>
+            <a:endParaRPr lang="en-US"/>
+          </a:p>
+        </p:txBody>
       </p:sp>
       <p:sp>
         <p:nvSpPr>
@@ -2658,6 +2815,13 @@
             <a:prstDash val="solid"/>
           </a:ln>
         </p:spPr>
+        <p:txBody>
+          <a:bodyPr/>
+          <a:lstStyle/>
+          <a:p>
+            <a:endParaRPr lang="en-US"/>
+          </a:p>
+        </p:txBody>
       </p:sp>
       <p:sp>
         <p:nvSpPr>
@@ -2683,6 +2847,13 @@
             <a:prstDash val="solid"/>
           </a:ln>
         </p:spPr>
+        <p:txBody>
+          <a:bodyPr/>
+          <a:lstStyle/>
+          <a:p>
+            <a:endParaRPr lang="en-US"/>
+          </a:p>
+        </p:txBody>
       </p:sp>
       <p:pic>
         <p:nvPicPr>
@@ -2821,6 +2992,13 @@
             <a:prstDash val="solid"/>
           </a:ln>
         </p:spPr>
+        <p:txBody>
+          <a:bodyPr/>
+          <a:lstStyle/>
+          <a:p>
+            <a:endParaRPr lang="en-US"/>
+          </a:p>
+        </p:txBody>
       </p:sp>
       <p:sp>
         <p:nvSpPr>
@@ -2846,6 +3024,13 @@
             <a:prstDash val="solid"/>
           </a:ln>
         </p:spPr>
+        <p:txBody>
+          <a:bodyPr/>
+          <a:lstStyle/>
+          <a:p>
+            <a:endParaRPr lang="en-US"/>
+          </a:p>
+        </p:txBody>
       </p:sp>
       <p:sp>
         <p:nvSpPr>
@@ -2933,6 +3118,13 @@
             <a:prstDash val="solid"/>
           </a:ln>
         </p:spPr>
+        <p:txBody>
+          <a:bodyPr/>
+          <a:lstStyle/>
+          <a:p>
+            <a:endParaRPr lang="en-US"/>
+          </a:p>
+        </p:txBody>
       </p:sp>
       <p:sp>
         <p:nvSpPr>
@@ -3009,6 +3201,13 @@
             <a:prstDash val="solid"/>
           </a:ln>
         </p:spPr>
+        <p:txBody>
+          <a:bodyPr/>
+          <a:lstStyle/>
+          <a:p>
+            <a:endParaRPr lang="en-US"/>
+          </a:p>
+        </p:txBody>
       </p:sp>
       <p:sp>
         <p:nvSpPr>
@@ -3074,6 +3273,13 @@
             <a:prstDash val="solid"/>
           </a:ln>
         </p:spPr>
+        <p:txBody>
+          <a:bodyPr/>
+          <a:lstStyle/>
+          <a:p>
+            <a:endParaRPr lang="en-US"/>
+          </a:p>
+        </p:txBody>
       </p:sp>
       <p:sp>
         <p:nvSpPr>
@@ -3139,6 +3345,13 @@
             <a:prstDash val="solid"/>
           </a:ln>
         </p:spPr>
+        <p:txBody>
+          <a:bodyPr/>
+          <a:lstStyle/>
+          <a:p>
+            <a:endParaRPr lang="en-US"/>
+          </a:p>
+        </p:txBody>
       </p:sp>
       <p:sp>
         <p:nvSpPr>
@@ -3204,13 +3417,20 @@
             <a:prstDash val="solid"/>
           </a:ln>
           <a:effectLst>
-            <a:outerShdw blurRad="101600" dist="25400" dir="8100000" sx="100000" sy="100000" kx="0" ky="0" algn="bl" rotWithShape="0">
+            <a:outerShdw blurRad="101600" dist="25400" dir="8100000" algn="bl" rotWithShape="0">
               <a:srgbClr val="000000">
                 <a:alpha val="10000"/>
               </a:srgbClr>
             </a:outerShdw>
           </a:effectLst>
         </p:spPr>
+        <p:txBody>
+          <a:bodyPr/>
+          <a:lstStyle/>
+          <a:p>
+            <a:endParaRPr lang="en-US"/>
+          </a:p>
+        </p:txBody>
       </p:sp>
       <p:sp>
         <p:nvSpPr>
@@ -3236,6 +3456,13 @@
             <a:prstDash val="solid"/>
           </a:ln>
         </p:spPr>
+        <p:txBody>
+          <a:bodyPr/>
+          <a:lstStyle/>
+          <a:p>
+            <a:endParaRPr lang="en-US"/>
+          </a:p>
+        </p:txBody>
       </p:sp>
       <p:sp>
         <p:nvSpPr>
@@ -3261,6 +3488,13 @@
             <a:prstDash val="solid"/>
           </a:ln>
         </p:spPr>
+        <p:txBody>
+          <a:bodyPr/>
+          <a:lstStyle/>
+          <a:p>
+            <a:endParaRPr lang="en-US"/>
+          </a:p>
+        </p:txBody>
       </p:sp>
       <p:pic>
         <p:nvPicPr>
@@ -3388,6 +3622,13 @@
             <a:prstDash val="solid"/>
           </a:ln>
         </p:spPr>
+        <p:txBody>
+          <a:bodyPr/>
+          <a:lstStyle/>
+          <a:p>
+            <a:endParaRPr lang="en-US"/>
+          </a:p>
+        </p:txBody>
       </p:sp>
       <p:sp>
         <p:nvSpPr>
@@ -3413,6 +3654,13 @@
             <a:prstDash val="solid"/>
           </a:ln>
         </p:spPr>
+        <p:txBody>
+          <a:bodyPr/>
+          <a:lstStyle/>
+          <a:p>
+            <a:endParaRPr lang="en-US"/>
+          </a:p>
+        </p:txBody>
       </p:sp>
       <p:sp>
         <p:nvSpPr>
@@ -3478,6 +3726,13 @@
             <a:prstDash val="solid"/>
           </a:ln>
         </p:spPr>
+        <p:txBody>
+          <a:bodyPr/>
+          <a:lstStyle/>
+          <a:p>
+            <a:endParaRPr lang="en-US"/>
+          </a:p>
+        </p:txBody>
       </p:sp>
       <p:sp>
         <p:nvSpPr>
@@ -3543,13 +3798,20 @@
             <a:prstDash val="solid"/>
           </a:ln>
           <a:effectLst>
-            <a:outerShdw blurRad="101600" dist="25400" dir="8100000" sx="100000" sy="100000" kx="0" ky="0" algn="bl" rotWithShape="0">
+            <a:outerShdw blurRad="101600" dist="25400" dir="8100000" algn="bl" rotWithShape="0">
               <a:srgbClr val="000000">
                 <a:alpha val="10000"/>
               </a:srgbClr>
             </a:outerShdw>
           </a:effectLst>
         </p:spPr>
+        <p:txBody>
+          <a:bodyPr/>
+          <a:lstStyle/>
+          <a:p>
+            <a:endParaRPr lang="en-US"/>
+          </a:p>
+        </p:txBody>
       </p:sp>
       <p:sp>
         <p:nvSpPr>
@@ -3575,6 +3837,13 @@
             <a:prstDash val="solid"/>
           </a:ln>
         </p:spPr>
+        <p:txBody>
+          <a:bodyPr/>
+          <a:lstStyle/>
+          <a:p>
+            <a:endParaRPr lang="en-US"/>
+          </a:p>
+        </p:txBody>
       </p:sp>
       <p:sp>
         <p:nvSpPr>
@@ -3600,6 +3869,13 @@
             <a:prstDash val="solid"/>
           </a:ln>
         </p:spPr>
+        <p:txBody>
+          <a:bodyPr/>
+          <a:lstStyle/>
+          <a:p>
+            <a:endParaRPr lang="en-US"/>
+          </a:p>
+        </p:txBody>
       </p:sp>
       <p:pic>
         <p:nvPicPr>
@@ -3727,6 +4003,13 @@
             <a:prstDash val="solid"/>
           </a:ln>
         </p:spPr>
+        <p:txBody>
+          <a:bodyPr/>
+          <a:lstStyle/>
+          <a:p>
+            <a:endParaRPr lang="en-US"/>
+          </a:p>
+        </p:txBody>
       </p:sp>
       <p:sp>
         <p:nvSpPr>
@@ -3752,6 +4035,13 @@
             <a:prstDash val="solid"/>
           </a:ln>
         </p:spPr>
+        <p:txBody>
+          <a:bodyPr/>
+          <a:lstStyle/>
+          <a:p>
+            <a:endParaRPr lang="en-US"/>
+          </a:p>
+        </p:txBody>
       </p:sp>
       <p:sp>
         <p:nvSpPr>
@@ -3795,7 +4085,7 @@
       </p:sp>
       <p:grpSp>
         <p:nvGrpSpPr>
-          <p:cNvPr id="1876734150" name=""/>
+          <p:cNvPr id="1876734150" name="Group 1876734149"/>
           <p:cNvGrpSpPr/>
           <p:nvPr/>
         </p:nvGrpSpPr>
@@ -3831,6 +4121,13 @@
               <a:prstDash val="solid"/>
             </a:ln>
           </p:spPr>
+          <p:txBody>
+            <a:bodyPr/>
+            <a:lstStyle/>
+            <a:p>
+              <a:endParaRPr lang="en-US"/>
+            </a:p>
+          </p:txBody>
         </p:sp>
         <p:sp>
           <p:nvSpPr>
@@ -3897,6 +4194,13 @@
             <a:prstDash val="solid"/>
           </a:ln>
         </p:spPr>
+        <p:txBody>
+          <a:bodyPr/>
+          <a:lstStyle/>
+          <a:p>
+            <a:endParaRPr lang="en-US"/>
+          </a:p>
+        </p:txBody>
       </p:sp>
       <p:sp>
         <p:nvSpPr>
@@ -4002,17 +4306,24 @@
             <a:prstDash val="solid"/>
           </a:ln>
         </p:spPr>
+        <p:txBody>
+          <a:bodyPr/>
+          <a:lstStyle/>
+          <a:p>
+            <a:endParaRPr lang="en-US"/>
+          </a:p>
+        </p:txBody>
       </p:sp>
     </p:spTree>
   </p:cSld>
   <p:clrMapOvr>
     <a:masterClrMapping/>
   </p:clrMapOvr>
-  <mc:AlternateContent xmlns:mc="http://schemas.openxmlformats.org/markup-compatibility/2006">
-    <mc:Choice xmlns:p159="http://schemas.microsoft.com/office/powerpoint/2015/09/main" xmlns:p14="http://schemas.microsoft.com/office/powerpoint/2010/main" Requires="p159">
-      <p:transition p14:dur="500" advClick="1"/>
+  <mc:AlternateContent xmlns:mc="http://schemas.openxmlformats.org/markup-compatibility/2006" xmlns:p159="http://schemas.microsoft.com/office/powerpoint/2015/09/main">
+    <mc:Choice Requires="p159">
+      <p:transition/>
     </mc:Choice>
-    <mc:Fallback>
+    <mc:Fallback xmlns:w="http://schemas.openxmlformats.org/wordprocessingml/2006/main" xmlns:m="http://schemas.openxmlformats.org/officeDocument/2006/math" xmlns="">
       <p:transition advClick="1"/>
     </mc:Fallback>
   </mc:AlternateContent>
@@ -4020,15 +4331,16 @@
 </file>
 
 <file path=ppt/slides/slide5.xml><?xml version="1.0" encoding="utf-8"?>
-<p:sld xmlns:a="http://schemas.openxmlformats.org/drawingml/2006/main" xmlns:r="http://schemas.openxmlformats.org/officeDocument/2006/relationships" xmlns:p="http://schemas.openxmlformats.org/presentationml/2006/main" xmlns:m="http://schemas.openxmlformats.org/officeDocument/2006/math" xmlns:w="http://schemas.openxmlformats.org/wordprocessingml/2006/main" xmlns:mc="http://schemas.openxmlformats.org/markup-compatibility/2006" showMasterPhAnim="0" showMasterSp="1" show="1">
+<p:sld xmlns:a="http://schemas.openxmlformats.org/drawingml/2006/main" xmlns:r="http://schemas.openxmlformats.org/officeDocument/2006/relationships" xmlns:p="http://schemas.openxmlformats.org/presentationml/2006/main" showMasterPhAnim="0">
   <p:cSld name="Slide 3">
     <p:bg>
-      <p:bgPr shadeToTitle="0">
+      <p:bgPr>
         <a:solidFill>
           <a:schemeClr val="bg1">
             <a:lumMod val="95000"/>
           </a:schemeClr>
         </a:solidFill>
+        <a:effectLst/>
       </p:bgPr>
     </p:bg>
     <p:spTree>
@@ -4069,6 +4381,13 @@
             <a:prstDash val="solid"/>
           </a:ln>
         </p:spPr>
+        <p:txBody>
+          <a:bodyPr/>
+          <a:lstStyle/>
+          <a:p>
+            <a:endParaRPr lang="en-US"/>
+          </a:p>
+        </p:txBody>
       </p:sp>
       <p:sp>
         <p:nvSpPr>
@@ -4117,7 +4436,7 @@
           <p:nvPr/>
         </p:nvSpPr>
         <p:spPr bwMode="auto">
-          <a:xfrm flipH="0" flipV="0">
+          <a:xfrm>
             <a:off x="201167" y="1112223"/>
             <a:ext cx="2194560" cy="3387674"/>
           </a:xfrm>
@@ -4134,13 +4453,20 @@
             <a:prstDash val="solid"/>
           </a:ln>
           <a:effectLst>
-            <a:outerShdw blurRad="76200" dist="25400" dir="8100000" sx="100000" sy="100000" kx="0" ky="0" algn="bl" rotWithShape="0">
+            <a:outerShdw blurRad="76200" dist="25400" dir="8100000" algn="bl" rotWithShape="0">
               <a:srgbClr val="000000">
                 <a:alpha val="9000"/>
               </a:srgbClr>
             </a:outerShdw>
           </a:effectLst>
         </p:spPr>
+        <p:txBody>
+          <a:bodyPr/>
+          <a:lstStyle/>
+          <a:p>
+            <a:endParaRPr lang="en-US"/>
+          </a:p>
+        </p:txBody>
       </p:sp>
       <p:sp>
         <p:nvSpPr>
@@ -4166,6 +4492,13 @@
             <a:prstDash val="solid"/>
           </a:ln>
         </p:spPr>
+        <p:txBody>
+          <a:bodyPr/>
+          <a:lstStyle/>
+          <a:p>
+            <a:endParaRPr lang="en-US"/>
+          </a:p>
+        </p:txBody>
       </p:sp>
       <p:sp>
         <p:nvSpPr>
@@ -4209,7 +4542,7 @@
       </p:sp>
       <p:grpSp>
         <p:nvGrpSpPr>
-          <p:cNvPr id="1901520704" name=""/>
+          <p:cNvPr id="1901520704" name="Group 1901520703"/>
           <p:cNvGrpSpPr/>
           <p:nvPr/>
         </p:nvGrpSpPr>
@@ -4245,6 +4578,13 @@
               <a:prstDash val="solid"/>
             </a:ln>
           </p:spPr>
+          <p:txBody>
+            <a:bodyPr/>
+            <a:lstStyle/>
+            <a:p>
+              <a:endParaRPr lang="en-US"/>
+            </a:p>
+          </p:txBody>
         </p:sp>
         <p:pic>
           <p:nvPicPr>
@@ -4311,7 +4651,7 @@
       </p:grpSp>
       <p:grpSp>
         <p:nvGrpSpPr>
-          <p:cNvPr id="550493900" name=""/>
+          <p:cNvPr id="550493900" name="Group 550493899"/>
           <p:cNvGrpSpPr/>
           <p:nvPr/>
         </p:nvGrpSpPr>
@@ -4347,13 +4687,20 @@
               <a:prstDash val="solid"/>
             </a:ln>
             <a:effectLst>
-              <a:outerShdw blurRad="76200" dist="25400" dir="8100000" sx="100000" sy="100000" kx="0" ky="0" algn="bl" rotWithShape="0">
+              <a:outerShdw blurRad="76200" dist="25400" dir="8100000" algn="bl" rotWithShape="0">
                 <a:srgbClr val="000000">
                   <a:alpha val="9000"/>
                 </a:srgbClr>
               </a:outerShdw>
             </a:effectLst>
           </p:spPr>
+          <p:txBody>
+            <a:bodyPr/>
+            <a:lstStyle/>
+            <a:p>
+              <a:endParaRPr lang="en-US"/>
+            </a:p>
+          </p:txBody>
         </p:sp>
         <p:sp>
           <p:nvSpPr>
@@ -4379,6 +4726,13 @@
               <a:prstDash val="solid"/>
             </a:ln>
           </p:spPr>
+          <p:txBody>
+            <a:bodyPr/>
+            <a:lstStyle/>
+            <a:p>
+              <a:endParaRPr lang="en-US"/>
+            </a:p>
+          </p:txBody>
         </p:sp>
         <p:sp>
           <p:nvSpPr>
@@ -4444,6 +4798,13 @@
               <a:prstDash val="solid"/>
             </a:ln>
           </p:spPr>
+          <p:txBody>
+            <a:bodyPr/>
+            <a:lstStyle/>
+            <a:p>
+              <a:endParaRPr lang="en-US"/>
+            </a:p>
+          </p:txBody>
         </p:sp>
         <p:sp>
           <p:nvSpPr>
@@ -4509,6 +4870,13 @@
               <a:prstDash val="solid"/>
             </a:ln>
           </p:spPr>
+          <p:txBody>
+            <a:bodyPr/>
+            <a:lstStyle/>
+            <a:p>
+              <a:endParaRPr lang="en-US"/>
+            </a:p>
+          </p:txBody>
         </p:sp>
         <p:sp>
           <p:nvSpPr>
@@ -4553,7 +4921,7 @@
       </p:grpSp>
       <p:grpSp>
         <p:nvGrpSpPr>
-          <p:cNvPr id="72862429" name=""/>
+          <p:cNvPr id="72862429" name="Group 72862428"/>
           <p:cNvGrpSpPr/>
           <p:nvPr/>
         </p:nvGrpSpPr>
@@ -4572,7 +4940,7 @@
             <p:nvPr/>
           </p:nvSpPr>
           <p:spPr bwMode="auto">
-            <a:xfrm flipH="0" flipV="0">
+            <a:xfrm>
               <a:off x="0" y="0"/>
               <a:ext cx="2194560" cy="845818"/>
             </a:xfrm>
@@ -4589,13 +4957,20 @@
               <a:prstDash val="solid"/>
             </a:ln>
             <a:effectLst>
-              <a:outerShdw blurRad="76200" dist="25400" dir="8100000" sx="100000" sy="100000" kx="0" ky="0" algn="bl" rotWithShape="0">
+              <a:outerShdw blurRad="76200" dist="25400" dir="8100000" algn="bl" rotWithShape="0">
                 <a:srgbClr val="000000">
                   <a:alpha val="9000"/>
                 </a:srgbClr>
               </a:outerShdw>
             </a:effectLst>
           </p:spPr>
+          <p:txBody>
+            <a:bodyPr/>
+            <a:lstStyle/>
+            <a:p>
+              <a:endParaRPr lang="en-US"/>
+            </a:p>
+          </p:txBody>
         </p:sp>
         <p:sp>
           <p:nvSpPr>
@@ -4621,6 +4996,13 @@
               <a:prstDash val="solid"/>
             </a:ln>
           </p:spPr>
+          <p:txBody>
+            <a:bodyPr/>
+            <a:lstStyle/>
+            <a:p>
+              <a:endParaRPr lang="en-US"/>
+            </a:p>
+          </p:txBody>
         </p:sp>
         <p:sp>
           <p:nvSpPr>
@@ -4686,6 +5068,13 @@
               <a:prstDash val="solid"/>
             </a:ln>
           </p:spPr>
+          <p:txBody>
+            <a:bodyPr/>
+            <a:lstStyle/>
+            <a:p>
+              <a:endParaRPr lang="en-US"/>
+            </a:p>
+          </p:txBody>
         </p:sp>
         <p:sp>
           <p:nvSpPr>
@@ -4730,7 +5119,7 @@
       </p:grpSp>
       <p:grpSp>
         <p:nvGrpSpPr>
-          <p:cNvPr id="456160677" name=""/>
+          <p:cNvPr id="456160677" name="Group 456160676"/>
           <p:cNvGrpSpPr/>
           <p:nvPr/>
         </p:nvGrpSpPr>
@@ -4766,13 +5155,20 @@
               <a:prstDash val="solid"/>
             </a:ln>
             <a:effectLst>
-              <a:outerShdw blurRad="76200" dist="25400" dir="8100000" sx="100000" sy="100000" kx="0" ky="0" algn="bl" rotWithShape="0">
+              <a:outerShdw blurRad="76200" dist="25400" dir="8100000" algn="bl" rotWithShape="0">
                 <a:srgbClr val="000000">
                   <a:alpha val="9000"/>
                 </a:srgbClr>
               </a:outerShdw>
             </a:effectLst>
           </p:spPr>
+          <p:txBody>
+            <a:bodyPr/>
+            <a:lstStyle/>
+            <a:p>
+              <a:endParaRPr lang="en-US"/>
+            </a:p>
+          </p:txBody>
         </p:sp>
         <p:sp>
           <p:nvSpPr>
@@ -4798,6 +5194,13 @@
               <a:prstDash val="solid"/>
             </a:ln>
           </p:spPr>
+          <p:txBody>
+            <a:bodyPr/>
+            <a:lstStyle/>
+            <a:p>
+              <a:endParaRPr lang="en-US"/>
+            </a:p>
+          </p:txBody>
         </p:sp>
         <p:sp>
           <p:nvSpPr>
@@ -4863,6 +5266,13 @@
               <a:prstDash val="solid"/>
             </a:ln>
           </p:spPr>
+          <p:txBody>
+            <a:bodyPr/>
+            <a:lstStyle/>
+            <a:p>
+              <a:endParaRPr lang="en-US"/>
+            </a:p>
+          </p:txBody>
         </p:sp>
         <p:sp>
           <p:nvSpPr>
@@ -4928,6 +5338,13 @@
               <a:prstDash val="solid"/>
             </a:ln>
           </p:spPr>
+          <p:txBody>
+            <a:bodyPr/>
+            <a:lstStyle/>
+            <a:p>
+              <a:endParaRPr lang="en-US"/>
+            </a:p>
+          </p:txBody>
         </p:sp>
         <p:sp>
           <p:nvSpPr>
@@ -4993,6 +5410,13 @@
               <a:prstDash val="solid"/>
             </a:ln>
           </p:spPr>
+          <p:txBody>
+            <a:bodyPr/>
+            <a:lstStyle/>
+            <a:p>
+              <a:endParaRPr lang="en-US"/>
+            </a:p>
+          </p:txBody>
         </p:sp>
         <p:sp>
           <p:nvSpPr>
@@ -5037,7 +5461,7 @@
       </p:grpSp>
       <p:grpSp>
         <p:nvGrpSpPr>
-          <p:cNvPr id="1166411386" name=""/>
+          <p:cNvPr id="1166411386" name="Group 1166411385"/>
           <p:cNvGrpSpPr/>
           <p:nvPr/>
         </p:nvGrpSpPr>
@@ -5073,13 +5497,20 @@
               <a:prstDash val="solid"/>
             </a:ln>
             <a:effectLst>
-              <a:outerShdw blurRad="76200" dist="25400" dir="8100000" sx="100000" sy="100000" kx="0" ky="0" algn="bl" rotWithShape="0">
+              <a:outerShdw blurRad="76200" dist="25400" dir="8100000" algn="bl" rotWithShape="0">
                 <a:srgbClr val="000000">
                   <a:alpha val="9000"/>
                 </a:srgbClr>
               </a:outerShdw>
             </a:effectLst>
           </p:spPr>
+          <p:txBody>
+            <a:bodyPr/>
+            <a:lstStyle/>
+            <a:p>
+              <a:endParaRPr lang="en-US"/>
+            </a:p>
+          </p:txBody>
         </p:sp>
         <p:sp>
           <p:nvSpPr>
@@ -5105,6 +5536,13 @@
               <a:prstDash val="solid"/>
             </a:ln>
           </p:spPr>
+          <p:txBody>
+            <a:bodyPr/>
+            <a:lstStyle/>
+            <a:p>
+              <a:endParaRPr lang="en-US"/>
+            </a:p>
+          </p:txBody>
         </p:sp>
         <p:sp>
           <p:nvSpPr>
@@ -5170,6 +5608,13 @@
               <a:prstDash val="solid"/>
             </a:ln>
           </p:spPr>
+          <p:txBody>
+            <a:bodyPr/>
+            <a:lstStyle/>
+            <a:p>
+              <a:endParaRPr lang="en-US"/>
+            </a:p>
+          </p:txBody>
         </p:sp>
         <p:sp>
           <p:nvSpPr>
@@ -5235,6 +5680,13 @@
               <a:prstDash val="solid"/>
             </a:ln>
           </p:spPr>
+          <p:txBody>
+            <a:bodyPr/>
+            <a:lstStyle/>
+            <a:p>
+              <a:endParaRPr lang="en-US"/>
+            </a:p>
+          </p:txBody>
         </p:sp>
         <p:sp>
           <p:nvSpPr>
@@ -5300,6 +5752,13 @@
               <a:prstDash val="solid"/>
             </a:ln>
           </p:spPr>
+          <p:txBody>
+            <a:bodyPr/>
+            <a:lstStyle/>
+            <a:p>
+              <a:endParaRPr lang="en-US"/>
+            </a:p>
+          </p:txBody>
         </p:sp>
         <p:sp>
           <p:nvSpPr>
@@ -5373,7 +5832,7 @@
       </p:sp>
       <p:grpSp>
         <p:nvGrpSpPr>
-          <p:cNvPr id="1663097440" name=""/>
+          <p:cNvPr id="1663097440" name="Group 1663097439"/>
           <p:cNvGrpSpPr/>
           <p:nvPr/>
         </p:nvGrpSpPr>
@@ -5409,6 +5868,13 @@
               <a:prstDash val="solid"/>
             </a:ln>
           </p:spPr>
+          <p:txBody>
+            <a:bodyPr/>
+            <a:lstStyle/>
+            <a:p>
+              <a:endParaRPr lang="en-US"/>
+            </a:p>
+          </p:txBody>
         </p:sp>
         <p:sp>
           <p:nvSpPr>
@@ -5453,7 +5919,7 @@
       </p:grpSp>
       <p:grpSp>
         <p:nvGrpSpPr>
-          <p:cNvPr id="630773313" name=""/>
+          <p:cNvPr id="630773313" name="Group 630773312"/>
           <p:cNvGrpSpPr/>
           <p:nvPr/>
         </p:nvGrpSpPr>
@@ -5489,6 +5955,13 @@
               <a:prstDash val="solid"/>
             </a:ln>
           </p:spPr>
+          <p:txBody>
+            <a:bodyPr/>
+            <a:lstStyle/>
+            <a:p>
+              <a:endParaRPr lang="en-US"/>
+            </a:p>
+          </p:txBody>
         </p:sp>
         <p:sp>
           <p:nvSpPr>
@@ -5533,7 +6006,7 @@
       </p:grpSp>
       <p:grpSp>
         <p:nvGrpSpPr>
-          <p:cNvPr id="2125615672" name=""/>
+          <p:cNvPr id="2125615672" name="Group 2125615671"/>
           <p:cNvGrpSpPr/>
           <p:nvPr/>
         </p:nvGrpSpPr>
@@ -5569,6 +6042,13 @@
               <a:prstDash val="solid"/>
             </a:ln>
           </p:spPr>
+          <p:txBody>
+            <a:bodyPr/>
+            <a:lstStyle/>
+            <a:p>
+              <a:endParaRPr lang="en-US"/>
+            </a:p>
+          </p:txBody>
         </p:sp>
         <p:sp>
           <p:nvSpPr>
@@ -5613,7 +6093,7 @@
       </p:grpSp>
       <p:grpSp>
         <p:nvGrpSpPr>
-          <p:cNvPr id="21980623" name=""/>
+          <p:cNvPr id="21980623" name="Group 21980622"/>
           <p:cNvGrpSpPr/>
           <p:nvPr/>
         </p:nvGrpSpPr>
@@ -5649,6 +6129,13 @@
               <a:prstDash val="solid"/>
             </a:ln>
           </p:spPr>
+          <p:txBody>
+            <a:bodyPr/>
+            <a:lstStyle/>
+            <a:p>
+              <a:endParaRPr lang="en-US"/>
+            </a:p>
+          </p:txBody>
         </p:sp>
         <p:sp>
           <p:nvSpPr>
@@ -5693,7 +6180,7 @@
       </p:grpSp>
       <p:grpSp>
         <p:nvGrpSpPr>
-          <p:cNvPr id="1611543351" name=""/>
+          <p:cNvPr id="1611543351" name="Group 1611543350"/>
           <p:cNvGrpSpPr/>
           <p:nvPr/>
         </p:nvGrpSpPr>
@@ -5729,6 +6216,13 @@
               <a:prstDash val="solid"/>
             </a:ln>
           </p:spPr>
+          <p:txBody>
+            <a:bodyPr/>
+            <a:lstStyle/>
+            <a:p>
+              <a:endParaRPr lang="en-US"/>
+            </a:p>
+          </p:txBody>
         </p:sp>
         <p:sp>
           <p:nvSpPr>
@@ -5773,7 +6267,7 @@
       </p:grpSp>
       <p:grpSp>
         <p:nvGrpSpPr>
-          <p:cNvPr id="818181742" name=""/>
+          <p:cNvPr id="818181742" name="Group 818181741"/>
           <p:cNvGrpSpPr/>
           <p:nvPr/>
         </p:nvGrpSpPr>
@@ -5809,6 +6303,13 @@
               <a:prstDash val="solid"/>
             </a:ln>
           </p:spPr>
+          <p:txBody>
+            <a:bodyPr/>
+            <a:lstStyle/>
+            <a:p>
+              <a:endParaRPr lang="en-US"/>
+            </a:p>
+          </p:txBody>
         </p:sp>
         <p:sp>
           <p:nvSpPr>
@@ -5853,7 +6354,7 @@
       </p:grpSp>
       <p:grpSp>
         <p:nvGrpSpPr>
-          <p:cNvPr id="1883486366" name=""/>
+          <p:cNvPr id="1883486366" name="Group 1883486365"/>
           <p:cNvGrpSpPr/>
           <p:nvPr/>
         </p:nvGrpSpPr>
@@ -5889,6 +6390,13 @@
               <a:prstDash val="solid"/>
             </a:ln>
           </p:spPr>
+          <p:txBody>
+            <a:bodyPr/>
+            <a:lstStyle/>
+            <a:p>
+              <a:endParaRPr lang="en-US"/>
+            </a:p>
+          </p:txBody>
         </p:sp>
         <p:sp>
           <p:nvSpPr>
@@ -5933,7 +6441,7 @@
       </p:grpSp>
       <p:grpSp>
         <p:nvGrpSpPr>
-          <p:cNvPr id="1089236089" name=""/>
+          <p:cNvPr id="1089236089" name="Group 1089236088"/>
           <p:cNvGrpSpPr/>
           <p:nvPr/>
         </p:nvGrpSpPr>
@@ -6009,11 +6517,18 @@
               <a:prstDash val="solid"/>
             </a:ln>
           </p:spPr>
+          <p:txBody>
+            <a:bodyPr/>
+            <a:lstStyle/>
+            <a:p>
+              <a:endParaRPr lang="en-US"/>
+            </a:p>
+          </p:txBody>
         </p:sp>
       </p:grpSp>
       <p:grpSp>
         <p:nvGrpSpPr>
-          <p:cNvPr id="459840996" name=""/>
+          <p:cNvPr id="459840996" name="Group 459840995"/>
           <p:cNvGrpSpPr/>
           <p:nvPr/>
         </p:nvGrpSpPr>
@@ -6089,11 +6604,18 @@
               <a:prstDash val="solid"/>
             </a:ln>
           </p:spPr>
+          <p:txBody>
+            <a:bodyPr/>
+            <a:lstStyle/>
+            <a:p>
+              <a:endParaRPr lang="en-US"/>
+            </a:p>
+          </p:txBody>
         </p:sp>
       </p:grpSp>
       <p:grpSp>
         <p:nvGrpSpPr>
-          <p:cNvPr id="1091002730" name=""/>
+          <p:cNvPr id="1091002730" name="Group 1091002729"/>
           <p:cNvGrpSpPr/>
           <p:nvPr/>
         </p:nvGrpSpPr>
@@ -6169,6 +6691,13 @@
               <a:prstDash val="solid"/>
             </a:ln>
           </p:spPr>
+          <p:txBody>
+            <a:bodyPr/>
+            <a:lstStyle/>
+            <a:p>
+              <a:endParaRPr lang="en-US"/>
+            </a:p>
+          </p:txBody>
         </p:sp>
       </p:grpSp>
       <p:sp>
@@ -6178,7 +6707,7 @@
           <p:nvPr/>
         </p:nvSpPr>
         <p:spPr bwMode="auto">
-          <a:xfrm flipH="0" flipV="0">
+          <a:xfrm>
             <a:off x="5057276" y="4285668"/>
             <a:ext cx="1654419" cy="150874"/>
           </a:xfrm>
@@ -6193,6 +6722,13 @@
             <a:prstDash val="solid"/>
           </a:ln>
         </p:spPr>
+        <p:txBody>
+          <a:bodyPr/>
+          <a:lstStyle/>
+          <a:p>
+            <a:endParaRPr lang="en-US"/>
+          </a:p>
+        </p:txBody>
       </p:sp>
       <p:sp>
         <p:nvSpPr>
@@ -6201,7 +6737,7 @@
           <p:nvPr/>
         </p:nvSpPr>
         <p:spPr bwMode="auto">
-          <a:xfrm flipH="0" flipV="1">
+          <a:xfrm flipV="1">
             <a:off x="4915111" y="1804891"/>
             <a:ext cx="1796977" cy="2124274"/>
           </a:xfrm>
@@ -6216,6 +6752,13 @@
             <a:prstDash val="solid"/>
           </a:ln>
         </p:spPr>
+        <p:txBody>
+          <a:bodyPr/>
+          <a:lstStyle/>
+          <a:p>
+            <a:endParaRPr lang="en-US"/>
+          </a:p>
+        </p:txBody>
       </p:sp>
       <p:sp>
         <p:nvSpPr>
@@ -6224,7 +6767,7 @@
           <p:nvPr/>
         </p:nvSpPr>
         <p:spPr bwMode="auto">
-          <a:xfrm flipH="0" flipV="0">
+          <a:xfrm>
             <a:off x="2395728" y="2879168"/>
             <a:ext cx="2036025" cy="1150468"/>
           </a:xfrm>
@@ -6239,6 +6782,13 @@
             <a:prstDash val="solid"/>
           </a:ln>
         </p:spPr>
+        <p:txBody>
+          <a:bodyPr/>
+          <a:lstStyle/>
+          <a:p>
+            <a:endParaRPr lang="en-US"/>
+          </a:p>
+        </p:txBody>
       </p:sp>
       <p:sp>
         <p:nvSpPr>
@@ -6247,7 +6797,7 @@
           <p:nvPr/>
         </p:nvSpPr>
         <p:spPr bwMode="auto">
-          <a:xfrm flipH="1" flipV="0">
+          <a:xfrm flipH="1">
             <a:off x="5057276" y="3139006"/>
             <a:ext cx="1654813" cy="890629"/>
           </a:xfrm>
@@ -6262,6 +6812,13 @@
             <a:prstDash val="solid"/>
           </a:ln>
         </p:spPr>
+        <p:txBody>
+          <a:bodyPr/>
+          <a:lstStyle/>
+          <a:p>
+            <a:endParaRPr lang="en-US"/>
+          </a:p>
+        </p:txBody>
       </p:sp>
       <p:sp>
         <p:nvSpPr>
@@ -6270,7 +6827,7 @@
           <p:nvPr/>
         </p:nvSpPr>
         <p:spPr bwMode="auto">
-          <a:xfrm flipH="0" flipV="0">
+          <a:xfrm>
             <a:off x="4722875" y="2422112"/>
             <a:ext cx="0" cy="1433787"/>
           </a:xfrm>
@@ -6285,17 +6842,24 @@
             <a:prstDash val="solid"/>
           </a:ln>
         </p:spPr>
+        <p:txBody>
+          <a:bodyPr/>
+          <a:lstStyle/>
+          <a:p>
+            <a:endParaRPr lang="en-US"/>
+          </a:p>
+        </p:txBody>
       </p:sp>
     </p:spTree>
   </p:cSld>
   <p:clrMapOvr>
     <a:masterClrMapping/>
   </p:clrMapOvr>
-  <mc:AlternateContent xmlns:mc="http://schemas.openxmlformats.org/markup-compatibility/2006">
-    <mc:Choice xmlns:p159="http://schemas.microsoft.com/office/powerpoint/2015/09/main" xmlns:p14="http://schemas.microsoft.com/office/powerpoint/2010/main" Requires="p159">
-      <p:transition p14:dur="500" advClick="1"/>
+  <mc:AlternateContent xmlns:mc="http://schemas.openxmlformats.org/markup-compatibility/2006" xmlns:p159="http://schemas.microsoft.com/office/powerpoint/2015/09/main">
+    <mc:Choice Requires="p159">
+      <p:transition/>
     </mc:Choice>
-    <mc:Fallback>
+    <mc:Fallback xmlns:w="http://schemas.openxmlformats.org/wordprocessingml/2006/main" xmlns:m="http://schemas.openxmlformats.org/officeDocument/2006/math" xmlns="">
       <p:transition advClick="1"/>
     </mc:Fallback>
   </mc:AlternateContent>
@@ -6303,15 +6867,16 @@
 </file>
 
 <file path=ppt/slides/slide6.xml><?xml version="1.0" encoding="utf-8"?>
-<p:sld xmlns:a="http://schemas.openxmlformats.org/drawingml/2006/main" xmlns:r="http://schemas.openxmlformats.org/officeDocument/2006/relationships" xmlns:p="http://schemas.openxmlformats.org/presentationml/2006/main" xmlns:m="http://schemas.openxmlformats.org/officeDocument/2006/math" xmlns:w="http://schemas.openxmlformats.org/wordprocessingml/2006/main" xmlns:mc="http://schemas.openxmlformats.org/markup-compatibility/2006" showMasterPhAnim="0" showMasterSp="1" show="1">
+<p:sld xmlns:a="http://schemas.openxmlformats.org/drawingml/2006/main" xmlns:r="http://schemas.openxmlformats.org/officeDocument/2006/relationships" xmlns:p="http://schemas.openxmlformats.org/presentationml/2006/main" showMasterPhAnim="0">
   <p:cSld name="Slide 4">
     <p:bg>
-      <p:bgPr shadeToTitle="0">
+      <p:bgPr>
         <a:solidFill>
           <a:schemeClr val="bg1">
             <a:lumMod val="95000"/>
           </a:schemeClr>
         </a:solidFill>
+        <a:effectLst/>
       </p:bgPr>
     </p:bg>
     <p:spTree>
@@ -6352,6 +6917,13 @@
             <a:prstDash val="solid"/>
           </a:ln>
         </p:spPr>
+        <p:txBody>
+          <a:bodyPr/>
+          <a:lstStyle/>
+          <a:p>
+            <a:endParaRPr lang="en-US"/>
+          </a:p>
+        </p:txBody>
       </p:sp>
       <p:sp>
         <p:nvSpPr>
@@ -6417,6 +6989,13 @@
             <a:prstDash val="solid"/>
           </a:ln>
         </p:spPr>
+        <p:txBody>
+          <a:bodyPr/>
+          <a:lstStyle/>
+          <a:p>
+            <a:endParaRPr lang="en-US"/>
+          </a:p>
+        </p:txBody>
       </p:sp>
       <p:sp>
         <p:nvSpPr>
@@ -6465,7 +7044,7 @@
           <p:nvPr/>
         </p:nvSpPr>
         <p:spPr bwMode="auto">
-          <a:xfrm flipH="0" flipV="1">
+          <a:xfrm flipV="1">
             <a:off x="4867723" y="2699034"/>
             <a:ext cx="2313068" cy="1066151"/>
           </a:xfrm>
@@ -6480,10 +7059,17 @@
             <a:prstDash val="solid"/>
           </a:ln>
         </p:spPr>
+        <p:txBody>
+          <a:bodyPr/>
+          <a:lstStyle/>
+          <a:p>
+            <a:endParaRPr lang="en-US"/>
+          </a:p>
+        </p:txBody>
       </p:sp>
       <p:grpSp>
         <p:nvGrpSpPr>
-          <p:cNvPr id="564140426" name=""/>
+          <p:cNvPr id="564140426" name="Group 564140425"/>
           <p:cNvGrpSpPr/>
           <p:nvPr/>
         </p:nvGrpSpPr>
@@ -6519,6 +7105,13 @@
               <a:prstDash val="solid"/>
             </a:ln>
           </p:spPr>
+          <p:txBody>
+            <a:bodyPr/>
+            <a:lstStyle/>
+            <a:p>
+              <a:endParaRPr lang="en-US"/>
+            </a:p>
+          </p:txBody>
         </p:sp>
         <p:pic>
           <p:nvPicPr>
@@ -6585,7 +7178,7 @@
       </p:grpSp>
       <p:grpSp>
         <p:nvGrpSpPr>
-          <p:cNvPr id="1658739631" name=""/>
+          <p:cNvPr id="1658739631" name="Group 1658739630"/>
           <p:cNvGrpSpPr/>
           <p:nvPr/>
         </p:nvGrpSpPr>
@@ -6621,13 +7214,20 @@
               <a:prstDash val="solid"/>
             </a:ln>
             <a:effectLst>
-              <a:outerShdw blurRad="76200" dist="25400" dir="8100000" sx="100000" sy="100000" kx="0" ky="0" algn="bl" rotWithShape="0">
+              <a:outerShdw blurRad="76200" dist="25400" dir="8100000" algn="bl" rotWithShape="0">
                 <a:srgbClr val="000000">
                   <a:alpha val="9000"/>
                 </a:srgbClr>
               </a:outerShdw>
             </a:effectLst>
           </p:spPr>
+          <p:txBody>
+            <a:bodyPr/>
+            <a:lstStyle/>
+            <a:p>
+              <a:endParaRPr lang="en-US"/>
+            </a:p>
+          </p:txBody>
         </p:sp>
         <p:sp>
           <p:nvSpPr>
@@ -6653,6 +7253,13 @@
               <a:prstDash val="solid"/>
             </a:ln>
           </p:spPr>
+          <p:txBody>
+            <a:bodyPr/>
+            <a:lstStyle/>
+            <a:p>
+              <a:endParaRPr lang="en-US"/>
+            </a:p>
+          </p:txBody>
         </p:sp>
         <p:sp>
           <p:nvSpPr>
@@ -6729,6 +7336,13 @@
               <a:prstDash val="solid"/>
             </a:ln>
           </p:spPr>
+          <p:txBody>
+            <a:bodyPr/>
+            <a:lstStyle/>
+            <a:p>
+              <a:endParaRPr lang="en-US"/>
+            </a:p>
+          </p:txBody>
         </p:sp>
         <p:sp>
           <p:nvSpPr>
@@ -6794,6 +7408,13 @@
               <a:prstDash val="solid"/>
             </a:ln>
           </p:spPr>
+          <p:txBody>
+            <a:bodyPr/>
+            <a:lstStyle/>
+            <a:p>
+              <a:endParaRPr lang="en-US"/>
+            </a:p>
+          </p:txBody>
         </p:sp>
         <p:sp>
           <p:nvSpPr>
@@ -6843,7 +7464,7 @@
           <p:nvPr/>
         </p:nvSpPr>
         <p:spPr bwMode="auto">
-          <a:xfrm flipH="0" flipV="0">
+          <a:xfrm>
             <a:off x="1868059" y="2699034"/>
             <a:ext cx="2416790" cy="1066151"/>
           </a:xfrm>
@@ -6858,10 +7479,17 @@
             <a:prstDash val="solid"/>
           </a:ln>
         </p:spPr>
+        <p:txBody>
+          <a:bodyPr/>
+          <a:lstStyle/>
+          <a:p>
+            <a:endParaRPr lang="en-US"/>
+          </a:p>
+        </p:txBody>
       </p:sp>
       <p:grpSp>
         <p:nvGrpSpPr>
-          <p:cNvPr id="1022503775" name=""/>
+          <p:cNvPr id="1022503775" name="Group 1022503774"/>
           <p:cNvGrpSpPr/>
           <p:nvPr/>
         </p:nvGrpSpPr>
@@ -6897,13 +7525,20 @@
               <a:prstDash val="solid"/>
             </a:ln>
             <a:effectLst>
-              <a:outerShdw blurRad="76200" dist="25400" dir="8100000" sx="100000" sy="100000" kx="0" ky="0" algn="bl" rotWithShape="0">
+              <a:outerShdw blurRad="76200" dist="25400" dir="8100000" algn="bl" rotWithShape="0">
                 <a:srgbClr val="000000">
                   <a:alpha val="9000"/>
                 </a:srgbClr>
               </a:outerShdw>
             </a:effectLst>
           </p:spPr>
+          <p:txBody>
+            <a:bodyPr/>
+            <a:lstStyle/>
+            <a:p>
+              <a:endParaRPr lang="en-US"/>
+            </a:p>
+          </p:txBody>
         </p:sp>
         <p:sp>
           <p:nvSpPr>
@@ -6929,6 +7564,13 @@
               <a:prstDash val="solid"/>
             </a:ln>
           </p:spPr>
+          <p:txBody>
+            <a:bodyPr/>
+            <a:lstStyle/>
+            <a:p>
+              <a:endParaRPr lang="en-US"/>
+            </a:p>
+          </p:txBody>
         </p:sp>
         <p:sp>
           <p:nvSpPr>
@@ -6994,6 +7636,13 @@
               <a:prstDash val="solid"/>
             </a:ln>
           </p:spPr>
+          <p:txBody>
+            <a:bodyPr/>
+            <a:lstStyle/>
+            <a:p>
+              <a:endParaRPr lang="en-US"/>
+            </a:p>
+          </p:txBody>
         </p:sp>
         <p:sp>
           <p:nvSpPr>
@@ -7059,6 +7708,13 @@
               <a:prstDash val="solid"/>
             </a:ln>
           </p:spPr>
+          <p:txBody>
+            <a:bodyPr/>
+            <a:lstStyle/>
+            <a:p>
+              <a:endParaRPr lang="en-US"/>
+            </a:p>
+          </p:txBody>
         </p:sp>
         <p:sp>
           <p:nvSpPr>
@@ -7106,11 +7762,11 @@
   <p:clrMapOvr>
     <a:masterClrMapping/>
   </p:clrMapOvr>
-  <mc:AlternateContent xmlns:mc="http://schemas.openxmlformats.org/markup-compatibility/2006">
-    <mc:Choice xmlns:p159="http://schemas.microsoft.com/office/powerpoint/2015/09/main" xmlns:p14="http://schemas.microsoft.com/office/powerpoint/2010/main" Requires="p159">
-      <p:transition p14:dur="500" advClick="1"/>
+  <mc:AlternateContent xmlns:mc="http://schemas.openxmlformats.org/markup-compatibility/2006" xmlns:p159="http://schemas.microsoft.com/office/powerpoint/2015/09/main">
+    <mc:Choice Requires="p159">
+      <p:transition/>
     </mc:Choice>
-    <mc:Fallback>
+    <mc:Fallback xmlns:w="http://schemas.openxmlformats.org/wordprocessingml/2006/main" xmlns:m="http://schemas.openxmlformats.org/officeDocument/2006/math" xmlns="">
       <p:transition advClick="1"/>
     </mc:Fallback>
   </mc:AlternateContent>
@@ -7118,15 +7774,16 @@
 </file>
 
 <file path=ppt/slides/slide7.xml><?xml version="1.0" encoding="utf-8"?>
-<p:sld xmlns:a="http://schemas.openxmlformats.org/drawingml/2006/main" xmlns:r="http://schemas.openxmlformats.org/officeDocument/2006/relationships" xmlns:p="http://schemas.openxmlformats.org/presentationml/2006/main" xmlns:m="http://schemas.openxmlformats.org/officeDocument/2006/math" xmlns:w="http://schemas.openxmlformats.org/wordprocessingml/2006/main" xmlns:mc="http://schemas.openxmlformats.org/markup-compatibility/2006" showMasterPhAnim="0" showMasterSp="1" show="1">
+<p:sld xmlns:a="http://schemas.openxmlformats.org/drawingml/2006/main" xmlns:r="http://schemas.openxmlformats.org/officeDocument/2006/relationships" xmlns:p="http://schemas.openxmlformats.org/presentationml/2006/main" showMasterPhAnim="0">
   <p:cSld name="Slide 5">
     <p:bg>
-      <p:bgPr shadeToTitle="0">
+      <p:bgPr>
         <a:solidFill>
           <a:schemeClr val="bg1">
             <a:lumMod val="95000"/>
           </a:schemeClr>
         </a:solidFill>
+        <a:effectLst/>
       </p:bgPr>
     </p:bg>
     <p:spTree>
@@ -7167,6 +7824,13 @@
             <a:prstDash val="solid"/>
           </a:ln>
         </p:spPr>
+        <p:txBody>
+          <a:bodyPr/>
+          <a:lstStyle/>
+          <a:p>
+            <a:endParaRPr lang="en-US"/>
+          </a:p>
+        </p:txBody>
       </p:sp>
       <p:sp>
         <p:nvSpPr>
@@ -7232,6 +7896,13 @@
             <a:prstDash val="solid"/>
           </a:ln>
         </p:spPr>
+        <p:txBody>
+          <a:bodyPr/>
+          <a:lstStyle/>
+          <a:p>
+            <a:endParaRPr lang="en-US"/>
+          </a:p>
+        </p:txBody>
       </p:sp>
       <p:sp>
         <p:nvSpPr>
@@ -7275,7 +7946,7 @@
       </p:sp>
       <p:grpSp>
         <p:nvGrpSpPr>
-          <p:cNvPr id="707970611" name=""/>
+          <p:cNvPr id="707970611" name="Group 707970610"/>
           <p:cNvGrpSpPr/>
           <p:nvPr/>
         </p:nvGrpSpPr>
@@ -7311,6 +7982,13 @@
               <a:prstDash val="solid"/>
             </a:ln>
           </p:spPr>
+          <p:txBody>
+            <a:bodyPr/>
+            <a:lstStyle/>
+            <a:p>
+              <a:endParaRPr lang="en-US"/>
+            </a:p>
+          </p:txBody>
         </p:sp>
         <p:pic>
           <p:nvPicPr>
@@ -7382,7 +8060,7 @@
           <p:nvPr/>
         </p:nvSpPr>
         <p:spPr bwMode="auto">
-          <a:xfrm flipH="0" flipV="0">
+          <a:xfrm>
             <a:off x="2370372" y="2419365"/>
             <a:ext cx="1914475" cy="1222610"/>
           </a:xfrm>
@@ -7397,10 +8075,17 @@
             <a:prstDash val="solid"/>
           </a:ln>
         </p:spPr>
+        <p:txBody>
+          <a:bodyPr/>
+          <a:lstStyle/>
+          <a:p>
+            <a:endParaRPr lang="en-US"/>
+          </a:p>
+        </p:txBody>
       </p:sp>
       <p:grpSp>
         <p:nvGrpSpPr>
-          <p:cNvPr id="1395350226" name=""/>
+          <p:cNvPr id="1395350226" name="Group 1395350225"/>
           <p:cNvGrpSpPr/>
           <p:nvPr/>
         </p:nvGrpSpPr>
@@ -7419,7 +8104,7 @@
             <p:nvPr/>
           </p:nvSpPr>
           <p:spPr bwMode="auto">
-            <a:xfrm flipH="0" flipV="0">
+            <a:xfrm>
               <a:off x="0" y="0"/>
               <a:ext cx="2194560" cy="733042"/>
             </a:xfrm>
@@ -7436,13 +8121,20 @@
               <a:prstDash val="solid"/>
             </a:ln>
             <a:effectLst>
-              <a:outerShdw blurRad="76200" dist="25400" dir="8100000" sx="100000" sy="100000" kx="0" ky="0" algn="bl" rotWithShape="0">
+              <a:outerShdw blurRad="76200" dist="25400" dir="8100000" algn="bl" rotWithShape="0">
                 <a:srgbClr val="000000">
                   <a:alpha val="9000"/>
                 </a:srgbClr>
               </a:outerShdw>
             </a:effectLst>
           </p:spPr>
+          <p:txBody>
+            <a:bodyPr/>
+            <a:lstStyle/>
+            <a:p>
+              <a:endParaRPr lang="en-US"/>
+            </a:p>
+          </p:txBody>
         </p:sp>
         <p:sp>
           <p:nvSpPr>
@@ -7468,6 +8160,13 @@
               <a:prstDash val="solid"/>
             </a:ln>
           </p:spPr>
+          <p:txBody>
+            <a:bodyPr/>
+            <a:lstStyle/>
+            <a:p>
+              <a:endParaRPr lang="en-US"/>
+            </a:p>
+          </p:txBody>
         </p:sp>
         <p:sp>
           <p:nvSpPr>
@@ -7533,6 +8232,13 @@
               <a:prstDash val="solid"/>
             </a:ln>
           </p:spPr>
+          <p:txBody>
+            <a:bodyPr/>
+            <a:lstStyle/>
+            <a:p>
+              <a:endParaRPr lang="en-US"/>
+            </a:p>
+          </p:txBody>
         </p:sp>
         <p:sp>
           <p:nvSpPr>
@@ -7582,7 +8288,7 @@
           <p:nvPr/>
         </p:nvSpPr>
         <p:spPr bwMode="auto">
-          <a:xfrm flipH="1" flipV="0">
+          <a:xfrm flipH="1">
             <a:off x="4872462" y="2181402"/>
             <a:ext cx="1955040" cy="1460574"/>
           </a:xfrm>
@@ -7597,10 +8303,17 @@
             <a:prstDash val="solid"/>
           </a:ln>
         </p:spPr>
+        <p:txBody>
+          <a:bodyPr/>
+          <a:lstStyle/>
+          <a:p>
+            <a:endParaRPr lang="en-US"/>
+          </a:p>
+        </p:txBody>
       </p:sp>
       <p:grpSp>
         <p:nvGrpSpPr>
-          <p:cNvPr id="1907407505" name=""/>
+          <p:cNvPr id="1907407505" name="Group 1907407504"/>
           <p:cNvGrpSpPr/>
           <p:nvPr/>
         </p:nvGrpSpPr>
@@ -7636,13 +8349,20 @@
               <a:prstDash val="solid"/>
             </a:ln>
             <a:effectLst>
-              <a:outerShdw blurRad="76200" dist="25400" dir="8100000" sx="100000" sy="100000" kx="0" ky="0" algn="bl" rotWithShape="0">
+              <a:outerShdw blurRad="76200" dist="25400" dir="8100000" algn="bl" rotWithShape="0">
                 <a:srgbClr val="000000">
                   <a:alpha val="9000"/>
                 </a:srgbClr>
               </a:outerShdw>
             </a:effectLst>
           </p:spPr>
+          <p:txBody>
+            <a:bodyPr/>
+            <a:lstStyle/>
+            <a:p>
+              <a:endParaRPr lang="en-US"/>
+            </a:p>
+          </p:txBody>
         </p:sp>
         <p:sp>
           <p:nvSpPr>
@@ -7668,6 +8388,13 @@
               <a:prstDash val="solid"/>
             </a:ln>
           </p:spPr>
+          <p:txBody>
+            <a:bodyPr/>
+            <a:lstStyle/>
+            <a:p>
+              <a:endParaRPr lang="en-US"/>
+            </a:p>
+          </p:txBody>
         </p:sp>
         <p:sp>
           <p:nvSpPr>
@@ -7733,6 +8460,13 @@
               <a:prstDash val="solid"/>
             </a:ln>
           </p:spPr>
+          <p:txBody>
+            <a:bodyPr/>
+            <a:lstStyle/>
+            <a:p>
+              <a:endParaRPr lang="en-US"/>
+            </a:p>
+          </p:txBody>
         </p:sp>
         <p:sp>
           <p:nvSpPr>
@@ -7809,6 +8543,13 @@
               <a:prstDash val="solid"/>
             </a:ln>
           </p:spPr>
+          <p:txBody>
+            <a:bodyPr/>
+            <a:lstStyle/>
+            <a:p>
+              <a:endParaRPr lang="en-US"/>
+            </a:p>
+          </p:txBody>
         </p:sp>
         <p:sp>
           <p:nvSpPr>
@@ -7867,11 +8608,11 @@
   <p:clrMapOvr>
     <a:masterClrMapping/>
   </p:clrMapOvr>
-  <mc:AlternateContent xmlns:mc="http://schemas.openxmlformats.org/markup-compatibility/2006">
-    <mc:Choice xmlns:p159="http://schemas.microsoft.com/office/powerpoint/2015/09/main" xmlns:p14="http://schemas.microsoft.com/office/powerpoint/2010/main" Requires="p159">
-      <p:transition p14:dur="500" advClick="1"/>
+  <mc:AlternateContent xmlns:mc="http://schemas.openxmlformats.org/markup-compatibility/2006" xmlns:p159="http://schemas.microsoft.com/office/powerpoint/2015/09/main">
+    <mc:Choice Requires="p159">
+      <p:transition/>
     </mc:Choice>
-    <mc:Fallback>
+    <mc:Fallback xmlns:w="http://schemas.openxmlformats.org/wordprocessingml/2006/main" xmlns:m="http://schemas.openxmlformats.org/officeDocument/2006/math" xmlns="">
       <p:transition advClick="1"/>
     </mc:Fallback>
   </mc:AlternateContent>
@@ -7879,7 +8620,7 @@
 </file>
 
 <file path=ppt/theme/theme1.xml><?xml version="1.0" encoding="utf-8"?>
-<a:theme xmlns:a="http://schemas.openxmlformats.org/drawingml/2006/main" xmlns:r="http://schemas.openxmlformats.org/officeDocument/2006/relationships" xmlns:p="http://schemas.openxmlformats.org/presentationml/2006/main" name="Office Theme">
+<a:theme xmlns:a="http://schemas.openxmlformats.org/drawingml/2006/main" name="Office Theme">
   <a:themeElements>
     <a:clrScheme name="Office">
       <a:dk1>
@@ -8070,5 +8811,321 @@
     </a:fmtScheme>
   </a:themeElements>
   <a:objectDefaults/>
+  <a:extraClrSchemeLst/>
+</a:theme>
+</file>
+
+<file path=ppt/theme/theme2.xml><?xml version="1.0" encoding="utf-8"?>
+<a:theme xmlns:a="http://schemas.openxmlformats.org/drawingml/2006/main" name="Office Theme">
+  <a:themeElements>
+    <a:clrScheme name="Office">
+      <a:dk1>
+        <a:sysClr val="windowText" lastClr="000000"/>
+      </a:dk1>
+      <a:lt1>
+        <a:sysClr val="window" lastClr="FFFFFF"/>
+      </a:lt1>
+      <a:dk2>
+        <a:srgbClr val="0E2841"/>
+      </a:dk2>
+      <a:lt2>
+        <a:srgbClr val="E8E8E8"/>
+      </a:lt2>
+      <a:accent1>
+        <a:srgbClr val="156082"/>
+      </a:accent1>
+      <a:accent2>
+        <a:srgbClr val="E97132"/>
+      </a:accent2>
+      <a:accent3>
+        <a:srgbClr val="196B24"/>
+      </a:accent3>
+      <a:accent4>
+        <a:srgbClr val="0F9ED5"/>
+      </a:accent4>
+      <a:accent5>
+        <a:srgbClr val="A02B93"/>
+      </a:accent5>
+      <a:accent6>
+        <a:srgbClr val="4EA72E"/>
+      </a:accent6>
+      <a:hlink>
+        <a:srgbClr val="467886"/>
+      </a:hlink>
+      <a:folHlink>
+        <a:srgbClr val="96607D"/>
+      </a:folHlink>
+    </a:clrScheme>
+    <a:fontScheme name="Office">
+      <a:majorFont>
+        <a:latin typeface="Aptos Display" panose="02110004020202020204"/>
+        <a:ea typeface=""/>
+        <a:cs typeface=""/>
+        <a:font script="Jpan" typeface="游ゴシック Light"/>
+        <a:font script="Hang" typeface="맑은 고딕"/>
+        <a:font script="Hans" typeface="等线 Light"/>
+        <a:font script="Hant" typeface="新細明體"/>
+        <a:font script="Arab" typeface="Times New Roman"/>
+        <a:font script="Hebr" typeface="Times New Roman"/>
+        <a:font script="Thai" typeface="Angsana New"/>
+        <a:font script="Ethi" typeface="Nyala"/>
+        <a:font script="Beng" typeface="Vrinda"/>
+        <a:font script="Gujr" typeface="Shruti"/>
+        <a:font script="Khmr" typeface="MoolBoran"/>
+        <a:font script="Knda" typeface="Tunga"/>
+        <a:font script="Guru" typeface="Raavi"/>
+        <a:font script="Cans" typeface="Euphemia"/>
+        <a:font script="Cher" typeface="Plantagenet Cherokee"/>
+        <a:font script="Yiii" typeface="Microsoft Yi Baiti"/>
+        <a:font script="Tibt" typeface="Microsoft Himalaya"/>
+        <a:font script="Thaa" typeface="MV Boli"/>
+        <a:font script="Deva" typeface="Mangal"/>
+        <a:font script="Telu" typeface="Gautami"/>
+        <a:font script="Taml" typeface="Latha"/>
+        <a:font script="Syrc" typeface="Estrangelo Edessa"/>
+        <a:font script="Orya" typeface="Kalinga"/>
+        <a:font script="Mlym" typeface="Kartika"/>
+        <a:font script="Laoo" typeface="DokChampa"/>
+        <a:font script="Sinh" typeface="Iskoola Pota"/>
+        <a:font script="Mong" typeface="Mongolian Baiti"/>
+        <a:font script="Viet" typeface="Times New Roman"/>
+        <a:font script="Uigh" typeface="Microsoft Uighur"/>
+        <a:font script="Geor" typeface="Sylfaen"/>
+        <a:font script="Armn" typeface="Arial"/>
+        <a:font script="Bugi" typeface="Leelawadee UI"/>
+        <a:font script="Bopo" typeface="Microsoft JhengHei"/>
+        <a:font script="Java" typeface="Javanese Text"/>
+        <a:font script="Lisu" typeface="Segoe UI"/>
+        <a:font script="Mymr" typeface="Myanmar Text"/>
+        <a:font script="Nkoo" typeface="Ebrima"/>
+        <a:font script="Olck" typeface="Nirmala UI"/>
+        <a:font script="Osma" typeface="Ebrima"/>
+        <a:font script="Phag" typeface="Phagspa"/>
+        <a:font script="Syrn" typeface="Estrangelo Edessa"/>
+        <a:font script="Syrj" typeface="Estrangelo Edessa"/>
+        <a:font script="Syre" typeface="Estrangelo Edessa"/>
+        <a:font script="Sora" typeface="Nirmala UI"/>
+        <a:font script="Tale" typeface="Microsoft Tai Le"/>
+        <a:font script="Talu" typeface="Microsoft New Tai Lue"/>
+        <a:font script="Tfng" typeface="Ebrima"/>
+      </a:majorFont>
+      <a:minorFont>
+        <a:latin typeface="Aptos" panose="02110004020202020204"/>
+        <a:ea typeface=""/>
+        <a:cs typeface=""/>
+        <a:font script="Jpan" typeface="游ゴシック"/>
+        <a:font script="Hang" typeface="맑은 고딕"/>
+        <a:font script="Hans" typeface="等线"/>
+        <a:font script="Hant" typeface="新細明體"/>
+        <a:font script="Arab" typeface="Arial"/>
+        <a:font script="Hebr" typeface="Arial"/>
+        <a:font script="Thai" typeface="Cordia New"/>
+        <a:font script="Ethi" typeface="Nyala"/>
+        <a:font script="Beng" typeface="Vrinda"/>
+        <a:font script="Gujr" typeface="Shruti"/>
+        <a:font script="Khmr" typeface="DaunPenh"/>
+        <a:font script="Knda" typeface="Tunga"/>
+        <a:font script="Guru" typeface="Raavi"/>
+        <a:font script="Cans" typeface="Euphemia"/>
+        <a:font script="Cher" typeface="Plantagenet Cherokee"/>
+        <a:font script="Yiii" typeface="Microsoft Yi Baiti"/>
+        <a:font script="Tibt" typeface="Microsoft Himalaya"/>
+        <a:font script="Thaa" typeface="MV Boli"/>
+        <a:font script="Deva" typeface="Mangal"/>
+        <a:font script="Telu" typeface="Gautami"/>
+        <a:font script="Taml" typeface="Latha"/>
+        <a:font script="Syrc" typeface="Estrangelo Edessa"/>
+        <a:font script="Orya" typeface="Kalinga"/>
+        <a:font script="Mlym" typeface="Kartika"/>
+        <a:font script="Laoo" typeface="DokChampa"/>
+        <a:font script="Sinh" typeface="Iskoola Pota"/>
+        <a:font script="Mong" typeface="Mongolian Baiti"/>
+        <a:font script="Viet" typeface="Arial"/>
+        <a:font script="Uigh" typeface="Microsoft Uighur"/>
+        <a:font script="Geor" typeface="Sylfaen"/>
+        <a:font script="Armn" typeface="Arial"/>
+        <a:font script="Bugi" typeface="Leelawadee UI"/>
+        <a:font script="Bopo" typeface="Microsoft JhengHei"/>
+        <a:font script="Java" typeface="Javanese Text"/>
+        <a:font script="Lisu" typeface="Segoe UI"/>
+        <a:font script="Mymr" typeface="Myanmar Text"/>
+        <a:font script="Nkoo" typeface="Ebrima"/>
+        <a:font script="Olck" typeface="Nirmala UI"/>
+        <a:font script="Osma" typeface="Ebrima"/>
+        <a:font script="Phag" typeface="Phagspa"/>
+        <a:font script="Syrn" typeface="Estrangelo Edessa"/>
+        <a:font script="Syrj" typeface="Estrangelo Edessa"/>
+        <a:font script="Syre" typeface="Estrangelo Edessa"/>
+        <a:font script="Sora" typeface="Nirmala UI"/>
+        <a:font script="Tale" typeface="Microsoft Tai Le"/>
+        <a:font script="Talu" typeface="Microsoft New Tai Lue"/>
+        <a:font script="Tfng" typeface="Ebrima"/>
+      </a:minorFont>
+    </a:fontScheme>
+    <a:fmtScheme name="Office">
+      <a:fillStyleLst>
+        <a:solidFill>
+          <a:schemeClr val="phClr"/>
+        </a:solidFill>
+        <a:gradFill rotWithShape="1">
+          <a:gsLst>
+            <a:gs pos="0">
+              <a:schemeClr val="phClr">
+                <a:lumMod val="110000"/>
+                <a:satMod val="105000"/>
+                <a:tint val="67000"/>
+              </a:schemeClr>
+            </a:gs>
+            <a:gs pos="50000">
+              <a:schemeClr val="phClr">
+                <a:lumMod val="105000"/>
+                <a:satMod val="103000"/>
+                <a:tint val="73000"/>
+              </a:schemeClr>
+            </a:gs>
+            <a:gs pos="100000">
+              <a:schemeClr val="phClr">
+                <a:lumMod val="105000"/>
+                <a:satMod val="109000"/>
+                <a:tint val="81000"/>
+              </a:schemeClr>
+            </a:gs>
+          </a:gsLst>
+          <a:lin ang="5400000" scaled="0"/>
+        </a:gradFill>
+        <a:gradFill rotWithShape="1">
+          <a:gsLst>
+            <a:gs pos="0">
+              <a:schemeClr val="phClr">
+                <a:satMod val="103000"/>
+                <a:lumMod val="102000"/>
+                <a:tint val="94000"/>
+              </a:schemeClr>
+            </a:gs>
+            <a:gs pos="50000">
+              <a:schemeClr val="phClr">
+                <a:satMod val="110000"/>
+                <a:lumMod val="100000"/>
+                <a:shade val="100000"/>
+              </a:schemeClr>
+            </a:gs>
+            <a:gs pos="100000">
+              <a:schemeClr val="phClr">
+                <a:lumMod val="99000"/>
+                <a:satMod val="120000"/>
+                <a:shade val="78000"/>
+              </a:schemeClr>
+            </a:gs>
+          </a:gsLst>
+          <a:lin ang="5400000" scaled="0"/>
+        </a:gradFill>
+      </a:fillStyleLst>
+      <a:lnStyleLst>
+        <a:ln w="12700" cap="flat" cmpd="sng" algn="ctr">
+          <a:solidFill>
+            <a:schemeClr val="phClr"/>
+          </a:solidFill>
+          <a:prstDash val="solid"/>
+          <a:miter lim="800000"/>
+        </a:ln>
+        <a:ln w="19050" cap="flat" cmpd="sng" algn="ctr">
+          <a:solidFill>
+            <a:schemeClr val="phClr"/>
+          </a:solidFill>
+          <a:prstDash val="solid"/>
+          <a:miter lim="800000"/>
+        </a:ln>
+        <a:ln w="25400" cap="flat" cmpd="sng" algn="ctr">
+          <a:solidFill>
+            <a:schemeClr val="phClr"/>
+          </a:solidFill>
+          <a:prstDash val="solid"/>
+          <a:miter lim="800000"/>
+        </a:ln>
+      </a:lnStyleLst>
+      <a:effectStyleLst>
+        <a:effectStyle>
+          <a:effectLst/>
+        </a:effectStyle>
+        <a:effectStyle>
+          <a:effectLst/>
+        </a:effectStyle>
+        <a:effectStyle>
+          <a:effectLst>
+            <a:outerShdw blurRad="57150" dist="19050" dir="5400000" algn="ctr" rotWithShape="0">
+              <a:srgbClr val="000000">
+                <a:alpha val="63000"/>
+              </a:srgbClr>
+            </a:outerShdw>
+          </a:effectLst>
+        </a:effectStyle>
+      </a:effectStyleLst>
+      <a:bgFillStyleLst>
+        <a:solidFill>
+          <a:schemeClr val="phClr"/>
+        </a:solidFill>
+        <a:solidFill>
+          <a:schemeClr val="phClr">
+            <a:tint val="95000"/>
+            <a:satMod val="170000"/>
+          </a:schemeClr>
+        </a:solidFill>
+        <a:gradFill rotWithShape="1">
+          <a:gsLst>
+            <a:gs pos="0">
+              <a:schemeClr val="phClr">
+                <a:tint val="93000"/>
+                <a:satMod val="150000"/>
+                <a:shade val="98000"/>
+                <a:lumMod val="102000"/>
+              </a:schemeClr>
+            </a:gs>
+            <a:gs pos="50000">
+              <a:schemeClr val="phClr">
+                <a:tint val="98000"/>
+                <a:satMod val="130000"/>
+                <a:shade val="90000"/>
+                <a:lumMod val="103000"/>
+              </a:schemeClr>
+            </a:gs>
+            <a:gs pos="100000">
+              <a:schemeClr val="phClr">
+                <a:shade val="63000"/>
+                <a:satMod val="120000"/>
+              </a:schemeClr>
+            </a:gs>
+          </a:gsLst>
+          <a:lin ang="5400000" scaled="0"/>
+        </a:gradFill>
+      </a:bgFillStyleLst>
+    </a:fmtScheme>
+  </a:themeElements>
+  <a:objectDefaults>
+    <a:lnDef>
+      <a:spPr/>
+      <a:bodyPr/>
+      <a:lstStyle/>
+      <a:style>
+        <a:lnRef idx="2">
+          <a:schemeClr val="accent1"/>
+        </a:lnRef>
+        <a:fillRef idx="0">
+          <a:schemeClr val="accent1"/>
+        </a:fillRef>
+        <a:effectRef idx="1">
+          <a:schemeClr val="accent1"/>
+        </a:effectRef>
+        <a:fontRef idx="minor">
+          <a:schemeClr val="tx1"/>
+        </a:fontRef>
+      </a:style>
+    </a:lnDef>
+  </a:objectDefaults>
+  <a:extraClrSchemeLst/>
+  <a:extLst>
+    <a:ext uri="{05A4C25C-085E-4340-85A3-A5531E510DB2}">
+      <thm15:themeFamily xmlns:thm15="http://schemas.microsoft.com/office/thememl/2012/main" name="Office Theme" id="{2E142A2C-CD16-42D6-873A-C26D2A0506FA}" vid="{1BDDFF52-6CD6-40A5-AB3C-68EB2F1E4D0A}"/>
+    </a:ext>
+  </a:extLst>
 </a:theme>
 </file>
</xml_diff>